<commit_message>
feat: finalize judge-facing RouteLens release
</commit_message>
<xml_diff>
--- a/presentation/RouteLens_Defense_RU.pptx
+++ b/presentation/RouteLens_Defense_RU.pptx
@@ -2,19 +2,19 @@
 <file path=ppt/presentation.xml><?xml version="1.0" encoding="utf-8"?>
 <p:presentation xmlns:p="http://schemas.openxmlformats.org/presentationml/2006/main">
   <p:sldMasterIdLst>
-    <p:sldMasterId xmlns:r="http://schemas.openxmlformats.org/officeDocument/2006/relationships" id="2147483648" r:id="Ra8b7f51f6972450e"/>
+    <p:sldMasterId xmlns:r="http://schemas.openxmlformats.org/officeDocument/2006/relationships" id="2147483648" r:id="Rbac2c8e8ec1844d1"/>
   </p:sldMasterIdLst>
   <p:notesMasterIdLst>
-    <p:notesMasterId xmlns:r="http://schemas.openxmlformats.org/officeDocument/2006/relationships" r:id="R2ae4576293494e4c"/>
+    <p:notesMasterId xmlns:r="http://schemas.openxmlformats.org/officeDocument/2006/relationships" r:id="R4dc16d2d11c1441e"/>
   </p:notesMasterIdLst>
   <p:sldIdLst>
-    <p:sldId xmlns:r="http://schemas.openxmlformats.org/officeDocument/2006/relationships" id="256" r:id="R1a335e99252046a5"/>
-    <p:sldId xmlns:r="http://schemas.openxmlformats.org/officeDocument/2006/relationships" id="257" r:id="R4f7f08b08eef4284"/>
-    <p:sldId xmlns:r="http://schemas.openxmlformats.org/officeDocument/2006/relationships" id="258" r:id="R669cd43b0eab4788"/>
-    <p:sldId xmlns:r="http://schemas.openxmlformats.org/officeDocument/2006/relationships" id="259" r:id="Rd893197b050c414f"/>
-    <p:sldId xmlns:r="http://schemas.openxmlformats.org/officeDocument/2006/relationships" id="260" r:id="Rb6e790ea6f8648e8"/>
-    <p:sldId xmlns:r="http://schemas.openxmlformats.org/officeDocument/2006/relationships" id="261" r:id="R713e130c6e9c4f04"/>
-    <p:sldId xmlns:r="http://schemas.openxmlformats.org/officeDocument/2006/relationships" id="262" r:id="R24d3eedebcdf4653"/>
+    <p:sldId xmlns:r="http://schemas.openxmlformats.org/officeDocument/2006/relationships" id="256" r:id="Rd8eca323ea594b05"/>
+    <p:sldId xmlns:r="http://schemas.openxmlformats.org/officeDocument/2006/relationships" id="257" r:id="R7d8f1d2b630a481b"/>
+    <p:sldId xmlns:r="http://schemas.openxmlformats.org/officeDocument/2006/relationships" id="258" r:id="R57cf83fe4ad54833"/>
+    <p:sldId xmlns:r="http://schemas.openxmlformats.org/officeDocument/2006/relationships" id="259" r:id="R96c9f78c69f74158"/>
+    <p:sldId xmlns:r="http://schemas.openxmlformats.org/officeDocument/2006/relationships" id="260" r:id="R970344a5f0624b6c"/>
+    <p:sldId xmlns:r="http://schemas.openxmlformats.org/officeDocument/2006/relationships" id="261" r:id="R2cc11ffd80a2441b"/>
+    <p:sldId xmlns:r="http://schemas.openxmlformats.org/officeDocument/2006/relationships" id="262" r:id="R4a03092a185e424b"/>
   </p:sldIdLst>
   <p:sldSz cx="12192000" cy="6858000"/>
   <p:notesSz cx="6858000" cy="9144000"/>
@@ -678,7 +678,12 @@
           </a:p>
           <a:p xmlns:a="http://schemas.openxmlformats.org/drawingml/2006/main">
             <a:r>
-              <a:t>Показаны суммы округлённых вкладов из score_breakdown. Итоговые scores берутся из артефакта решения.</a:t>
+              <a:t>Выбран Vipay: 3.4732. Альтернатива Quickpay: -2.746254.</a:t>
+            </a:r>
+          </a:p>
+          <a:p xmlns:a="http://schemas.openxmlformats.org/drawingml/2006/main">
+            <a:r>
+              <a:t>Показаны суммы вкладов из score_breakdown. Итоговые scores берутся из артефакта решения.</a:t>
             </a:r>
           </a:p>
         </p:txBody>
@@ -753,7 +758,12 @@
           </a:p>
           <a:p xmlns:a="http://schemas.openxmlformats.org/drawingml/2006/main">
             <a:r>
-              <a:t>op_101: Vipay rejected 5 c, Payflow expired 20 c, Quickpay approved 25 c. Итого 50 c.</a:t>
+              <a:t>op_101: Vipay expired  ·  Payflow approved. Итоговая задержка 102 c.</a:t>
+            </a:r>
+          </a:p>
+          <a:p xmlns:a="http://schemas.openxmlformats.org/drawingml/2006/main">
+            <a:r>
+              <a:t>op_102: Quickpay expired  ·  Payflow rejected  ·  SpacePayments approved.</a:t>
             </a:r>
           </a:p>
         </p:txBody>
@@ -833,7 +843,7 @@
           </a:p>
           <a:p xmlns:a="http://schemas.openxmlformats.org/drawingml/2006/main">
             <a:r>
-              <a:t>Replay рекомендации: Payflow 99,63% → 98,03%, count error 30 → 20, volume error 56,27 → 81,15.</a:t>
+              <a:t>Replay рекомендации: Payflow 99.63% до 96.69%, count error 10 до 0, volume error 51.08 до 96.7.</a:t>
             </a:r>
           </a:p>
         </p:txBody>
@@ -976,7 +986,7 @@
   </p:cSld>
   <p:clrMap bg1="lt1" tx1="dk1" bg2="lt2" tx2="dk2" accent1="accent1" accent2="accent2" accent3="accent3" accent4="accent4" accent5="accent5" accent6="accent6" hlink="hlink" folHlink="folHlink"/>
   <p:sldLayoutIdLst>
-    <p:sldLayoutId xmlns:r="http://schemas.openxmlformats.org/officeDocument/2006/relationships" id="2147483649" r:id="Rc5631189d257472f"/>
+    <p:sldLayoutId xmlns:r="http://schemas.openxmlformats.org/officeDocument/2006/relationships" id="2147483649" r:id="Rda105c8160074be9"/>
   </p:sldLayoutIdLst>
   <p:txStyles>
     <p:titleStyle>
@@ -1550,10 +1560,10 @@
                 <c:formatCode>0.0</c:formatCode>
                 <c:ptCount val="4"/>
                 <c:pt idx="0">
-                  <c:v>30</c:v>
+                  <c:v>10</c:v>
                 </c:pt>
                 <c:pt idx="1">
-                  <c:v>130</c:v>
+                  <c:v>30</c:v>
                 </c:pt>
                 <c:pt idx="2">
                   <c:v>10</c:v>
@@ -1603,10 +1613,10 @@
                 <c:formatCode>0.0</c:formatCode>
                 <c:ptCount val="4"/>
                 <c:pt idx="0">
-                  <c:v>56.27</c:v>
+                  <c:v>51.08</c:v>
                 </c:pt>
                 <c:pt idx="1">
-                  <c:v>149.58</c:v>
+                  <c:v>71.82</c:v>
                 </c:pt>
                 <c:pt idx="2">
                   <c:v>51.08</c:v>
@@ -1805,7 +1815,7 @@
           <p:cNvPr id="21" name="">
             <a:extLst xmlns:a="http://schemas.openxmlformats.org/drawingml/2006/main">
               <a:ext uri="{FF2B5EF4-FFF2-40B4-BE49-F238E27FC236}">
-                <a16:creationId xmlns:a16="http://schemas.microsoft.com/office/drawing/2014/main" id="{3EBCECE2-CA52-49E4-B49F-63EA976A8A76}"/>
+                <a16:creationId xmlns:a16="http://schemas.microsoft.com/office/drawing/2014/main" id="{63788C93-345C-4619-8B33-438F769AAD1A}"/>
               </a:ext>
             </a:extLst>
           </p:cNvPr>
@@ -1863,7 +1873,7 @@
           <p:cNvPr id="2" name="">
             <a:extLst xmlns:a="http://schemas.openxmlformats.org/drawingml/2006/main">
               <a:ext uri="{FF2B5EF4-FFF2-40B4-BE49-F238E27FC236}">
-                <a16:creationId xmlns:a16="http://schemas.microsoft.com/office/drawing/2014/main" id="{48F736A7-53F7-4296-B9E4-42EC0127EE7E}"/>
+                <a16:creationId xmlns:a16="http://schemas.microsoft.com/office/drawing/2014/main" id="{59F97067-5462-4A61-9752-BEB286C3BAD8}"/>
               </a:ext>
             </a:extLst>
           </p:cNvPr>
@@ -1921,7 +1931,7 @@
           <p:cNvPr id="3" name="">
             <a:extLst xmlns:a="http://schemas.openxmlformats.org/drawingml/2006/main">
               <a:ext uri="{FF2B5EF4-FFF2-40B4-BE49-F238E27FC236}">
-                <a16:creationId xmlns:a16="http://schemas.microsoft.com/office/drawing/2014/main" id="{F0657030-7D0F-4856-82D4-FAD79E5AA294}"/>
+                <a16:creationId xmlns:a16="http://schemas.microsoft.com/office/drawing/2014/main" id="{5BA4075D-BF5F-4A88-91F6-E9A1A9FAF916}"/>
               </a:ext>
             </a:extLst>
           </p:cNvPr>
@@ -1979,7 +1989,7 @@
           <p:cNvPr id="4" name="">
             <a:extLst xmlns:a="http://schemas.openxmlformats.org/drawingml/2006/main">
               <a:ext uri="{FF2B5EF4-FFF2-40B4-BE49-F238E27FC236}">
-                <a16:creationId xmlns:a16="http://schemas.microsoft.com/office/drawing/2014/main" id="{323D9518-1FFA-4E10-B2A0-FF42021E1039}"/>
+                <a16:creationId xmlns:a16="http://schemas.microsoft.com/office/drawing/2014/main" id="{EB75E0DA-AF72-40AF-8AC4-8E129FA25BA5}"/>
               </a:ext>
             </a:extLst>
           </p:cNvPr>
@@ -2060,7 +2070,7 @@
           <p:cNvPr id="5" name="">
             <a:extLst xmlns:a="http://schemas.openxmlformats.org/drawingml/2006/main">
               <a:ext uri="{FF2B5EF4-FFF2-40B4-BE49-F238E27FC236}">
-                <a16:creationId xmlns:a16="http://schemas.microsoft.com/office/drawing/2014/main" id="{21458F22-5F5E-4691-9993-2F8E10FEDA15}"/>
+                <a16:creationId xmlns:a16="http://schemas.microsoft.com/office/drawing/2014/main" id="{5E519051-8EE3-42C3-890E-E740168DF09F}"/>
               </a:ext>
             </a:extLst>
           </p:cNvPr>
@@ -2091,7 +2101,7 @@
           <p:cNvPr id="6" name="">
             <a:extLst xmlns:a="http://schemas.openxmlformats.org/drawingml/2006/main">
               <a:ext uri="{FF2B5EF4-FFF2-40B4-BE49-F238E27FC236}">
-                <a16:creationId xmlns:a16="http://schemas.microsoft.com/office/drawing/2014/main" id="{664BAB9F-FB2D-4EEC-9DA6-A5F9F66F12A2}"/>
+                <a16:creationId xmlns:a16="http://schemas.microsoft.com/office/drawing/2014/main" id="{017616EB-0364-44A5-B8FD-ADF684A5DD11}"/>
               </a:ext>
             </a:extLst>
           </p:cNvPr>
@@ -2124,7 +2134,7 @@
           <p:cNvPr id="7" name="">
             <a:extLst xmlns:a="http://schemas.openxmlformats.org/drawingml/2006/main">
               <a:ext uri="{FF2B5EF4-FFF2-40B4-BE49-F238E27FC236}">
-                <a16:creationId xmlns:a16="http://schemas.microsoft.com/office/drawing/2014/main" id="{FD42AD8A-C847-407D-B9DB-A4346003E120}"/>
+                <a16:creationId xmlns:a16="http://schemas.microsoft.com/office/drawing/2014/main" id="{7AC75FB0-A3F4-4669-9A1E-C6CC857DC77D}"/>
               </a:ext>
             </a:extLst>
           </p:cNvPr>
@@ -2182,7 +2192,7 @@
           <p:cNvPr id="8" name="">
             <a:extLst xmlns:a="http://schemas.openxmlformats.org/drawingml/2006/main">
               <a:ext uri="{FF2B5EF4-FFF2-40B4-BE49-F238E27FC236}">
-                <a16:creationId xmlns:a16="http://schemas.microsoft.com/office/drawing/2014/main" id="{02FDC1D0-0DA7-4DB5-8CF5-78CF31C2B988}"/>
+                <a16:creationId xmlns:a16="http://schemas.microsoft.com/office/drawing/2014/main" id="{05B47C36-CCC7-474C-AE8F-72E50A7A6C9A}"/>
               </a:ext>
             </a:extLst>
           </p:cNvPr>
@@ -2240,7 +2250,7 @@
           <p:cNvPr id="9" name="">
             <a:extLst xmlns:a="http://schemas.openxmlformats.org/drawingml/2006/main">
               <a:ext uri="{FF2B5EF4-FFF2-40B4-BE49-F238E27FC236}">
-                <a16:creationId xmlns:a16="http://schemas.microsoft.com/office/drawing/2014/main" id="{3D6FF153-8C87-4C25-AB16-84CB697D4710}"/>
+                <a16:creationId xmlns:a16="http://schemas.microsoft.com/office/drawing/2014/main" id="{96D06B7E-2FF1-4FD2-8127-5DCC73F6B863}"/>
               </a:ext>
             </a:extLst>
           </p:cNvPr>
@@ -2298,7 +2308,7 @@
           <p:cNvPr id="10" name="">
             <a:extLst xmlns:a="http://schemas.openxmlformats.org/drawingml/2006/main">
               <a:ext uri="{FF2B5EF4-FFF2-40B4-BE49-F238E27FC236}">
-                <a16:creationId xmlns:a16="http://schemas.microsoft.com/office/drawing/2014/main" id="{84FFE4BC-1895-4593-92FD-E13F631BE0B7}"/>
+                <a16:creationId xmlns:a16="http://schemas.microsoft.com/office/drawing/2014/main" id="{86533840-B96C-43D3-8A3B-C47858054D18}"/>
               </a:ext>
             </a:extLst>
           </p:cNvPr>
@@ -2331,7 +2341,7 @@
           <p:cNvPr id="11" name="">
             <a:extLst xmlns:a="http://schemas.openxmlformats.org/drawingml/2006/main">
               <a:ext uri="{FF2B5EF4-FFF2-40B4-BE49-F238E27FC236}">
-                <a16:creationId xmlns:a16="http://schemas.microsoft.com/office/drawing/2014/main" id="{9E6AFAE4-E936-4B4A-B25B-E1DC5257819B}"/>
+                <a16:creationId xmlns:a16="http://schemas.microsoft.com/office/drawing/2014/main" id="{1DBA230F-C917-4B5B-8327-370590285FDC}"/>
               </a:ext>
             </a:extLst>
           </p:cNvPr>
@@ -2389,7 +2399,7 @@
           <p:cNvPr id="12" name="">
             <a:extLst xmlns:a="http://schemas.openxmlformats.org/drawingml/2006/main">
               <a:ext uri="{FF2B5EF4-FFF2-40B4-BE49-F238E27FC236}">
-                <a16:creationId xmlns:a16="http://schemas.microsoft.com/office/drawing/2014/main" id="{B808F7F8-7921-4170-A727-B28594E6924A}"/>
+                <a16:creationId xmlns:a16="http://schemas.microsoft.com/office/drawing/2014/main" id="{9B520E23-8351-4BD9-92A6-C504E25D6104}"/>
               </a:ext>
             </a:extLst>
           </p:cNvPr>
@@ -2447,7 +2457,7 @@
           <p:cNvPr id="13" name="">
             <a:extLst xmlns:a="http://schemas.openxmlformats.org/drawingml/2006/main">
               <a:ext uri="{FF2B5EF4-FFF2-40B4-BE49-F238E27FC236}">
-                <a16:creationId xmlns:a16="http://schemas.microsoft.com/office/drawing/2014/main" id="{2B3FC38E-8204-41C7-9A1C-F63B752E4D74}"/>
+                <a16:creationId xmlns:a16="http://schemas.microsoft.com/office/drawing/2014/main" id="{056BCA4A-F3BB-48C6-9863-FF23BEC7C5DF}"/>
               </a:ext>
             </a:extLst>
           </p:cNvPr>
@@ -2505,7 +2515,7 @@
           <p:cNvPr id="14" name="">
             <a:extLst xmlns:a="http://schemas.openxmlformats.org/drawingml/2006/main">
               <a:ext uri="{FF2B5EF4-FFF2-40B4-BE49-F238E27FC236}">
-                <a16:creationId xmlns:a16="http://schemas.microsoft.com/office/drawing/2014/main" id="{212525B1-4B8F-41F9-AA50-ADEBB671E501}"/>
+                <a16:creationId xmlns:a16="http://schemas.microsoft.com/office/drawing/2014/main" id="{E21E412D-CC3B-4F5D-93D8-86C1E513C720}"/>
               </a:ext>
             </a:extLst>
           </p:cNvPr>
@@ -2538,7 +2548,7 @@
           <p:cNvPr id="15" name="">
             <a:extLst xmlns:a="http://schemas.openxmlformats.org/drawingml/2006/main">
               <a:ext uri="{FF2B5EF4-FFF2-40B4-BE49-F238E27FC236}">
-                <a16:creationId xmlns:a16="http://schemas.microsoft.com/office/drawing/2014/main" id="{08757B3E-94BF-480D-828C-883352D1395A}"/>
+                <a16:creationId xmlns:a16="http://schemas.microsoft.com/office/drawing/2014/main" id="{8F20E9AA-4674-404E-85BF-5D9E4A275115}"/>
               </a:ext>
             </a:extLst>
           </p:cNvPr>
@@ -2596,7 +2606,7 @@
           <p:cNvPr id="16" name="">
             <a:extLst xmlns:a="http://schemas.openxmlformats.org/drawingml/2006/main">
               <a:ext uri="{FF2B5EF4-FFF2-40B4-BE49-F238E27FC236}">
-                <a16:creationId xmlns:a16="http://schemas.microsoft.com/office/drawing/2014/main" id="{1532B648-1C11-4D35-8797-DD11B344A4AC}"/>
+                <a16:creationId xmlns:a16="http://schemas.microsoft.com/office/drawing/2014/main" id="{04F8B87B-33B5-47C0-B070-C2CBD384F3FD}"/>
               </a:ext>
             </a:extLst>
           </p:cNvPr>
@@ -2654,7 +2664,7 @@
           <p:cNvPr id="17" name="">
             <a:extLst xmlns:a="http://schemas.openxmlformats.org/drawingml/2006/main">
               <a:ext uri="{FF2B5EF4-FFF2-40B4-BE49-F238E27FC236}">
-                <a16:creationId xmlns:a16="http://schemas.microsoft.com/office/drawing/2014/main" id="{04FB2555-D7FA-4015-96E4-5BA9EBF36AD0}"/>
+                <a16:creationId xmlns:a16="http://schemas.microsoft.com/office/drawing/2014/main" id="{ED86E767-B714-448D-9BD5-F03DF1D9BB9E}"/>
               </a:ext>
             </a:extLst>
           </p:cNvPr>
@@ -2712,7 +2722,7 @@
           <p:cNvPr id="18" name="">
             <a:extLst xmlns:a="http://schemas.openxmlformats.org/drawingml/2006/main">
               <a:ext uri="{FF2B5EF4-FFF2-40B4-BE49-F238E27FC236}">
-                <a16:creationId xmlns:a16="http://schemas.microsoft.com/office/drawing/2014/main" id="{A49411B2-1BC6-4D36-866F-EF1AD5D7636A}"/>
+                <a16:creationId xmlns:a16="http://schemas.microsoft.com/office/drawing/2014/main" id="{373C3DE2-05D4-4AF5-B184-E5CEDE528DFB}"/>
               </a:ext>
             </a:extLst>
           </p:cNvPr>
@@ -2743,7 +2753,7 @@
           <p:cNvPr id="19" name="">
             <a:extLst xmlns:a="http://schemas.openxmlformats.org/drawingml/2006/main">
               <a:ext uri="{FF2B5EF4-FFF2-40B4-BE49-F238E27FC236}">
-                <a16:creationId xmlns:a16="http://schemas.microsoft.com/office/drawing/2014/main" id="{A1A0EB36-C8BA-4265-AA4C-8BD24364DB19}"/>
+                <a16:creationId xmlns:a16="http://schemas.microsoft.com/office/drawing/2014/main" id="{0B080630-A1AB-46E6-9659-DB9A8D4EE6EC}"/>
               </a:ext>
             </a:extLst>
           </p:cNvPr>
@@ -2801,7 +2811,7 @@
           <p:cNvPr id="20" name="">
             <a:extLst xmlns:a="http://schemas.openxmlformats.org/drawingml/2006/main">
               <a:ext uri="{FF2B5EF4-FFF2-40B4-BE49-F238E27FC236}">
-                <a16:creationId xmlns:a16="http://schemas.microsoft.com/office/drawing/2014/main" id="{A6AD5241-292A-4493-90DF-EEA4D81B7451}"/>
+                <a16:creationId xmlns:a16="http://schemas.microsoft.com/office/drawing/2014/main" id="{E52682D0-CC46-4994-9DFA-9268F57DBA44}"/>
               </a:ext>
             </a:extLst>
           </p:cNvPr>
@@ -2857,7 +2867,7 @@
     </p:spTree>
     <p:extLst>
       <p:ext uri="{BB962C8B-B14F-4D97-AF65-F5344CB8AC3E}">
-        <p14:creationId xmlns:p14="http://schemas.microsoft.com/office/powerpoint/2010/main" val="1498401449"/>
+        <p14:creationId xmlns:p14="http://schemas.microsoft.com/office/powerpoint/2010/main" val="1584498178"/>
       </p:ext>
     </p:extLst>
   </p:cSld>
@@ -2888,7 +2898,7 @@
           <p:cNvPr id="25" name="">
             <a:extLst xmlns:a="http://schemas.openxmlformats.org/drawingml/2006/main">
               <a:ext uri="{FF2B5EF4-FFF2-40B4-BE49-F238E27FC236}">
-                <a16:creationId xmlns:a16="http://schemas.microsoft.com/office/drawing/2014/main" id="{F1651C3A-4A76-4969-8CDB-A3CB9FD8BF9D}"/>
+                <a16:creationId xmlns:a16="http://schemas.microsoft.com/office/drawing/2014/main" id="{89BD23A0-5E68-4DB0-B937-A7B258C126A9}"/>
               </a:ext>
             </a:extLst>
           </p:cNvPr>
@@ -2946,7 +2956,7 @@
           <p:cNvPr id="2" name="">
             <a:extLst xmlns:a="http://schemas.openxmlformats.org/drawingml/2006/main">
               <a:ext uri="{FF2B5EF4-FFF2-40B4-BE49-F238E27FC236}">
-                <a16:creationId xmlns:a16="http://schemas.microsoft.com/office/drawing/2014/main" id="{339BF420-A278-4A1F-AD64-F99CD0094633}"/>
+                <a16:creationId xmlns:a16="http://schemas.microsoft.com/office/drawing/2014/main" id="{9C628B62-5B45-4DA1-9DFB-B494E102175C}"/>
               </a:ext>
             </a:extLst>
           </p:cNvPr>
@@ -3004,7 +3014,7 @@
           <p:cNvPr id="3" name="">
             <a:extLst xmlns:a="http://schemas.openxmlformats.org/drawingml/2006/main">
               <a:ext uri="{FF2B5EF4-FFF2-40B4-BE49-F238E27FC236}">
-                <a16:creationId xmlns:a16="http://schemas.microsoft.com/office/drawing/2014/main" id="{1C9375D1-D1A7-4BB4-89AA-3C11A5D39C8E}"/>
+                <a16:creationId xmlns:a16="http://schemas.microsoft.com/office/drawing/2014/main" id="{2585446C-05DC-4754-84F9-A82215CD4E02}"/>
               </a:ext>
             </a:extLst>
           </p:cNvPr>
@@ -3062,7 +3072,7 @@
           <p:cNvPr id="4" name="">
             <a:extLst xmlns:a="http://schemas.openxmlformats.org/drawingml/2006/main">
               <a:ext uri="{FF2B5EF4-FFF2-40B4-BE49-F238E27FC236}">
-                <a16:creationId xmlns:a16="http://schemas.microsoft.com/office/drawing/2014/main" id="{882AA509-6861-4FF9-B41B-7F8214D1CBB6}"/>
+                <a16:creationId xmlns:a16="http://schemas.microsoft.com/office/drawing/2014/main" id="{A9242BAF-9FFA-4699-BB9D-DB4692DA8183}"/>
               </a:ext>
             </a:extLst>
           </p:cNvPr>
@@ -3120,7 +3130,7 @@
           <p:cNvPr id="5" name="">
             <a:extLst xmlns:a="http://schemas.openxmlformats.org/drawingml/2006/main">
               <a:ext uri="{FF2B5EF4-FFF2-40B4-BE49-F238E27FC236}">
-                <a16:creationId xmlns:a16="http://schemas.microsoft.com/office/drawing/2014/main" id="{DF028490-4CA6-4AC7-82C4-BB38DDBF00A4}"/>
+                <a16:creationId xmlns:a16="http://schemas.microsoft.com/office/drawing/2014/main" id="{62671090-38D9-4F61-BD51-1284A0F03C80}"/>
               </a:ext>
             </a:extLst>
           </p:cNvPr>
@@ -3178,7 +3188,7 @@
           <p:cNvPr id="6" name="">
             <a:extLst xmlns:a="http://schemas.openxmlformats.org/drawingml/2006/main">
               <a:ext uri="{FF2B5EF4-FFF2-40B4-BE49-F238E27FC236}">
-                <a16:creationId xmlns:a16="http://schemas.microsoft.com/office/drawing/2014/main" id="{6F63E9EA-6703-450E-BC87-0ECDD385EE52}"/>
+                <a16:creationId xmlns:a16="http://schemas.microsoft.com/office/drawing/2014/main" id="{8D7906D3-974A-492E-91CE-5466C20E0A69}"/>
               </a:ext>
             </a:extLst>
           </p:cNvPr>
@@ -3236,7 +3246,7 @@
           <p:cNvPr id="7" name="">
             <a:extLst xmlns:a="http://schemas.openxmlformats.org/drawingml/2006/main">
               <a:ext uri="{FF2B5EF4-FFF2-40B4-BE49-F238E27FC236}">
-                <a16:creationId xmlns:a16="http://schemas.microsoft.com/office/drawing/2014/main" id="{CF63928F-A1CC-424E-A8C7-33CD425B2EFF}"/>
+                <a16:creationId xmlns:a16="http://schemas.microsoft.com/office/drawing/2014/main" id="{89D621EA-0213-4DC1-A1A6-C58221B54FC0}"/>
               </a:ext>
             </a:extLst>
           </p:cNvPr>
@@ -3267,7 +3277,7 @@
           <p:cNvPr id="8" name="">
             <a:extLst xmlns:a="http://schemas.openxmlformats.org/drawingml/2006/main">
               <a:ext uri="{FF2B5EF4-FFF2-40B4-BE49-F238E27FC236}">
-                <a16:creationId xmlns:a16="http://schemas.microsoft.com/office/drawing/2014/main" id="{B9BC0A2D-BC5E-4B48-817E-25232A63DB97}"/>
+                <a16:creationId xmlns:a16="http://schemas.microsoft.com/office/drawing/2014/main" id="{698A6670-9D0C-4A3A-9D47-71D8839B084B}"/>
               </a:ext>
             </a:extLst>
           </p:cNvPr>
@@ -3325,7 +3335,7 @@
           <p:cNvPr id="9" name="">
             <a:extLst xmlns:a="http://schemas.openxmlformats.org/drawingml/2006/main">
               <a:ext uri="{FF2B5EF4-FFF2-40B4-BE49-F238E27FC236}">
-                <a16:creationId xmlns:a16="http://schemas.microsoft.com/office/drawing/2014/main" id="{6100CBED-13C1-431A-A861-4F9A49F4ADD0}"/>
+                <a16:creationId xmlns:a16="http://schemas.microsoft.com/office/drawing/2014/main" id="{A99EE0BD-77B6-4ECC-AA21-63499ADD9E72}"/>
               </a:ext>
             </a:extLst>
           </p:cNvPr>
@@ -3383,7 +3393,7 @@
           <p:cNvPr id="10" name="">
             <a:extLst xmlns:a="http://schemas.openxmlformats.org/drawingml/2006/main">
               <a:ext uri="{FF2B5EF4-FFF2-40B4-BE49-F238E27FC236}">
-                <a16:creationId xmlns:a16="http://schemas.microsoft.com/office/drawing/2014/main" id="{CDBBEDCA-CC9B-4AD0-B80D-47D63139BC15}"/>
+                <a16:creationId xmlns:a16="http://schemas.microsoft.com/office/drawing/2014/main" id="{9E115893-B3E4-4278-A23C-B428C0D00FE0}"/>
               </a:ext>
             </a:extLst>
           </p:cNvPr>
@@ -3441,7 +3451,7 @@
           <p:cNvPr id="11" name="">
             <a:extLst xmlns:a="http://schemas.openxmlformats.org/drawingml/2006/main">
               <a:ext uri="{FF2B5EF4-FFF2-40B4-BE49-F238E27FC236}">
-                <a16:creationId xmlns:a16="http://schemas.microsoft.com/office/drawing/2014/main" id="{8B466E54-D8EE-4DAE-BD91-F69761149F41}"/>
+                <a16:creationId xmlns:a16="http://schemas.microsoft.com/office/drawing/2014/main" id="{C4E7DC77-4B93-433F-ADD7-A66030B2E75E}"/>
               </a:ext>
             </a:extLst>
           </p:cNvPr>
@@ -3568,7 +3578,7 @@
           <p:cNvPr id="12" name="">
             <a:extLst xmlns:a="http://schemas.openxmlformats.org/drawingml/2006/main">
               <a:ext uri="{FF2B5EF4-FFF2-40B4-BE49-F238E27FC236}">
-                <a16:creationId xmlns:a16="http://schemas.microsoft.com/office/drawing/2014/main" id="{89639854-545E-419A-8DD7-5126BCF5CBFD}"/>
+                <a16:creationId xmlns:a16="http://schemas.microsoft.com/office/drawing/2014/main" id="{8D61F8E1-712E-4922-8398-0C4B4E991298}"/>
               </a:ext>
             </a:extLst>
           </p:cNvPr>
@@ -3599,7 +3609,7 @@
           <p:cNvPr id="13" name="">
             <a:extLst xmlns:a="http://schemas.openxmlformats.org/drawingml/2006/main">
               <a:ext uri="{FF2B5EF4-FFF2-40B4-BE49-F238E27FC236}">
-                <a16:creationId xmlns:a16="http://schemas.microsoft.com/office/drawing/2014/main" id="{522CDC7C-76A7-4C3D-91D8-68774CFC2A25}"/>
+                <a16:creationId xmlns:a16="http://schemas.microsoft.com/office/drawing/2014/main" id="{3F32B58C-EA5A-4ECF-88B7-8EA20CA8506D}"/>
               </a:ext>
             </a:extLst>
           </p:cNvPr>
@@ -3657,7 +3667,7 @@
           <p:cNvPr id="14" name="">
             <a:extLst xmlns:a="http://schemas.openxmlformats.org/drawingml/2006/main">
               <a:ext uri="{FF2B5EF4-FFF2-40B4-BE49-F238E27FC236}">
-                <a16:creationId xmlns:a16="http://schemas.microsoft.com/office/drawing/2014/main" id="{AFD383E2-77AE-4F76-BA08-AF0C3BBE70E4}"/>
+                <a16:creationId xmlns:a16="http://schemas.microsoft.com/office/drawing/2014/main" id="{CE9A370D-4136-4D2A-B8FB-E688DF623EFA}"/>
               </a:ext>
             </a:extLst>
           </p:cNvPr>
@@ -3688,7 +3698,7 @@
           <p:cNvPr id="15" name="">
             <a:extLst xmlns:a="http://schemas.openxmlformats.org/drawingml/2006/main">
               <a:ext uri="{FF2B5EF4-FFF2-40B4-BE49-F238E27FC236}">
-                <a16:creationId xmlns:a16="http://schemas.microsoft.com/office/drawing/2014/main" id="{46A699A6-0A8D-4128-BF99-989512098391}"/>
+                <a16:creationId xmlns:a16="http://schemas.microsoft.com/office/drawing/2014/main" id="{047FA5B3-4989-431F-8B31-B9B378F4D565}"/>
               </a:ext>
             </a:extLst>
           </p:cNvPr>
@@ -3746,7 +3756,7 @@
           <p:cNvPr id="16" name="">
             <a:extLst xmlns:a="http://schemas.openxmlformats.org/drawingml/2006/main">
               <a:ext uri="{FF2B5EF4-FFF2-40B4-BE49-F238E27FC236}">
-                <a16:creationId xmlns:a16="http://schemas.microsoft.com/office/drawing/2014/main" id="{EE394C37-51D1-450A-B107-7845723642B9}"/>
+                <a16:creationId xmlns:a16="http://schemas.microsoft.com/office/drawing/2014/main" id="{99F3863E-385F-44C2-AA73-D5C7CADCB60D}"/>
               </a:ext>
             </a:extLst>
           </p:cNvPr>
@@ -3804,7 +3814,7 @@
           <p:cNvPr id="17" name="">
             <a:extLst xmlns:a="http://schemas.openxmlformats.org/drawingml/2006/main">
               <a:ext uri="{FF2B5EF4-FFF2-40B4-BE49-F238E27FC236}">
-                <a16:creationId xmlns:a16="http://schemas.microsoft.com/office/drawing/2014/main" id="{634AE2C9-C1AD-4F22-A895-02879FB5D131}"/>
+                <a16:creationId xmlns:a16="http://schemas.microsoft.com/office/drawing/2014/main" id="{A642FE82-6373-4FC5-B21B-5061DBA43284}"/>
               </a:ext>
             </a:extLst>
           </p:cNvPr>
@@ -3862,7 +3872,7 @@
           <p:cNvPr id="18" name="">
             <a:extLst xmlns:a="http://schemas.openxmlformats.org/drawingml/2006/main">
               <a:ext uri="{FF2B5EF4-FFF2-40B4-BE49-F238E27FC236}">
-                <a16:creationId xmlns:a16="http://schemas.microsoft.com/office/drawing/2014/main" id="{4EBA5D19-8554-4166-B00B-B55D039E3DD5}"/>
+                <a16:creationId xmlns:a16="http://schemas.microsoft.com/office/drawing/2014/main" id="{9704664E-AB29-4191-A40C-9F91C14AB0CD}"/>
               </a:ext>
             </a:extLst>
           </p:cNvPr>
@@ -3920,7 +3930,7 @@
           <p:cNvPr id="19" name="">
             <a:extLst xmlns:a="http://schemas.openxmlformats.org/drawingml/2006/main">
               <a:ext uri="{FF2B5EF4-FFF2-40B4-BE49-F238E27FC236}">
-                <a16:creationId xmlns:a16="http://schemas.microsoft.com/office/drawing/2014/main" id="{9019CA47-9817-4561-BD54-E13DE45FF209}"/>
+                <a16:creationId xmlns:a16="http://schemas.microsoft.com/office/drawing/2014/main" id="{FF0CBC0F-102F-4F4D-9DB4-D5303CBF3EA8}"/>
               </a:ext>
             </a:extLst>
           </p:cNvPr>
@@ -4047,7 +4057,7 @@
           <p:cNvPr id="20" name="">
             <a:extLst xmlns:a="http://schemas.openxmlformats.org/drawingml/2006/main">
               <a:ext uri="{FF2B5EF4-FFF2-40B4-BE49-F238E27FC236}">
-                <a16:creationId xmlns:a16="http://schemas.microsoft.com/office/drawing/2014/main" id="{3B3EC7D5-9FAF-4DE5-8483-F498081D2AC3}"/>
+                <a16:creationId xmlns:a16="http://schemas.microsoft.com/office/drawing/2014/main" id="{488ADFE9-E6D2-42F8-9A91-1F2F0CB5AFFE}"/>
               </a:ext>
             </a:extLst>
           </p:cNvPr>
@@ -4078,7 +4088,7 @@
           <p:cNvPr id="21" name="">
             <a:extLst xmlns:a="http://schemas.openxmlformats.org/drawingml/2006/main">
               <a:ext uri="{FF2B5EF4-FFF2-40B4-BE49-F238E27FC236}">
-                <a16:creationId xmlns:a16="http://schemas.microsoft.com/office/drawing/2014/main" id="{321F9C1F-DE5B-4C64-84F9-C2940285B665}"/>
+                <a16:creationId xmlns:a16="http://schemas.microsoft.com/office/drawing/2014/main" id="{D5205BDD-C9BB-4327-9EA7-F681792D2F61}"/>
               </a:ext>
             </a:extLst>
           </p:cNvPr>
@@ -4136,7 +4146,7 @@
           <p:cNvPr id="22" name="">
             <a:extLst xmlns:a="http://schemas.openxmlformats.org/drawingml/2006/main">
               <a:ext uri="{FF2B5EF4-FFF2-40B4-BE49-F238E27FC236}">
-                <a16:creationId xmlns:a16="http://schemas.microsoft.com/office/drawing/2014/main" id="{F06F2E22-9684-4993-87A8-EC60D0788114}"/>
+                <a16:creationId xmlns:a16="http://schemas.microsoft.com/office/drawing/2014/main" id="{2E75F99A-9BC3-4AD6-B4E2-4264587D2285}"/>
               </a:ext>
             </a:extLst>
           </p:cNvPr>
@@ -4167,7 +4177,7 @@
           <p:cNvPr id="23" name="">
             <a:extLst xmlns:a="http://schemas.openxmlformats.org/drawingml/2006/main">
               <a:ext uri="{FF2B5EF4-FFF2-40B4-BE49-F238E27FC236}">
-                <a16:creationId xmlns:a16="http://schemas.microsoft.com/office/drawing/2014/main" id="{72532A40-7C40-46D7-B5C4-9264F10C25EC}"/>
+                <a16:creationId xmlns:a16="http://schemas.microsoft.com/office/drawing/2014/main" id="{CC1367E7-C742-4A85-B927-25A8C946924C}"/>
               </a:ext>
             </a:extLst>
           </p:cNvPr>
@@ -4225,7 +4235,7 @@
           <p:cNvPr id="24" name="">
             <a:extLst xmlns:a="http://schemas.openxmlformats.org/drawingml/2006/main">
               <a:ext uri="{FF2B5EF4-FFF2-40B4-BE49-F238E27FC236}">
-                <a16:creationId xmlns:a16="http://schemas.microsoft.com/office/drawing/2014/main" id="{9A1E35C0-5ED1-4CFE-8534-E330E62561D5}"/>
+                <a16:creationId xmlns:a16="http://schemas.microsoft.com/office/drawing/2014/main" id="{21508A51-9C12-4DF4-AD43-09535003B5D1}"/>
               </a:ext>
             </a:extLst>
           </p:cNvPr>
@@ -4281,7 +4291,7 @@
     </p:spTree>
     <p:extLst>
       <p:ext uri="{BB962C8B-B14F-4D97-AF65-F5344CB8AC3E}">
-        <p14:creationId xmlns:p14="http://schemas.microsoft.com/office/powerpoint/2010/main" val="458605227"/>
+        <p14:creationId xmlns:p14="http://schemas.microsoft.com/office/powerpoint/2010/main" val="1422868484"/>
       </p:ext>
     </p:extLst>
   </p:cSld>
@@ -4309,10 +4319,10 @@
       </p:grpSpPr>
       <p:sp>
         <p:nvSpPr>
-          <p:cNvPr id="45" name="">
-            <a:extLst xmlns:a="http://schemas.openxmlformats.org/drawingml/2006/main">
-              <a:ext uri="{FF2B5EF4-FFF2-40B4-BE49-F238E27FC236}">
-                <a16:creationId xmlns:a16="http://schemas.microsoft.com/office/drawing/2014/main" id="{8520CA68-EE3A-46A0-8CBC-41AAD23947BC}"/>
+          <p:cNvPr id="43" name="">
+            <a:extLst xmlns:a="http://schemas.openxmlformats.org/drawingml/2006/main">
+              <a:ext uri="{FF2B5EF4-FFF2-40B4-BE49-F238E27FC236}">
+                <a16:creationId xmlns:a16="http://schemas.microsoft.com/office/drawing/2014/main" id="{A7DF7DE8-1314-444B-AD3B-A181A2303264}"/>
               </a:ext>
             </a:extLst>
           </p:cNvPr>
@@ -4324,7 +4334,7 @@
         <p:spPr>
           <a:xfrm xmlns:a="http://schemas.openxmlformats.org/drawingml/2006/main">
             <a:off x="533400" y="247650"/>
-            <a:ext cx="1476375" cy="228600"/>
+            <a:ext cx="5905500" cy="228600"/>
           </a:xfrm>
           <a:prstGeom xmlns:a="http://schemas.openxmlformats.org/drawingml/2006/main" prst="rect">
             <a:avLst/>
@@ -4360,7 +4370,7 @@
                 <a:ea typeface="Noto Sans"/>
                 <a:cs typeface="Noto Sans"/>
               </a:rPr>
-              <a:t>CODEMASTERS</a:t>
+              <a:t>ИСПОЛНЕНИЕ</a:t>
             </a:r>
           </a:p>
         </p:txBody>
@@ -4370,123 +4380,7 @@
           <p:cNvPr id="2" name="">
             <a:extLst xmlns:a="http://schemas.openxmlformats.org/drawingml/2006/main">
               <a:ext uri="{FF2B5EF4-FFF2-40B4-BE49-F238E27FC236}">
-                <a16:creationId xmlns:a16="http://schemas.microsoft.com/office/drawing/2014/main" id="{0C6A952C-314F-447E-B26C-5F230E8B0CE7}"/>
-              </a:ext>
-            </a:extLst>
-          </p:cNvPr>
-          <p:cNvSpPr>
-            <a:spLocks xmlns:a="http://schemas.openxmlformats.org/drawingml/2006/main" noGrp="1"/>
-          </p:cNvSpPr>
-          <p:nvPr/>
-        </p:nvSpPr>
-        <p:spPr>
-          <a:xfrm xmlns:a="http://schemas.openxmlformats.org/drawingml/2006/main">
-            <a:off x="2038350" y="247650"/>
-            <a:ext cx="190500" cy="228600"/>
-          </a:xfrm>
-          <a:prstGeom xmlns:a="http://schemas.openxmlformats.org/drawingml/2006/main" prst="rect">
-            <a:avLst/>
-          </a:prstGeom>
-          <a:noFill xmlns:a="http://schemas.openxmlformats.org/drawingml/2006/main"/>
-          <a:ln xmlns:a="http://schemas.openxmlformats.org/drawingml/2006/main" w="0">
-            <a:noFill/>
-            <a:prstDash val="solid"/>
-          </a:ln>
-        </p:spPr>
-        <p:txBody>
-          <a:bodyPr xmlns:a="http://schemas.openxmlformats.org/drawingml/2006/main" anchor="ctr">
-            <a:noAutofit/>
-          </a:bodyPr>
-          <a:lstStyle xmlns:a="http://schemas.openxmlformats.org/drawingml/2006/main"/>
-          <a:p xmlns:a="http://schemas.openxmlformats.org/drawingml/2006/main">
-            <a:pPr algn="ctr">
-              <a:defRPr sz="1200" b="1">
-                <a:solidFill>
-                  <a:srgbClr val="16866D"/>
-                </a:solidFill>
-                <a:latin typeface="Noto Sans"/>
-                <a:ea typeface="Noto Sans"/>
-                <a:cs typeface="Noto Sans"/>
-              </a:defRPr>
-            </a:pPr>
-            <a:r>
-              <a:rPr sz="1200" b="1">
-                <a:solidFill>
-                  <a:srgbClr val="16866D"/>
-                </a:solidFill>
-                <a:latin typeface="Noto Sans"/>
-                <a:ea typeface="Noto Sans"/>
-                <a:cs typeface="Noto Sans"/>
-              </a:rPr>
-              <a:t>/</a:t>
-            </a:r>
-          </a:p>
-        </p:txBody>
-      </p:sp>
-      <p:sp>
-        <p:nvSpPr>
-          <p:cNvPr id="3" name="">
-            <a:extLst xmlns:a="http://schemas.openxmlformats.org/drawingml/2006/main">
-              <a:ext uri="{FF2B5EF4-FFF2-40B4-BE49-F238E27FC236}">
-                <a16:creationId xmlns:a16="http://schemas.microsoft.com/office/drawing/2014/main" id="{01F5C24E-50C9-4383-BB52-0D2B7CF218C8}"/>
-              </a:ext>
-            </a:extLst>
-          </p:cNvPr>
-          <p:cNvSpPr>
-            <a:spLocks xmlns:a="http://schemas.openxmlformats.org/drawingml/2006/main" noGrp="1"/>
-          </p:cNvSpPr>
-          <p:nvPr/>
-        </p:nvSpPr>
-        <p:spPr>
-          <a:xfrm xmlns:a="http://schemas.openxmlformats.org/drawingml/2006/main">
-            <a:off x="2286000" y="247650"/>
-            <a:ext cx="4476750" cy="228600"/>
-          </a:xfrm>
-          <a:prstGeom xmlns:a="http://schemas.openxmlformats.org/drawingml/2006/main" prst="rect">
-            <a:avLst/>
-          </a:prstGeom>
-          <a:noFill xmlns:a="http://schemas.openxmlformats.org/drawingml/2006/main"/>
-          <a:ln xmlns:a="http://schemas.openxmlformats.org/drawingml/2006/main" w="0">
-            <a:noFill/>
-            <a:prstDash val="solid"/>
-          </a:ln>
-        </p:spPr>
-        <p:txBody>
-          <a:bodyPr xmlns:a="http://schemas.openxmlformats.org/drawingml/2006/main" anchor="ctr">
-            <a:noAutofit/>
-          </a:bodyPr>
-          <a:lstStyle xmlns:a="http://schemas.openxmlformats.org/drawingml/2006/main"/>
-          <a:p xmlns:a="http://schemas.openxmlformats.org/drawingml/2006/main">
-            <a:pPr algn="l">
-              <a:defRPr sz="1200" b="1">
-                <a:solidFill>
-                  <a:srgbClr val="16866D"/>
-                </a:solidFill>
-                <a:latin typeface="Noto Sans"/>
-                <a:ea typeface="Noto Sans"/>
-                <a:cs typeface="Noto Sans"/>
-              </a:defRPr>
-            </a:pPr>
-            <a:r>
-              <a:rPr sz="1200" b="1">
-                <a:solidFill>
-                  <a:srgbClr val="16866D"/>
-                </a:solidFill>
-                <a:latin typeface="Noto Sans"/>
-                <a:ea typeface="Noto Sans"/>
-                <a:cs typeface="Noto Sans"/>
-              </a:rPr>
-              <a:t>ИСПОЛНЕНИЕ</a:t>
-            </a:r>
-          </a:p>
-        </p:txBody>
-      </p:sp>
-      <p:sp>
-        <p:nvSpPr>
-          <p:cNvPr id="4" name="">
-            <a:extLst xmlns:a="http://schemas.openxmlformats.org/drawingml/2006/main">
-              <a:ext uri="{FF2B5EF4-FFF2-40B4-BE49-F238E27FC236}">
-                <a16:creationId xmlns:a16="http://schemas.microsoft.com/office/drawing/2014/main" id="{9EDB17CB-981F-4E4E-B2F7-CF42FDA49803}"/>
+                <a16:creationId xmlns:a16="http://schemas.microsoft.com/office/drawing/2014/main" id="{21ECAEC5-B9CB-4827-BF73-D401BFF90A38}"/>
               </a:ext>
             </a:extLst>
           </p:cNvPr>
@@ -4541,10 +4435,10 @@
       </p:sp>
       <p:sp>
         <p:nvSpPr>
-          <p:cNvPr id="5" name="">
-            <a:extLst xmlns:a="http://schemas.openxmlformats.org/drawingml/2006/main">
-              <a:ext uri="{FF2B5EF4-FFF2-40B4-BE49-F238E27FC236}">
-                <a16:creationId xmlns:a16="http://schemas.microsoft.com/office/drawing/2014/main" id="{D33DA1CE-394F-4885-A08E-600DD3B43333}"/>
+          <p:cNvPr id="3" name="">
+            <a:extLst xmlns:a="http://schemas.openxmlformats.org/drawingml/2006/main">
+              <a:ext uri="{FF2B5EF4-FFF2-40B4-BE49-F238E27FC236}">
+                <a16:creationId xmlns:a16="http://schemas.microsoft.com/office/drawing/2014/main" id="{7C6731BC-212A-4AA3-BBF4-950D47963DC2}"/>
               </a:ext>
             </a:extLst>
           </p:cNvPr>
@@ -4599,10 +4493,10 @@
       </p:sp>
       <p:sp>
         <p:nvSpPr>
-          <p:cNvPr id="6" name="">
-            <a:extLst xmlns:a="http://schemas.openxmlformats.org/drawingml/2006/main">
-              <a:ext uri="{FF2B5EF4-FFF2-40B4-BE49-F238E27FC236}">
-                <a16:creationId xmlns:a16="http://schemas.microsoft.com/office/drawing/2014/main" id="{09FD0A49-5AA2-4349-B0CB-7DEE07E9EA70}"/>
+          <p:cNvPr id="4" name="">
+            <a:extLst xmlns:a="http://schemas.openxmlformats.org/drawingml/2006/main">
+              <a:ext uri="{FF2B5EF4-FFF2-40B4-BE49-F238E27FC236}">
+                <a16:creationId xmlns:a16="http://schemas.microsoft.com/office/drawing/2014/main" id="{664C64A9-F83E-4872-8B53-CD8897454BB3}"/>
               </a:ext>
             </a:extLst>
           </p:cNvPr>
@@ -4657,10 +4551,10 @@
       </p:sp>
       <p:sp>
         <p:nvSpPr>
-          <p:cNvPr id="7" name="">
-            <a:extLst xmlns:a="http://schemas.openxmlformats.org/drawingml/2006/main">
-              <a:ext uri="{FF2B5EF4-FFF2-40B4-BE49-F238E27FC236}">
-                <a16:creationId xmlns:a16="http://schemas.microsoft.com/office/drawing/2014/main" id="{67B02898-8D63-4FE6-9D90-84323FABDE29}"/>
+          <p:cNvPr id="5" name="">
+            <a:extLst xmlns:a="http://schemas.openxmlformats.org/drawingml/2006/main">
+              <a:ext uri="{FF2B5EF4-FFF2-40B4-BE49-F238E27FC236}">
+                <a16:creationId xmlns:a16="http://schemas.microsoft.com/office/drawing/2014/main" id="{93197EC1-1FD4-4EBD-B12E-4A5C7B2F92C5}"/>
               </a:ext>
             </a:extLst>
           </p:cNvPr>
@@ -4688,10 +4582,10 @@
       </p:sp>
       <p:sp>
         <p:nvSpPr>
-          <p:cNvPr id="8" name="">
-            <a:extLst xmlns:a="http://schemas.openxmlformats.org/drawingml/2006/main">
-              <a:ext uri="{FF2B5EF4-FFF2-40B4-BE49-F238E27FC236}">
-                <a16:creationId xmlns:a16="http://schemas.microsoft.com/office/drawing/2014/main" id="{5D1AF584-B179-48E0-9D7D-9AF6337AE15E}"/>
+          <p:cNvPr id="6" name="">
+            <a:extLst xmlns:a="http://schemas.openxmlformats.org/drawingml/2006/main">
+              <a:ext uri="{FF2B5EF4-FFF2-40B4-BE49-F238E27FC236}">
+                <a16:creationId xmlns:a16="http://schemas.microsoft.com/office/drawing/2014/main" id="{F8E7C803-448F-428F-9F0A-C8AC31748D90}"/>
               </a:ext>
             </a:extLst>
           </p:cNvPr>
@@ -4746,10 +4640,10 @@
       </p:sp>
       <p:sp>
         <p:nvSpPr>
-          <p:cNvPr id="9" name="">
-            <a:extLst xmlns:a="http://schemas.openxmlformats.org/drawingml/2006/main">
-              <a:ext uri="{FF2B5EF4-FFF2-40B4-BE49-F238E27FC236}">
-                <a16:creationId xmlns:a16="http://schemas.microsoft.com/office/drawing/2014/main" id="{7AF76087-B9DD-465D-A9E3-36696BB390E6}"/>
+          <p:cNvPr id="7" name="">
+            <a:extLst xmlns:a="http://schemas.openxmlformats.org/drawingml/2006/main">
+              <a:ext uri="{FF2B5EF4-FFF2-40B4-BE49-F238E27FC236}">
+                <a16:creationId xmlns:a16="http://schemas.microsoft.com/office/drawing/2014/main" id="{ABCA1E24-3DEB-4817-90B9-EA0FA8018EFA}"/>
               </a:ext>
             </a:extLst>
           </p:cNvPr>
@@ -4804,10 +4698,10 @@
       </p:sp>
       <p:sp>
         <p:nvSpPr>
-          <p:cNvPr id="10" name="">
-            <a:extLst xmlns:a="http://schemas.openxmlformats.org/drawingml/2006/main">
-              <a:ext uri="{FF2B5EF4-FFF2-40B4-BE49-F238E27FC236}">
-                <a16:creationId xmlns:a16="http://schemas.microsoft.com/office/drawing/2014/main" id="{352D3B4F-4B4E-4824-9038-429469F8404A}"/>
+          <p:cNvPr id="8" name="">
+            <a:extLst xmlns:a="http://schemas.openxmlformats.org/drawingml/2006/main">
+              <a:ext uri="{FF2B5EF4-FFF2-40B4-BE49-F238E27FC236}">
+                <a16:creationId xmlns:a16="http://schemas.microsoft.com/office/drawing/2014/main" id="{E0BF2FB6-FE01-47CD-965D-A78776354D9A}"/>
               </a:ext>
             </a:extLst>
           </p:cNvPr>
@@ -4862,10 +4756,10 @@
       </p:sp>
       <p:sp>
         <p:nvSpPr>
-          <p:cNvPr id="11" name="">
-            <a:extLst xmlns:a="http://schemas.openxmlformats.org/drawingml/2006/main">
-              <a:ext uri="{FF2B5EF4-FFF2-40B4-BE49-F238E27FC236}">
-                <a16:creationId xmlns:a16="http://schemas.microsoft.com/office/drawing/2014/main" id="{74A45069-E63A-4655-8D96-63B9B0688EDA}"/>
+          <p:cNvPr id="9" name="">
+            <a:extLst xmlns:a="http://schemas.openxmlformats.org/drawingml/2006/main">
+              <a:ext uri="{FF2B5EF4-FFF2-40B4-BE49-F238E27FC236}">
+                <a16:creationId xmlns:a16="http://schemas.microsoft.com/office/drawing/2014/main" id="{5736E9B5-9392-4BE4-B380-1327F6F8604E}"/>
               </a:ext>
             </a:extLst>
           </p:cNvPr>
@@ -4895,10 +4789,10 @@
       </p:sp>
       <p:sp>
         <p:nvSpPr>
-          <p:cNvPr id="12" name="">
-            <a:extLst xmlns:a="http://schemas.openxmlformats.org/drawingml/2006/main">
-              <a:ext uri="{FF2B5EF4-FFF2-40B4-BE49-F238E27FC236}">
-                <a16:creationId xmlns:a16="http://schemas.microsoft.com/office/drawing/2014/main" id="{FA47E622-AFE2-42CB-BB10-386E692D0782}"/>
+          <p:cNvPr id="10" name="">
+            <a:extLst xmlns:a="http://schemas.openxmlformats.org/drawingml/2006/main">
+              <a:ext uri="{FF2B5EF4-FFF2-40B4-BE49-F238E27FC236}">
+                <a16:creationId xmlns:a16="http://schemas.microsoft.com/office/drawing/2014/main" id="{C485D807-B971-499C-938D-E24EE8439918}"/>
               </a:ext>
             </a:extLst>
           </p:cNvPr>
@@ -4953,10 +4847,10 @@
       </p:sp>
       <p:sp>
         <p:nvSpPr>
-          <p:cNvPr id="13" name="">
-            <a:extLst xmlns:a="http://schemas.openxmlformats.org/drawingml/2006/main">
-              <a:ext uri="{FF2B5EF4-FFF2-40B4-BE49-F238E27FC236}">
-                <a16:creationId xmlns:a16="http://schemas.microsoft.com/office/drawing/2014/main" id="{81F1E5B3-0405-4C99-A11E-1D1CDEEE17B4}"/>
+          <p:cNvPr id="11" name="">
+            <a:extLst xmlns:a="http://schemas.openxmlformats.org/drawingml/2006/main">
+              <a:ext uri="{FF2B5EF4-FFF2-40B4-BE49-F238E27FC236}">
+                <a16:creationId xmlns:a16="http://schemas.microsoft.com/office/drawing/2014/main" id="{65D65371-5214-4E89-BDA7-150940467DD4}"/>
               </a:ext>
             </a:extLst>
           </p:cNvPr>
@@ -5011,10 +4905,10 @@
       </p:sp>
       <p:sp>
         <p:nvSpPr>
-          <p:cNvPr id="14" name="">
-            <a:extLst xmlns:a="http://schemas.openxmlformats.org/drawingml/2006/main">
-              <a:ext uri="{FF2B5EF4-FFF2-40B4-BE49-F238E27FC236}">
-                <a16:creationId xmlns:a16="http://schemas.microsoft.com/office/drawing/2014/main" id="{A0F794B6-DF07-4530-A0DF-38ACCFC40E37}"/>
+          <p:cNvPr id="12" name="">
+            <a:extLst xmlns:a="http://schemas.openxmlformats.org/drawingml/2006/main">
+              <a:ext uri="{FF2B5EF4-FFF2-40B4-BE49-F238E27FC236}">
+                <a16:creationId xmlns:a16="http://schemas.microsoft.com/office/drawing/2014/main" id="{ADB060FE-FD8D-4EDD-AC42-DBFBD2539EA8}"/>
               </a:ext>
             </a:extLst>
           </p:cNvPr>
@@ -5069,10 +4963,10 @@
       </p:sp>
       <p:sp>
         <p:nvSpPr>
-          <p:cNvPr id="15" name="">
-            <a:extLst xmlns:a="http://schemas.openxmlformats.org/drawingml/2006/main">
-              <a:ext uri="{FF2B5EF4-FFF2-40B4-BE49-F238E27FC236}">
-                <a16:creationId xmlns:a16="http://schemas.microsoft.com/office/drawing/2014/main" id="{92D1699E-BFE7-4E53-AC62-FE12BFAB05FF}"/>
+          <p:cNvPr id="13" name="">
+            <a:extLst xmlns:a="http://schemas.openxmlformats.org/drawingml/2006/main">
+              <a:ext uri="{FF2B5EF4-FFF2-40B4-BE49-F238E27FC236}">
+                <a16:creationId xmlns:a16="http://schemas.microsoft.com/office/drawing/2014/main" id="{A95C754B-6E72-4567-8EE3-C470B442FF28}"/>
               </a:ext>
             </a:extLst>
           </p:cNvPr>
@@ -5102,10 +4996,10 @@
       </p:sp>
       <p:sp>
         <p:nvSpPr>
-          <p:cNvPr id="16" name="">
-            <a:extLst xmlns:a="http://schemas.openxmlformats.org/drawingml/2006/main">
-              <a:ext uri="{FF2B5EF4-FFF2-40B4-BE49-F238E27FC236}">
-                <a16:creationId xmlns:a16="http://schemas.microsoft.com/office/drawing/2014/main" id="{976C6C73-1148-4B1C-999F-16C9B2AD36F2}"/>
+          <p:cNvPr id="14" name="">
+            <a:extLst xmlns:a="http://schemas.openxmlformats.org/drawingml/2006/main">
+              <a:ext uri="{FF2B5EF4-FFF2-40B4-BE49-F238E27FC236}">
+                <a16:creationId xmlns:a16="http://schemas.microsoft.com/office/drawing/2014/main" id="{BA16C240-5A50-4446-8D67-63B559BF0E05}"/>
               </a:ext>
             </a:extLst>
           </p:cNvPr>
@@ -5160,10 +5054,10 @@
       </p:sp>
       <p:sp>
         <p:nvSpPr>
-          <p:cNvPr id="17" name="">
-            <a:extLst xmlns:a="http://schemas.openxmlformats.org/drawingml/2006/main">
-              <a:ext uri="{FF2B5EF4-FFF2-40B4-BE49-F238E27FC236}">
-                <a16:creationId xmlns:a16="http://schemas.microsoft.com/office/drawing/2014/main" id="{B7F2BDBF-4A23-48FD-8269-9F49105B4E29}"/>
+          <p:cNvPr id="15" name="">
+            <a:extLst xmlns:a="http://schemas.openxmlformats.org/drawingml/2006/main">
+              <a:ext uri="{FF2B5EF4-FFF2-40B4-BE49-F238E27FC236}">
+                <a16:creationId xmlns:a16="http://schemas.microsoft.com/office/drawing/2014/main" id="{95C5ADDB-9ED2-4261-B730-655E32F71157}"/>
               </a:ext>
             </a:extLst>
           </p:cNvPr>
@@ -5218,10 +5112,10 @@
       </p:sp>
       <p:sp>
         <p:nvSpPr>
-          <p:cNvPr id="18" name="">
-            <a:extLst xmlns:a="http://schemas.openxmlformats.org/drawingml/2006/main">
-              <a:ext uri="{FF2B5EF4-FFF2-40B4-BE49-F238E27FC236}">
-                <a16:creationId xmlns:a16="http://schemas.microsoft.com/office/drawing/2014/main" id="{33CAB6E0-FE69-43C2-B9D1-DABFFBE349D5}"/>
+          <p:cNvPr id="16" name="">
+            <a:extLst xmlns:a="http://schemas.openxmlformats.org/drawingml/2006/main">
+              <a:ext uri="{FF2B5EF4-FFF2-40B4-BE49-F238E27FC236}">
+                <a16:creationId xmlns:a16="http://schemas.microsoft.com/office/drawing/2014/main" id="{A6072D32-244E-4F3A-9E80-30793E69B503}"/>
               </a:ext>
             </a:extLst>
           </p:cNvPr>
@@ -5299,10 +5193,10 @@
       </p:sp>
       <p:sp>
         <p:nvSpPr>
-          <p:cNvPr id="19" name="">
-            <a:extLst xmlns:a="http://schemas.openxmlformats.org/drawingml/2006/main">
-              <a:ext uri="{FF2B5EF4-FFF2-40B4-BE49-F238E27FC236}">
-                <a16:creationId xmlns:a16="http://schemas.microsoft.com/office/drawing/2014/main" id="{4BA591A8-ED99-427D-91EF-B1B85AF0AFDA}"/>
+          <p:cNvPr id="17" name="">
+            <a:extLst xmlns:a="http://schemas.openxmlformats.org/drawingml/2006/main">
+              <a:ext uri="{FF2B5EF4-FFF2-40B4-BE49-F238E27FC236}">
+                <a16:creationId xmlns:a16="http://schemas.microsoft.com/office/drawing/2014/main" id="{CCB69FA9-5CBC-4F55-B8B8-6C54BD76057A}"/>
               </a:ext>
             </a:extLst>
           </p:cNvPr>
@@ -5332,10 +5226,10 @@
       </p:sp>
       <p:sp>
         <p:nvSpPr>
-          <p:cNvPr id="20" name="">
-            <a:extLst xmlns:a="http://schemas.openxmlformats.org/drawingml/2006/main">
-              <a:ext uri="{FF2B5EF4-FFF2-40B4-BE49-F238E27FC236}">
-                <a16:creationId xmlns:a16="http://schemas.microsoft.com/office/drawing/2014/main" id="{73812820-D3F9-445A-91F7-9AF897B74FF9}"/>
+          <p:cNvPr id="18" name="">
+            <a:extLst xmlns:a="http://schemas.openxmlformats.org/drawingml/2006/main">
+              <a:ext uri="{FF2B5EF4-FFF2-40B4-BE49-F238E27FC236}">
+                <a16:creationId xmlns:a16="http://schemas.microsoft.com/office/drawing/2014/main" id="{A9E8A89A-163D-44AE-AF3B-A167D76643EC}"/>
               </a:ext>
             </a:extLst>
           </p:cNvPr>
@@ -5390,10 +5284,10 @@
       </p:sp>
       <p:sp>
         <p:nvSpPr>
-          <p:cNvPr id="21" name="">
-            <a:extLst xmlns:a="http://schemas.openxmlformats.org/drawingml/2006/main">
-              <a:ext uri="{FF2B5EF4-FFF2-40B4-BE49-F238E27FC236}">
-                <a16:creationId xmlns:a16="http://schemas.microsoft.com/office/drawing/2014/main" id="{ABD6BDEA-304D-46A3-A245-CFAF73D6EFD4}"/>
+          <p:cNvPr id="19" name="">
+            <a:extLst xmlns:a="http://schemas.openxmlformats.org/drawingml/2006/main">
+              <a:ext uri="{FF2B5EF4-FFF2-40B4-BE49-F238E27FC236}">
+                <a16:creationId xmlns:a16="http://schemas.microsoft.com/office/drawing/2014/main" id="{95E372FB-9F23-48ED-8767-E8F2402E2D69}"/>
               </a:ext>
             </a:extLst>
           </p:cNvPr>
@@ -5448,10 +5342,10 @@
       </p:sp>
       <p:sp>
         <p:nvSpPr>
-          <p:cNvPr id="22" name="">
-            <a:extLst xmlns:a="http://schemas.openxmlformats.org/drawingml/2006/main">
-              <a:ext uri="{FF2B5EF4-FFF2-40B4-BE49-F238E27FC236}">
-                <a16:creationId xmlns:a16="http://schemas.microsoft.com/office/drawing/2014/main" id="{89C0B7C2-47D4-411E-9CC7-8C1271F17E11}"/>
+          <p:cNvPr id="20" name="">
+            <a:extLst xmlns:a="http://schemas.openxmlformats.org/drawingml/2006/main">
+              <a:ext uri="{FF2B5EF4-FFF2-40B4-BE49-F238E27FC236}">
+                <a16:creationId xmlns:a16="http://schemas.microsoft.com/office/drawing/2014/main" id="{CC3DD9E4-8D51-467A-9617-6456706374E8}"/>
               </a:ext>
             </a:extLst>
           </p:cNvPr>
@@ -5529,10 +5423,10 @@
       </p:sp>
       <p:sp>
         <p:nvSpPr>
-          <p:cNvPr id="23" name="">
-            <a:extLst xmlns:a="http://schemas.openxmlformats.org/drawingml/2006/main">
-              <a:ext uri="{FF2B5EF4-FFF2-40B4-BE49-F238E27FC236}">
-                <a16:creationId xmlns:a16="http://schemas.microsoft.com/office/drawing/2014/main" id="{FA89CAE9-6AB8-4B85-8F8D-0FA9ED8241AD}"/>
+          <p:cNvPr id="21" name="">
+            <a:extLst xmlns:a="http://schemas.openxmlformats.org/drawingml/2006/main">
+              <a:ext uri="{FF2B5EF4-FFF2-40B4-BE49-F238E27FC236}">
+                <a16:creationId xmlns:a16="http://schemas.microsoft.com/office/drawing/2014/main" id="{B16BF5EF-A991-40E6-8473-085DEE9A1330}"/>
               </a:ext>
             </a:extLst>
           </p:cNvPr>
@@ -5562,10 +5456,10 @@
       </p:sp>
       <p:sp>
         <p:nvSpPr>
-          <p:cNvPr id="24" name="">
-            <a:extLst xmlns:a="http://schemas.openxmlformats.org/drawingml/2006/main">
-              <a:ext uri="{FF2B5EF4-FFF2-40B4-BE49-F238E27FC236}">
-                <a16:creationId xmlns:a16="http://schemas.microsoft.com/office/drawing/2014/main" id="{C329C1BA-EA17-4624-B9DC-8119865F0CB3}"/>
+          <p:cNvPr id="22" name="">
+            <a:extLst xmlns:a="http://schemas.openxmlformats.org/drawingml/2006/main">
+              <a:ext uri="{FF2B5EF4-FFF2-40B4-BE49-F238E27FC236}">
+                <a16:creationId xmlns:a16="http://schemas.microsoft.com/office/drawing/2014/main" id="{4B745148-E6BC-4D63-8DC2-602470635FFB}"/>
               </a:ext>
             </a:extLst>
           </p:cNvPr>
@@ -5620,10 +5514,10 @@
       </p:sp>
       <p:sp>
         <p:nvSpPr>
-          <p:cNvPr id="25" name="">
-            <a:extLst xmlns:a="http://schemas.openxmlformats.org/drawingml/2006/main">
-              <a:ext uri="{FF2B5EF4-FFF2-40B4-BE49-F238E27FC236}">
-                <a16:creationId xmlns:a16="http://schemas.microsoft.com/office/drawing/2014/main" id="{719700AC-DD2B-40D9-AFCF-62CE6714DEB1}"/>
+          <p:cNvPr id="23" name="">
+            <a:extLst xmlns:a="http://schemas.openxmlformats.org/drawingml/2006/main">
+              <a:ext uri="{FF2B5EF4-FFF2-40B4-BE49-F238E27FC236}">
+                <a16:creationId xmlns:a16="http://schemas.microsoft.com/office/drawing/2014/main" id="{ED71A76E-FDF8-4454-9156-AAB872606A8C}"/>
               </a:ext>
             </a:extLst>
           </p:cNvPr>
@@ -5678,10 +5572,10 @@
       </p:sp>
       <p:sp>
         <p:nvSpPr>
-          <p:cNvPr id="26" name="">
-            <a:extLst xmlns:a="http://schemas.openxmlformats.org/drawingml/2006/main">
-              <a:ext uri="{FF2B5EF4-FFF2-40B4-BE49-F238E27FC236}">
-                <a16:creationId xmlns:a16="http://schemas.microsoft.com/office/drawing/2014/main" id="{F99EFBDF-5654-4331-9C5B-C895FD374015}"/>
+          <p:cNvPr id="24" name="">
+            <a:extLst xmlns:a="http://schemas.openxmlformats.org/drawingml/2006/main">
+              <a:ext uri="{FF2B5EF4-FFF2-40B4-BE49-F238E27FC236}">
+                <a16:creationId xmlns:a16="http://schemas.microsoft.com/office/drawing/2014/main" id="{34930636-4F89-48F4-A978-E7C800470D7A}"/>
               </a:ext>
             </a:extLst>
           </p:cNvPr>
@@ -5736,10 +5630,10 @@
       </p:sp>
       <p:sp>
         <p:nvSpPr>
-          <p:cNvPr id="27" name="">
-            <a:extLst xmlns:a="http://schemas.openxmlformats.org/drawingml/2006/main">
-              <a:ext uri="{FF2B5EF4-FFF2-40B4-BE49-F238E27FC236}">
-                <a16:creationId xmlns:a16="http://schemas.microsoft.com/office/drawing/2014/main" id="{35EB0FB2-CBA2-48BD-BB50-8515733B5108}"/>
+          <p:cNvPr id="25" name="">
+            <a:extLst xmlns:a="http://schemas.openxmlformats.org/drawingml/2006/main">
+              <a:ext uri="{FF2B5EF4-FFF2-40B4-BE49-F238E27FC236}">
+                <a16:creationId xmlns:a16="http://schemas.microsoft.com/office/drawing/2014/main" id="{58D2B4AD-D26D-4701-9D8F-CD374AF00BAB}"/>
               </a:ext>
             </a:extLst>
           </p:cNvPr>
@@ -5769,10 +5663,10 @@
       </p:sp>
       <p:cxnSp>
         <p:nvCxnSpPr>
-          <p:cNvPr id="72" name=""/>
+          <p:cNvPr id="68" name=""/>
           <p:cNvCxnSpPr>
-            <a:stCxn xmlns:a="http://schemas.openxmlformats.org/drawingml/2006/main" id="11" idx="6"/>
-            <a:endCxn xmlns:a="http://schemas.openxmlformats.org/drawingml/2006/main" id="15" idx="2"/>
+            <a:stCxn xmlns:a="http://schemas.openxmlformats.org/drawingml/2006/main" id="9" idx="6"/>
+            <a:endCxn xmlns:a="http://schemas.openxmlformats.org/drawingml/2006/main" id="13" idx="2"/>
           </p:cNvCxnSpPr>
           <p:nvPr/>
         </p:nvCxnSpPr>
@@ -5795,10 +5689,10 @@
       </p:cxnSp>
       <p:cxnSp>
         <p:nvCxnSpPr>
-          <p:cNvPr id="73" name=""/>
+          <p:cNvPr id="69" name=""/>
           <p:cNvCxnSpPr>
-            <a:stCxn xmlns:a="http://schemas.openxmlformats.org/drawingml/2006/main" id="15" idx="6"/>
-            <a:endCxn xmlns:a="http://schemas.openxmlformats.org/drawingml/2006/main" id="19" idx="2"/>
+            <a:stCxn xmlns:a="http://schemas.openxmlformats.org/drawingml/2006/main" id="13" idx="6"/>
+            <a:endCxn xmlns:a="http://schemas.openxmlformats.org/drawingml/2006/main" id="17" idx="2"/>
           </p:cNvCxnSpPr>
           <p:nvPr/>
         </p:nvCxnSpPr>
@@ -5821,10 +5715,10 @@
       </p:cxnSp>
       <p:cxnSp>
         <p:nvCxnSpPr>
-          <p:cNvPr id="74" name=""/>
+          <p:cNvPr id="70" name=""/>
           <p:cNvCxnSpPr>
-            <a:stCxn xmlns:a="http://schemas.openxmlformats.org/drawingml/2006/main" id="19" idx="6"/>
-            <a:endCxn xmlns:a="http://schemas.openxmlformats.org/drawingml/2006/main" id="23" idx="2"/>
+            <a:stCxn xmlns:a="http://schemas.openxmlformats.org/drawingml/2006/main" id="17" idx="6"/>
+            <a:endCxn xmlns:a="http://schemas.openxmlformats.org/drawingml/2006/main" id="21" idx="2"/>
           </p:cNvCxnSpPr>
           <p:nvPr/>
         </p:nvCxnSpPr>
@@ -5847,10 +5741,10 @@
       </p:cxnSp>
       <p:cxnSp>
         <p:nvCxnSpPr>
-          <p:cNvPr id="75" name=""/>
+          <p:cNvPr id="71" name=""/>
           <p:cNvCxnSpPr>
-            <a:stCxn xmlns:a="http://schemas.openxmlformats.org/drawingml/2006/main" id="23" idx="6"/>
-            <a:endCxn xmlns:a="http://schemas.openxmlformats.org/drawingml/2006/main" id="27" idx="2"/>
+            <a:stCxn xmlns:a="http://schemas.openxmlformats.org/drawingml/2006/main" id="21" idx="6"/>
+            <a:endCxn xmlns:a="http://schemas.openxmlformats.org/drawingml/2006/main" id="25" idx="2"/>
           </p:cNvCxnSpPr>
           <p:nvPr/>
         </p:nvCxnSpPr>
@@ -5873,10 +5767,10 @@
       </p:cxnSp>
       <p:sp>
         <p:nvSpPr>
-          <p:cNvPr id="32" name="">
-            <a:extLst xmlns:a="http://schemas.openxmlformats.org/drawingml/2006/main">
-              <a:ext uri="{FF2B5EF4-FFF2-40B4-BE49-F238E27FC236}">
-                <a16:creationId xmlns:a16="http://schemas.microsoft.com/office/drawing/2014/main" id="{8EFA3FE8-4E74-446D-A008-28D4076D8D81}"/>
+          <p:cNvPr id="30" name="">
+            <a:extLst xmlns:a="http://schemas.openxmlformats.org/drawingml/2006/main">
+              <a:ext uri="{FF2B5EF4-FFF2-40B4-BE49-F238E27FC236}">
+                <a16:creationId xmlns:a16="http://schemas.microsoft.com/office/drawing/2014/main" id="{C7623D38-CE34-4773-95E4-A22019AF71D5}"/>
               </a:ext>
             </a:extLst>
           </p:cNvPr>
@@ -5931,10 +5825,10 @@
       </p:sp>
       <p:sp>
         <p:nvSpPr>
-          <p:cNvPr id="33" name="">
-            <a:extLst xmlns:a="http://schemas.openxmlformats.org/drawingml/2006/main">
-              <a:ext uri="{FF2B5EF4-FFF2-40B4-BE49-F238E27FC236}">
-                <a16:creationId xmlns:a16="http://schemas.microsoft.com/office/drawing/2014/main" id="{5430D7F6-A21F-4BB0-9B9A-6C2D10C372F4}"/>
+          <p:cNvPr id="31" name="">
+            <a:extLst xmlns:a="http://schemas.openxmlformats.org/drawingml/2006/main">
+              <a:ext uri="{FF2B5EF4-FFF2-40B4-BE49-F238E27FC236}">
+                <a16:creationId xmlns:a16="http://schemas.microsoft.com/office/drawing/2014/main" id="{8D5C8E25-6788-4689-9186-454A26F21D08}"/>
               </a:ext>
             </a:extLst>
           </p:cNvPr>
@@ -5962,10 +5856,10 @@
       </p:sp>
       <p:sp>
         <p:nvSpPr>
-          <p:cNvPr id="34" name="">
-            <a:extLst xmlns:a="http://schemas.openxmlformats.org/drawingml/2006/main">
-              <a:ext uri="{FF2B5EF4-FFF2-40B4-BE49-F238E27FC236}">
-                <a16:creationId xmlns:a16="http://schemas.microsoft.com/office/drawing/2014/main" id="{F4D65A31-CC19-49D3-831B-CD346F010855}"/>
+          <p:cNvPr id="32" name="">
+            <a:extLst xmlns:a="http://schemas.openxmlformats.org/drawingml/2006/main">
+              <a:ext uri="{FF2B5EF4-FFF2-40B4-BE49-F238E27FC236}">
+                <a16:creationId xmlns:a16="http://schemas.microsoft.com/office/drawing/2014/main" id="{F74C1D6E-B104-40DD-A66F-82D20961ABFF}"/>
               </a:ext>
             </a:extLst>
           </p:cNvPr>
@@ -6020,10 +5914,10 @@
       </p:sp>
       <p:sp>
         <p:nvSpPr>
-          <p:cNvPr id="35" name="">
-            <a:extLst xmlns:a="http://schemas.openxmlformats.org/drawingml/2006/main">
-              <a:ext uri="{FF2B5EF4-FFF2-40B4-BE49-F238E27FC236}">
-                <a16:creationId xmlns:a16="http://schemas.microsoft.com/office/drawing/2014/main" id="{2A6D3D12-D990-4ABB-9DFF-639D6FAB9A3E}"/>
+          <p:cNvPr id="33" name="">
+            <a:extLst xmlns:a="http://schemas.openxmlformats.org/drawingml/2006/main">
+              <a:ext uri="{FF2B5EF4-FFF2-40B4-BE49-F238E27FC236}">
+                <a16:creationId xmlns:a16="http://schemas.microsoft.com/office/drawing/2014/main" id="{4C219EE6-35BB-445F-BA8B-F82E3E9B3FA8}"/>
               </a:ext>
             </a:extLst>
           </p:cNvPr>
@@ -6078,10 +5972,10 @@
       </p:sp>
       <p:cxnSp>
         <p:nvCxnSpPr>
-          <p:cNvPr id="80" name=""/>
+          <p:cNvPr id="76" name=""/>
           <p:cNvCxnSpPr>
-            <a:stCxn xmlns:a="http://schemas.openxmlformats.org/drawingml/2006/main" id="23" idx="4"/>
-            <a:endCxn xmlns:a="http://schemas.openxmlformats.org/drawingml/2006/main" id="33" idx="3"/>
+            <a:stCxn xmlns:a="http://schemas.openxmlformats.org/drawingml/2006/main" id="21" idx="4"/>
+            <a:endCxn xmlns:a="http://schemas.openxmlformats.org/drawingml/2006/main" id="31" idx="3"/>
           </p:cNvCxnSpPr>
           <p:nvPr/>
         </p:nvCxnSpPr>
@@ -6104,10 +5998,10 @@
       </p:cxnSp>
       <p:cxnSp>
         <p:nvCxnSpPr>
-          <p:cNvPr id="81" name=""/>
+          <p:cNvPr id="77" name=""/>
           <p:cNvCxnSpPr>
-            <a:stCxn xmlns:a="http://schemas.openxmlformats.org/drawingml/2006/main" id="33" idx="1"/>
-            <a:endCxn xmlns:a="http://schemas.openxmlformats.org/drawingml/2006/main" id="15" idx="4"/>
+            <a:stCxn xmlns:a="http://schemas.openxmlformats.org/drawingml/2006/main" id="31" idx="1"/>
+            <a:endCxn xmlns:a="http://schemas.openxmlformats.org/drawingml/2006/main" id="13" idx="4"/>
           </p:cNvCxnSpPr>
           <p:nvPr/>
         </p:nvCxnSpPr>
@@ -6130,10 +6024,10 @@
       </p:cxnSp>
       <p:sp>
         <p:nvSpPr>
-          <p:cNvPr id="38" name="">
-            <a:extLst xmlns:a="http://schemas.openxmlformats.org/drawingml/2006/main">
-              <a:ext uri="{FF2B5EF4-FFF2-40B4-BE49-F238E27FC236}">
-                <a16:creationId xmlns:a16="http://schemas.microsoft.com/office/drawing/2014/main" id="{4B48AA06-5B31-4D78-BD9A-FB55E92214DD}"/>
+          <p:cNvPr id="36" name="">
+            <a:extLst xmlns:a="http://schemas.openxmlformats.org/drawingml/2006/main">
+              <a:ext uri="{FF2B5EF4-FFF2-40B4-BE49-F238E27FC236}">
+                <a16:creationId xmlns:a16="http://schemas.microsoft.com/office/drawing/2014/main" id="{AFC95C87-2A2A-4615-8A69-DE1AF6B2ADDB}"/>
               </a:ext>
             </a:extLst>
           </p:cNvPr>
@@ -6188,10 +6082,10 @@
       </p:sp>
       <p:sp>
         <p:nvSpPr>
-          <p:cNvPr id="39" name="">
-            <a:extLst xmlns:a="http://schemas.openxmlformats.org/drawingml/2006/main">
-              <a:ext uri="{FF2B5EF4-FFF2-40B4-BE49-F238E27FC236}">
-                <a16:creationId xmlns:a16="http://schemas.microsoft.com/office/drawing/2014/main" id="{67EF65E8-470A-490D-9DCB-727C7A428113}"/>
+          <p:cNvPr id="37" name="">
+            <a:extLst xmlns:a="http://schemas.openxmlformats.org/drawingml/2006/main">
+              <a:ext uri="{FF2B5EF4-FFF2-40B4-BE49-F238E27FC236}">
+                <a16:creationId xmlns:a16="http://schemas.microsoft.com/office/drawing/2014/main" id="{4763C23F-A6FB-4399-8D59-76E829B3F598}"/>
               </a:ext>
             </a:extLst>
           </p:cNvPr>
@@ -6246,10 +6140,10 @@
       </p:sp>
       <p:sp>
         <p:nvSpPr>
-          <p:cNvPr id="40" name="">
-            <a:extLst xmlns:a="http://schemas.openxmlformats.org/drawingml/2006/main">
-              <a:ext uri="{FF2B5EF4-FFF2-40B4-BE49-F238E27FC236}">
-                <a16:creationId xmlns:a16="http://schemas.microsoft.com/office/drawing/2014/main" id="{51FBA770-3E76-4FB4-8DBC-49340DF5348D}"/>
+          <p:cNvPr id="38" name="">
+            <a:extLst xmlns:a="http://schemas.openxmlformats.org/drawingml/2006/main">
+              <a:ext uri="{FF2B5EF4-FFF2-40B4-BE49-F238E27FC236}">
+                <a16:creationId xmlns:a16="http://schemas.microsoft.com/office/drawing/2014/main" id="{02BE1735-33D3-4ACA-9B66-2848F8C5C3B0}"/>
               </a:ext>
             </a:extLst>
           </p:cNvPr>
@@ -6304,10 +6198,10 @@
       </p:sp>
       <p:sp>
         <p:nvSpPr>
-          <p:cNvPr id="41" name="">
-            <a:extLst xmlns:a="http://schemas.openxmlformats.org/drawingml/2006/main">
-              <a:ext uri="{FF2B5EF4-FFF2-40B4-BE49-F238E27FC236}">
-                <a16:creationId xmlns:a16="http://schemas.microsoft.com/office/drawing/2014/main" id="{14C3A840-4727-415C-8D4A-F24AC8A9525E}"/>
+          <p:cNvPr id="39" name="">
+            <a:extLst xmlns:a="http://schemas.openxmlformats.org/drawingml/2006/main">
+              <a:ext uri="{FF2B5EF4-FFF2-40B4-BE49-F238E27FC236}">
+                <a16:creationId xmlns:a16="http://schemas.microsoft.com/office/drawing/2014/main" id="{05FF57F5-FE7A-4BEE-88E1-C3086A0DD13E}"/>
               </a:ext>
             </a:extLst>
           </p:cNvPr>
@@ -6362,10 +6256,10 @@
       </p:sp>
       <p:sp>
         <p:nvSpPr>
-          <p:cNvPr id="42" name="">
-            <a:extLst xmlns:a="http://schemas.openxmlformats.org/drawingml/2006/main">
-              <a:ext uri="{FF2B5EF4-FFF2-40B4-BE49-F238E27FC236}">
-                <a16:creationId xmlns:a16="http://schemas.microsoft.com/office/drawing/2014/main" id="{EFCAFCC7-D121-49E8-A4D9-6E3839FB0E76}"/>
+          <p:cNvPr id="40" name="">
+            <a:extLst xmlns:a="http://schemas.openxmlformats.org/drawingml/2006/main">
+              <a:ext uri="{FF2B5EF4-FFF2-40B4-BE49-F238E27FC236}">
+                <a16:creationId xmlns:a16="http://schemas.microsoft.com/office/drawing/2014/main" id="{B39D130A-2901-48E0-94D1-F2A5D2E4AF41}"/>
               </a:ext>
             </a:extLst>
           </p:cNvPr>
@@ -6393,10 +6287,10 @@
       </p:sp>
       <p:sp>
         <p:nvSpPr>
-          <p:cNvPr id="43" name="">
-            <a:extLst xmlns:a="http://schemas.openxmlformats.org/drawingml/2006/main">
-              <a:ext uri="{FF2B5EF4-FFF2-40B4-BE49-F238E27FC236}">
-                <a16:creationId xmlns:a16="http://schemas.microsoft.com/office/drawing/2014/main" id="{23C681FA-8ECD-4466-8120-A0E09999D16B}"/>
+          <p:cNvPr id="41" name="">
+            <a:extLst xmlns:a="http://schemas.openxmlformats.org/drawingml/2006/main">
+              <a:ext uri="{FF2B5EF4-FFF2-40B4-BE49-F238E27FC236}">
+                <a16:creationId xmlns:a16="http://schemas.microsoft.com/office/drawing/2014/main" id="{B94984EA-2886-4F75-B7F4-F264430276AE}"/>
               </a:ext>
             </a:extLst>
           </p:cNvPr>
@@ -6451,10 +6345,10 @@
       </p:sp>
       <p:sp>
         <p:nvSpPr>
-          <p:cNvPr id="44" name="">
-            <a:extLst xmlns:a="http://schemas.openxmlformats.org/drawingml/2006/main">
-              <a:ext uri="{FF2B5EF4-FFF2-40B4-BE49-F238E27FC236}">
-                <a16:creationId xmlns:a16="http://schemas.microsoft.com/office/drawing/2014/main" id="{FAEE7229-F53D-4AB4-B47B-93ED889313C4}"/>
+          <p:cNvPr id="42" name="">
+            <a:extLst xmlns:a="http://schemas.openxmlformats.org/drawingml/2006/main">
+              <a:ext uri="{FF2B5EF4-FFF2-40B4-BE49-F238E27FC236}">
+                <a16:creationId xmlns:a16="http://schemas.microsoft.com/office/drawing/2014/main" id="{A2FA3F4D-820E-4B6D-8D5A-0CA4C434CDD6}"/>
               </a:ext>
             </a:extLst>
           </p:cNvPr>
@@ -6510,7 +6404,7 @@
     </p:spTree>
     <p:extLst>
       <p:ext uri="{BB962C8B-B14F-4D97-AF65-F5344CB8AC3E}">
-        <p14:creationId xmlns:p14="http://schemas.microsoft.com/office/powerpoint/2010/main" val="316523937"/>
+        <p14:creationId xmlns:p14="http://schemas.microsoft.com/office/powerpoint/2010/main" val="562779222"/>
       </p:ext>
     </p:extLst>
   </p:cSld>
@@ -6541,7 +6435,7 @@
           <p:cNvPr id="27" name="">
             <a:extLst xmlns:a="http://schemas.openxmlformats.org/drawingml/2006/main">
               <a:ext uri="{FF2B5EF4-FFF2-40B4-BE49-F238E27FC236}">
-                <a16:creationId xmlns:a16="http://schemas.microsoft.com/office/drawing/2014/main" id="{847E20B3-1B8E-4559-8116-0940DBA23D25}"/>
+                <a16:creationId xmlns:a16="http://schemas.microsoft.com/office/drawing/2014/main" id="{54103BF2-5FE7-4968-8190-D95C9D15FC44}"/>
               </a:ext>
             </a:extLst>
           </p:cNvPr>
@@ -6599,7 +6493,7 @@
           <p:cNvPr id="2" name="">
             <a:extLst xmlns:a="http://schemas.openxmlformats.org/drawingml/2006/main">
               <a:ext uri="{FF2B5EF4-FFF2-40B4-BE49-F238E27FC236}">
-                <a16:creationId xmlns:a16="http://schemas.microsoft.com/office/drawing/2014/main" id="{7092C23D-980F-4A70-9065-0DB1CAEFD49C}"/>
+                <a16:creationId xmlns:a16="http://schemas.microsoft.com/office/drawing/2014/main" id="{875ED1A6-AC80-485A-90B7-7A3E96ED87B5}"/>
               </a:ext>
             </a:extLst>
           </p:cNvPr>
@@ -6657,7 +6551,7 @@
           <p:cNvPr id="3" name="">
             <a:extLst xmlns:a="http://schemas.openxmlformats.org/drawingml/2006/main">
               <a:ext uri="{FF2B5EF4-FFF2-40B4-BE49-F238E27FC236}">
-                <a16:creationId xmlns:a16="http://schemas.microsoft.com/office/drawing/2014/main" id="{0DFCC66B-22DD-4461-9A09-4CFE9E18FFF2}"/>
+                <a16:creationId xmlns:a16="http://schemas.microsoft.com/office/drawing/2014/main" id="{FEFDC8E8-DB82-4CB5-8BCE-1D9E147CA540}"/>
               </a:ext>
             </a:extLst>
           </p:cNvPr>
@@ -6715,7 +6609,7 @@
           <p:cNvPr id="4" name="">
             <a:extLst xmlns:a="http://schemas.openxmlformats.org/drawingml/2006/main">
               <a:ext uri="{FF2B5EF4-FFF2-40B4-BE49-F238E27FC236}">
-                <a16:creationId xmlns:a16="http://schemas.microsoft.com/office/drawing/2014/main" id="{6BDA6897-632F-4BD4-B6C7-863715EC8099}"/>
+                <a16:creationId xmlns:a16="http://schemas.microsoft.com/office/drawing/2014/main" id="{05514A60-66B4-4F18-892A-F07BC5F83C31}"/>
               </a:ext>
             </a:extLst>
           </p:cNvPr>
@@ -6773,7 +6667,7 @@
           <p:cNvPr id="5" name="">
             <a:extLst xmlns:a="http://schemas.openxmlformats.org/drawingml/2006/main">
               <a:ext uri="{FF2B5EF4-FFF2-40B4-BE49-F238E27FC236}">
-                <a16:creationId xmlns:a16="http://schemas.microsoft.com/office/drawing/2014/main" id="{C486F926-4A89-4621-B0A2-975B53C6A401}"/>
+                <a16:creationId xmlns:a16="http://schemas.microsoft.com/office/drawing/2014/main" id="{3BC2656D-3978-43A6-AEF4-10E83E27DC50}"/>
               </a:ext>
             </a:extLst>
           </p:cNvPr>
@@ -6821,7 +6715,7 @@
                 <a:ea typeface="Noto Sans"/>
                 <a:cs typeface="Noto Sans"/>
               </a:rPr>
-              <a:t>Почему Quickpay выбран для op_109</a:t>
+              <a:t>Почему Vipay выбран для op_109</a:t>
             </a:r>
           </a:p>
         </p:txBody>
@@ -6831,7 +6725,7 @@
           <p:cNvPr id="6" name="">
             <a:extLst xmlns:a="http://schemas.openxmlformats.org/drawingml/2006/main">
               <a:ext uri="{FF2B5EF4-FFF2-40B4-BE49-F238E27FC236}">
-                <a16:creationId xmlns:a16="http://schemas.microsoft.com/office/drawing/2014/main" id="{2E295AED-A0DE-4FCC-8263-FE0371998596}"/>
+                <a16:creationId xmlns:a16="http://schemas.microsoft.com/office/drawing/2014/main" id="{8B85F138-23D6-4399-82FF-5897675A138D}"/>
               </a:ext>
             </a:extLst>
           </p:cNvPr>
@@ -6879,7 +6773,7 @@
                 <a:ea typeface="Noto Sans"/>
                 <a:cs typeface="Noto Sans"/>
               </a:rPr>
-              <a:t>Payflow исключён по банку. Quickpay и Vipay сравниваются по всем десяти факторам.</a:t>
+              <a:t>Payflow исключён по банку. Два допустимых кандидата сравниваются по всем десяти факторам.</a:t>
             </a:r>
           </a:p>
         </p:txBody>
@@ -6889,7 +6783,7 @@
           <p:cNvPr id="7" name="">
             <a:extLst xmlns:a="http://schemas.openxmlformats.org/drawingml/2006/main">
               <a:ext uri="{FF2B5EF4-FFF2-40B4-BE49-F238E27FC236}">
-                <a16:creationId xmlns:a16="http://schemas.microsoft.com/office/drawing/2014/main" id="{E261AA71-D2D9-4F1B-A747-0A5AE450F52E}"/>
+                <a16:creationId xmlns:a16="http://schemas.microsoft.com/office/drawing/2014/main" id="{64286147-B9B9-4660-8DAF-78D4FB6497EB}"/>
               </a:ext>
             </a:extLst>
           </p:cNvPr>
@@ -6920,7 +6814,7 @@
           <p:cNvPr id="8" name="">
             <a:extLst xmlns:a="http://schemas.openxmlformats.org/drawingml/2006/main">
               <a:ext uri="{FF2B5EF4-FFF2-40B4-BE49-F238E27FC236}">
-                <a16:creationId xmlns:a16="http://schemas.microsoft.com/office/drawing/2014/main" id="{BDEDAB71-3E20-4121-A7F7-B2CB71C3A308}"/>
+                <a16:creationId xmlns:a16="http://schemas.microsoft.com/office/drawing/2014/main" id="{EA27ADBE-708D-49F2-963B-6A1EC5EB696C}"/>
               </a:ext>
             </a:extLst>
           </p:cNvPr>
@@ -6978,7 +6872,7 @@
           <p:cNvPr id="9" name="">
             <a:extLst xmlns:a="http://schemas.openxmlformats.org/drawingml/2006/main">
               <a:ext uri="{FF2B5EF4-FFF2-40B4-BE49-F238E27FC236}">
-                <a16:creationId xmlns:a16="http://schemas.microsoft.com/office/drawing/2014/main" id="{9978B87C-C00B-41C3-A2C0-2BA662DAB5A2}"/>
+                <a16:creationId xmlns:a16="http://schemas.microsoft.com/office/drawing/2014/main" id="{9EB164C2-37F9-4F57-A324-A0EF8A9A2115}"/>
               </a:ext>
             </a:extLst>
           </p:cNvPr>
@@ -7026,7 +6920,7 @@
                 <a:ea typeface="Noto Sans"/>
                 <a:cs typeface="Noto Sans"/>
               </a:rPr>
-              <a:t>Quickpay</a:t>
+              <a:t>Vipay</a:t>
             </a:r>
           </a:p>
         </p:txBody>
@@ -7036,7 +6930,7 @@
           <p:cNvPr id="10" name="">
             <a:extLst xmlns:a="http://schemas.openxmlformats.org/drawingml/2006/main">
               <a:ext uri="{FF2B5EF4-FFF2-40B4-BE49-F238E27FC236}">
-                <a16:creationId xmlns:a16="http://schemas.microsoft.com/office/drawing/2014/main" id="{B1A17B13-97C1-4D09-B9C0-3F12B2DE4FCC}"/>
+                <a16:creationId xmlns:a16="http://schemas.microsoft.com/office/drawing/2014/main" id="{D928C468-7E79-4131-8DE7-511CF58AAA28}"/>
               </a:ext>
             </a:extLst>
           </p:cNvPr>
@@ -7084,7 +6978,7 @@
                 <a:ea typeface="Noto Sans"/>
                 <a:cs typeface="Noto Sans"/>
               </a:rPr>
-              <a:t>1.574225</a:t>
+              <a:t>3.473200</a:t>
             </a:r>
           </a:p>
         </p:txBody>
@@ -7094,7 +6988,7 @@
           <p:cNvPr id="11" name="">
             <a:extLst xmlns:a="http://schemas.openxmlformats.org/drawingml/2006/main">
               <a:ext uri="{FF2B5EF4-FFF2-40B4-BE49-F238E27FC236}">
-                <a16:creationId xmlns:a16="http://schemas.microsoft.com/office/drawing/2014/main" id="{EBE96FE5-DA27-4648-9D1F-F0797F666536}"/>
+                <a16:creationId xmlns:a16="http://schemas.microsoft.com/office/drawing/2014/main" id="{F8F6796A-51B6-48D2-8C4A-A678B760C14B}"/>
               </a:ext>
             </a:extLst>
           </p:cNvPr>
@@ -7142,7 +7036,7 @@
                 <a:ea typeface="Noto Sans"/>
                 <a:cs typeface="Noto Sans"/>
               </a:rPr>
-              <a:t>approved · 20 с</a:t>
+              <a:t>approved · 49 с</a:t>
             </a:r>
           </a:p>
         </p:txBody>
@@ -7152,7 +7046,7 @@
           <p:cNvPr id="12" name="">
             <a:extLst xmlns:a="http://schemas.openxmlformats.org/drawingml/2006/main">
               <a:ext uri="{FF2B5EF4-FFF2-40B4-BE49-F238E27FC236}">
-                <a16:creationId xmlns:a16="http://schemas.microsoft.com/office/drawing/2014/main" id="{E3F2070E-04C2-4917-9B27-0A2A46A9C2D2}"/>
+                <a16:creationId xmlns:a16="http://schemas.microsoft.com/office/drawing/2014/main" id="{1AC7DA80-9B4F-4043-A0EF-CF01EBC9A1D4}"/>
               </a:ext>
             </a:extLst>
           </p:cNvPr>
@@ -7183,7 +7077,7 @@
           <p:cNvPr id="13" name="">
             <a:extLst xmlns:a="http://schemas.openxmlformats.org/drawingml/2006/main">
               <a:ext uri="{FF2B5EF4-FFF2-40B4-BE49-F238E27FC236}">
-                <a16:creationId xmlns:a16="http://schemas.microsoft.com/office/drawing/2014/main" id="{8BBFE19D-3E5C-41E2-BB51-6DEB592674A0}"/>
+                <a16:creationId xmlns:a16="http://schemas.microsoft.com/office/drawing/2014/main" id="{9AC461D2-913B-4AEB-B871-9B183ECF60DF}"/>
               </a:ext>
             </a:extLst>
           </p:cNvPr>
@@ -7241,7 +7135,7 @@
           <p:cNvPr id="14" name="">
             <a:extLst xmlns:a="http://schemas.openxmlformats.org/drawingml/2006/main">
               <a:ext uri="{FF2B5EF4-FFF2-40B4-BE49-F238E27FC236}">
-                <a16:creationId xmlns:a16="http://schemas.microsoft.com/office/drawing/2014/main" id="{2E923DE6-9C29-474C-90BA-AF819D969222}"/>
+                <a16:creationId xmlns:a16="http://schemas.microsoft.com/office/drawing/2014/main" id="{95277D0F-0177-4EC4-958F-84091F840DA8}"/>
               </a:ext>
             </a:extLst>
           </p:cNvPr>
@@ -7289,7 +7183,7 @@
                 <a:ea typeface="Noto Sans"/>
                 <a:cs typeface="Noto Sans"/>
               </a:rPr>
-              <a:t>Vipay</a:t>
+              <a:t>Quickpay</a:t>
             </a:r>
           </a:p>
         </p:txBody>
@@ -7299,7 +7193,7 @@
           <p:cNvPr id="15" name="">
             <a:extLst xmlns:a="http://schemas.openxmlformats.org/drawingml/2006/main">
               <a:ext uri="{FF2B5EF4-FFF2-40B4-BE49-F238E27FC236}">
-                <a16:creationId xmlns:a16="http://schemas.microsoft.com/office/drawing/2014/main" id="{DBDD29DD-1B54-45D0-B551-896051A7A5A7}"/>
+                <a16:creationId xmlns:a16="http://schemas.microsoft.com/office/drawing/2014/main" id="{C869C9A9-F75C-43AE-8A7F-BD22999436E2}"/>
               </a:ext>
             </a:extLst>
           </p:cNvPr>
@@ -7347,7 +7241,7 @@
                 <a:ea typeface="Noto Sans"/>
                 <a:cs typeface="Noto Sans"/>
               </a:rPr>
-              <a:t>1.533247</a:t>
+              <a:t>-2.746254</a:t>
             </a:r>
           </a:p>
         </p:txBody>
@@ -7357,7 +7251,7 @@
           <p:cNvPr id="16" name="">
             <a:extLst xmlns:a="http://schemas.openxmlformats.org/drawingml/2006/main">
               <a:ext uri="{FF2B5EF4-FFF2-40B4-BE49-F238E27FC236}">
-                <a16:creationId xmlns:a16="http://schemas.microsoft.com/office/drawing/2014/main" id="{929E0D31-33EF-4BBD-A80B-57883C138CDD}"/>
+                <a16:creationId xmlns:a16="http://schemas.microsoft.com/office/drawing/2014/main" id="{140ED9E9-693F-4312-A180-BD00D7287A3F}"/>
               </a:ext>
             </a:extLst>
           </p:cNvPr>
@@ -7405,7 +7299,7 @@
                 <a:ea typeface="Noto Sans"/>
                 <a:cs typeface="Noto Sans"/>
               </a:rPr>
-              <a:t>ниже на 0,040978</a:t>
+              <a:t>ниже на 6,219454</a:t>
             </a:r>
           </a:p>
         </p:txBody>
@@ -7415,7 +7309,7 @@
           <p:cNvPr id="17" name="">
             <a:extLst xmlns:a="http://schemas.openxmlformats.org/drawingml/2006/main">
               <a:ext uri="{FF2B5EF4-FFF2-40B4-BE49-F238E27FC236}">
-                <a16:creationId xmlns:a16="http://schemas.microsoft.com/office/drawing/2014/main" id="{43179B04-2373-44FC-89E9-3A8B33AAEE46}"/>
+                <a16:creationId xmlns:a16="http://schemas.microsoft.com/office/drawing/2014/main" id="{B5C05078-DAE9-4202-9A21-1055A5CDC9F9}"/>
               </a:ext>
             </a:extLst>
           </p:cNvPr>
@@ -7446,7 +7340,7 @@
           <p:cNvPr id="18" name="">
             <a:extLst xmlns:a="http://schemas.openxmlformats.org/drawingml/2006/main">
               <a:ext uri="{FF2B5EF4-FFF2-40B4-BE49-F238E27FC236}">
-                <a16:creationId xmlns:a16="http://schemas.microsoft.com/office/drawing/2014/main" id="{D7B28C30-538D-475E-B6A0-79A35B3BE7CE}"/>
+                <a16:creationId xmlns:a16="http://schemas.microsoft.com/office/drawing/2014/main" id="{9DDBA690-2ECA-4E56-B4B3-C6139A5365A6}"/>
               </a:ext>
             </a:extLst>
           </p:cNvPr>
@@ -7504,7 +7398,7 @@
           <p:cNvPr id="19" name="">
             <a:extLst xmlns:a="http://schemas.openxmlformats.org/drawingml/2006/main">
               <a:ext uri="{FF2B5EF4-FFF2-40B4-BE49-F238E27FC236}">
-                <a16:creationId xmlns:a16="http://schemas.microsoft.com/office/drawing/2014/main" id="{E525E681-57B2-4A67-8E08-4EF81994EFBE}"/>
+                <a16:creationId xmlns:a16="http://schemas.microsoft.com/office/drawing/2014/main" id="{8535FC55-19E6-412D-A05A-BAFE215CB56B}"/>
               </a:ext>
             </a:extLst>
           </p:cNvPr>
@@ -7562,7 +7456,7 @@
           <p:cNvPr id="20" name="">
             <a:extLst xmlns:a="http://schemas.openxmlformats.org/drawingml/2006/main">
               <a:ext uri="{FF2B5EF4-FFF2-40B4-BE49-F238E27FC236}">
-                <a16:creationId xmlns:a16="http://schemas.microsoft.com/office/drawing/2014/main" id="{429967A4-B134-4005-9EBC-BD8060110778}"/>
+                <a16:creationId xmlns:a16="http://schemas.microsoft.com/office/drawing/2014/main" id="{416D18A1-F5E4-4313-B302-8A1142759875}"/>
               </a:ext>
             </a:extLst>
           </p:cNvPr>
@@ -7620,7 +7514,7 @@
           <p:cNvPr id="21" name="">
             <a:extLst xmlns:a="http://schemas.openxmlformats.org/drawingml/2006/main">
               <a:ext uri="{FF2B5EF4-FFF2-40B4-BE49-F238E27FC236}">
-                <a16:creationId xmlns:a16="http://schemas.microsoft.com/office/drawing/2014/main" id="{F0C78DBA-D896-4912-96B0-86D26924A1CB}"/>
+                <a16:creationId xmlns:a16="http://schemas.microsoft.com/office/drawing/2014/main" id="{139A0251-25F8-45C0-99F4-9D012897C253}"/>
               </a:ext>
             </a:extLst>
           </p:cNvPr>
@@ -7734,7 +7628,7 @@
                           <a:ea typeface="Noto Sans"/>
                           <a:cs typeface="Noto Sans"/>
                         </a:rPr>
-                        <a:t>Quickpay</a:t>
+                        <a:t>Vipay</a:t>
                       </a:r>
                     </a:p>
                   </a:txBody>
@@ -7759,7 +7653,7 @@
                           <a:ea typeface="Noto Sans"/>
                           <a:cs typeface="Noto Sans"/>
                         </a:rPr>
-                        <a:t>Vipay</a:t>
+                        <a:t>Quickpay</a:t>
                       </a:r>
                     </a:p>
                   </a:txBody>
@@ -7836,7 +7730,7 @@
                           <a:ea typeface="Noto Sans"/>
                           <a:cs typeface="Noto Sans"/>
                         </a:rPr>
-                        <a:t>−0,19</a:t>
+                        <a:t>+1,88</a:t>
                       </a:r>
                     </a:p>
                   </a:txBody>
@@ -7861,7 +7755,7 @@
                           <a:ea typeface="Noto Sans"/>
                           <a:cs typeface="Noto Sans"/>
                         </a:rPr>
-                        <a:t>+0,03</a:t>
+                        <a:t>-4,44</a:t>
                       </a:r>
                     </a:p>
                   </a:txBody>
@@ -7913,7 +7807,7 @@
                           <a:ea typeface="Noto Sans"/>
                           <a:cs typeface="Noto Sans"/>
                         </a:rPr>
-                        <a:t>Качество + priority + capacity</a:t>
+                        <a:t>Качество и бизнес-факторы</a:t>
                       </a:r>
                     </a:p>
                   </a:txBody>
@@ -7938,7 +7832,7 @@
                           <a:ea typeface="Noto Sans"/>
                           <a:cs typeface="Noto Sans"/>
                         </a:rPr>
-                        <a:t>+2,08</a:t>
+                        <a:t>+2,98</a:t>
                       </a:r>
                     </a:p>
                   </a:txBody>
@@ -7963,7 +7857,7 @@
                           <a:ea typeface="Noto Sans"/>
                           <a:cs typeface="Noto Sans"/>
                         </a:rPr>
-                        <a:t>+2,79</a:t>
+                        <a:t>+1,74</a:t>
                       </a:r>
                     </a:p>
                   </a:txBody>
@@ -8040,7 +7934,7 @@
                           <a:ea typeface="Noto Sans"/>
                           <a:cs typeface="Noto Sans"/>
                         </a:rPr>
-                        <a:t>−0,32</a:t>
+                        <a:t>-1,39</a:t>
                       </a:r>
                     </a:p>
                   </a:txBody>
@@ -8065,7 +7959,7 @@
                           <a:ea typeface="Noto Sans"/>
                           <a:cs typeface="Noto Sans"/>
                         </a:rPr>
-                        <a:t>−1,29</a:t>
+                        <a:t>-0,05</a:t>
                       </a:r>
                     </a:p>
                   </a:txBody>
@@ -8142,7 +8036,7 @@
                           <a:ea typeface="Noto Sans"/>
                           <a:cs typeface="Noto Sans"/>
                         </a:rPr>
-                        <a:t>1,574225</a:t>
+                        <a:t>3,473200</a:t>
                       </a:r>
                     </a:p>
                   </a:txBody>
@@ -8167,7 +8061,7 @@
                           <a:ea typeface="Noto Sans"/>
                           <a:cs typeface="Noto Sans"/>
                         </a:rPr>
-                        <a:t>1,533247</a:t>
+                        <a:t>-2,746254</a:t>
                       </a:r>
                     </a:p>
                   </a:txBody>
@@ -8192,7 +8086,7 @@
                           <a:ea typeface="Noto Sans"/>
                           <a:cs typeface="Noto Sans"/>
                         </a:rPr>
-                        <a:t>Quickpay</a:t>
+                        <a:t>Vipay</a:t>
                       </a:r>
                     </a:p>
                   </a:txBody>
@@ -8212,7 +8106,7 @@
           <p:cNvPr id="23" name="">
             <a:extLst xmlns:a="http://schemas.openxmlformats.org/drawingml/2006/main">
               <a:ext uri="{FF2B5EF4-FFF2-40B4-BE49-F238E27FC236}">
-                <a16:creationId xmlns:a16="http://schemas.microsoft.com/office/drawing/2014/main" id="{4A5B7453-56E3-405F-82FC-950FA65A08BB}"/>
+                <a16:creationId xmlns:a16="http://schemas.microsoft.com/office/drawing/2014/main" id="{C60D8E7B-26B4-4B75-B0BF-9D4F347DBA67}"/>
               </a:ext>
             </a:extLst>
           </p:cNvPr>
@@ -8260,7 +8154,7 @@
                 <a:ea typeface="Noto Sans"/>
                 <a:cs typeface="Noto Sans"/>
               </a:rPr>
-              <a:t>Quickpay выигрывает за счёт более низких операционных штрафов.</a:t>
+              <a:t>Vipay выигрывает с преимуществом 6,2195 балла.</a:t>
             </a:r>
           </a:p>
         </p:txBody>
@@ -8270,7 +8164,7 @@
           <p:cNvPr id="24" name="">
             <a:extLst xmlns:a="http://schemas.openxmlformats.org/drawingml/2006/main">
               <a:ext uri="{FF2B5EF4-FFF2-40B4-BE49-F238E27FC236}">
-                <a16:creationId xmlns:a16="http://schemas.microsoft.com/office/drawing/2014/main" id="{DD71F2AB-69AC-4E16-BADC-36875672DD1B}"/>
+                <a16:creationId xmlns:a16="http://schemas.microsoft.com/office/drawing/2014/main" id="{DC8A4DB0-5D14-4A5A-8819-9633569E8F37}"/>
               </a:ext>
             </a:extLst>
           </p:cNvPr>
@@ -8301,7 +8195,7 @@
           <p:cNvPr id="25" name="">
             <a:extLst xmlns:a="http://schemas.openxmlformats.org/drawingml/2006/main">
               <a:ext uri="{FF2B5EF4-FFF2-40B4-BE49-F238E27FC236}">
-                <a16:creationId xmlns:a16="http://schemas.microsoft.com/office/drawing/2014/main" id="{A7D969ED-0355-49FE-9FD1-0B6ECF508DFA}"/>
+                <a16:creationId xmlns:a16="http://schemas.microsoft.com/office/drawing/2014/main" id="{6937DDF0-E4B6-4372-98C3-3902A99C933E}"/>
               </a:ext>
             </a:extLst>
           </p:cNvPr>
@@ -8359,7 +8253,7 @@
           <p:cNvPr id="26" name="">
             <a:extLst xmlns:a="http://schemas.openxmlformats.org/drawingml/2006/main">
               <a:ext uri="{FF2B5EF4-FFF2-40B4-BE49-F238E27FC236}">
-                <a16:creationId xmlns:a16="http://schemas.microsoft.com/office/drawing/2014/main" id="{361FB425-0E09-4DBC-AD5C-8DEC91B0B0D2}"/>
+                <a16:creationId xmlns:a16="http://schemas.microsoft.com/office/drawing/2014/main" id="{62E22E8C-403F-4655-8E73-63E02EAF6B13}"/>
               </a:ext>
             </a:extLst>
           </p:cNvPr>
@@ -8415,7 +8309,7 @@
     </p:spTree>
     <p:extLst>
       <p:ext uri="{BB962C8B-B14F-4D97-AF65-F5344CB8AC3E}">
-        <p14:creationId xmlns:p14="http://schemas.microsoft.com/office/powerpoint/2010/main" val="1376661174"/>
+        <p14:creationId xmlns:p14="http://schemas.microsoft.com/office/powerpoint/2010/main" val="1084087659"/>
       </p:ext>
     </p:extLst>
   </p:cSld>
@@ -8443,10 +8337,10 @@
       </p:grpSpPr>
       <p:sp>
         <p:nvSpPr>
-          <p:cNvPr id="33" name="">
-            <a:extLst xmlns:a="http://schemas.openxmlformats.org/drawingml/2006/main">
-              <a:ext uri="{FF2B5EF4-FFF2-40B4-BE49-F238E27FC236}">
-                <a16:creationId xmlns:a16="http://schemas.microsoft.com/office/drawing/2014/main" id="{7DB00DA4-82A0-4D22-B22A-03A124F47644}"/>
+          <p:cNvPr id="26" name="">
+            <a:extLst xmlns:a="http://schemas.openxmlformats.org/drawingml/2006/main">
+              <a:ext uri="{FF2B5EF4-FFF2-40B4-BE49-F238E27FC236}">
+                <a16:creationId xmlns:a16="http://schemas.microsoft.com/office/drawing/2014/main" id="{D89AEBED-5246-4FCD-86C1-2E384C0AFF26}"/>
               </a:ext>
             </a:extLst>
           </p:cNvPr>
@@ -8458,7 +8352,7 @@
         <p:spPr>
           <a:xfrm xmlns:a="http://schemas.openxmlformats.org/drawingml/2006/main">
             <a:off x="533400" y="247650"/>
-            <a:ext cx="1476375" cy="228600"/>
+            <a:ext cx="5905500" cy="228600"/>
           </a:xfrm>
           <a:prstGeom xmlns:a="http://schemas.openxmlformats.org/drawingml/2006/main" prst="rect">
             <a:avLst/>
@@ -8494,7 +8388,7 @@
                 <a:ea typeface="Noto Sans"/>
                 <a:cs typeface="Noto Sans"/>
               </a:rPr>
-              <a:t>CODEMASTERS</a:t>
+              <a:t>ОТКАЗОУСТОЙЧИВОСТЬ</a:t>
             </a:r>
           </a:p>
         </p:txBody>
@@ -8504,123 +8398,7 @@
           <p:cNvPr id="2" name="">
             <a:extLst xmlns:a="http://schemas.openxmlformats.org/drawingml/2006/main">
               <a:ext uri="{FF2B5EF4-FFF2-40B4-BE49-F238E27FC236}">
-                <a16:creationId xmlns:a16="http://schemas.microsoft.com/office/drawing/2014/main" id="{7B792125-2FEB-4256-BD52-78A90688B4E9}"/>
-              </a:ext>
-            </a:extLst>
-          </p:cNvPr>
-          <p:cNvSpPr>
-            <a:spLocks xmlns:a="http://schemas.openxmlformats.org/drawingml/2006/main" noGrp="1"/>
-          </p:cNvSpPr>
-          <p:nvPr/>
-        </p:nvSpPr>
-        <p:spPr>
-          <a:xfrm xmlns:a="http://schemas.openxmlformats.org/drawingml/2006/main">
-            <a:off x="2038350" y="247650"/>
-            <a:ext cx="190500" cy="228600"/>
-          </a:xfrm>
-          <a:prstGeom xmlns:a="http://schemas.openxmlformats.org/drawingml/2006/main" prst="rect">
-            <a:avLst/>
-          </a:prstGeom>
-          <a:noFill xmlns:a="http://schemas.openxmlformats.org/drawingml/2006/main"/>
-          <a:ln xmlns:a="http://schemas.openxmlformats.org/drawingml/2006/main" w="0">
-            <a:noFill/>
-            <a:prstDash val="solid"/>
-          </a:ln>
-        </p:spPr>
-        <p:txBody>
-          <a:bodyPr xmlns:a="http://schemas.openxmlformats.org/drawingml/2006/main" anchor="ctr">
-            <a:noAutofit/>
-          </a:bodyPr>
-          <a:lstStyle xmlns:a="http://schemas.openxmlformats.org/drawingml/2006/main"/>
-          <a:p xmlns:a="http://schemas.openxmlformats.org/drawingml/2006/main">
-            <a:pPr algn="ctr">
-              <a:defRPr sz="1200" b="1">
-                <a:solidFill>
-                  <a:srgbClr val="16866D"/>
-                </a:solidFill>
-                <a:latin typeface="Noto Sans"/>
-                <a:ea typeface="Noto Sans"/>
-                <a:cs typeface="Noto Sans"/>
-              </a:defRPr>
-            </a:pPr>
-            <a:r>
-              <a:rPr sz="1200" b="1">
-                <a:solidFill>
-                  <a:srgbClr val="16866D"/>
-                </a:solidFill>
-                <a:latin typeface="Noto Sans"/>
-                <a:ea typeface="Noto Sans"/>
-                <a:cs typeface="Noto Sans"/>
-              </a:rPr>
-              <a:t>/</a:t>
-            </a:r>
-          </a:p>
-        </p:txBody>
-      </p:sp>
-      <p:sp>
-        <p:nvSpPr>
-          <p:cNvPr id="3" name="">
-            <a:extLst xmlns:a="http://schemas.openxmlformats.org/drawingml/2006/main">
-              <a:ext uri="{FF2B5EF4-FFF2-40B4-BE49-F238E27FC236}">
-                <a16:creationId xmlns:a16="http://schemas.microsoft.com/office/drawing/2014/main" id="{6B6D8CDD-0A6F-4560-B87C-58809B3D2599}"/>
-              </a:ext>
-            </a:extLst>
-          </p:cNvPr>
-          <p:cNvSpPr>
-            <a:spLocks xmlns:a="http://schemas.openxmlformats.org/drawingml/2006/main" noGrp="1"/>
-          </p:cNvSpPr>
-          <p:nvPr/>
-        </p:nvSpPr>
-        <p:spPr>
-          <a:xfrm xmlns:a="http://schemas.openxmlformats.org/drawingml/2006/main">
-            <a:off x="2286000" y="247650"/>
-            <a:ext cx="4476750" cy="228600"/>
-          </a:xfrm>
-          <a:prstGeom xmlns:a="http://schemas.openxmlformats.org/drawingml/2006/main" prst="rect">
-            <a:avLst/>
-          </a:prstGeom>
-          <a:noFill xmlns:a="http://schemas.openxmlformats.org/drawingml/2006/main"/>
-          <a:ln xmlns:a="http://schemas.openxmlformats.org/drawingml/2006/main" w="0">
-            <a:noFill/>
-            <a:prstDash val="solid"/>
-          </a:ln>
-        </p:spPr>
-        <p:txBody>
-          <a:bodyPr xmlns:a="http://schemas.openxmlformats.org/drawingml/2006/main" anchor="ctr">
-            <a:noAutofit/>
-          </a:bodyPr>
-          <a:lstStyle xmlns:a="http://schemas.openxmlformats.org/drawingml/2006/main"/>
-          <a:p xmlns:a="http://schemas.openxmlformats.org/drawingml/2006/main">
-            <a:pPr algn="l">
-              <a:defRPr sz="1200" b="1">
-                <a:solidFill>
-                  <a:srgbClr val="16866D"/>
-                </a:solidFill>
-                <a:latin typeface="Noto Sans"/>
-                <a:ea typeface="Noto Sans"/>
-                <a:cs typeface="Noto Sans"/>
-              </a:defRPr>
-            </a:pPr>
-            <a:r>
-              <a:rPr sz="1200" b="1">
-                <a:solidFill>
-                  <a:srgbClr val="16866D"/>
-                </a:solidFill>
-                <a:latin typeface="Noto Sans"/>
-                <a:ea typeface="Noto Sans"/>
-                <a:cs typeface="Noto Sans"/>
-              </a:rPr>
-              <a:t>ОТКАЗОУСТОЙЧИВОСТЬ</a:t>
-            </a:r>
-          </a:p>
-        </p:txBody>
-      </p:sp>
-      <p:sp>
-        <p:nvSpPr>
-          <p:cNvPr id="4" name="">
-            <a:extLst xmlns:a="http://schemas.openxmlformats.org/drawingml/2006/main">
-              <a:ext uri="{FF2B5EF4-FFF2-40B4-BE49-F238E27FC236}">
-                <a16:creationId xmlns:a16="http://schemas.microsoft.com/office/drawing/2014/main" id="{3ABB0DDE-5373-49E7-BBA5-C0C03FD20EA1}"/>
+                <a16:creationId xmlns:a16="http://schemas.microsoft.com/office/drawing/2014/main" id="{14AEAB36-CDEF-4F11-8267-24508A1A814F}"/>
               </a:ext>
             </a:extLst>
           </p:cNvPr>
@@ -8675,10 +8453,10 @@
       </p:sp>
       <p:sp>
         <p:nvSpPr>
-          <p:cNvPr id="5" name="">
-            <a:extLst xmlns:a="http://schemas.openxmlformats.org/drawingml/2006/main">
-              <a:ext uri="{FF2B5EF4-FFF2-40B4-BE49-F238E27FC236}">
-                <a16:creationId xmlns:a16="http://schemas.microsoft.com/office/drawing/2014/main" id="{BD77FBC5-B854-4A7F-A1EA-2F291490AABB}"/>
+          <p:cNvPr id="3" name="">
+            <a:extLst xmlns:a="http://schemas.openxmlformats.org/drawingml/2006/main">
+              <a:ext uri="{FF2B5EF4-FFF2-40B4-BE49-F238E27FC236}">
+                <a16:creationId xmlns:a16="http://schemas.microsoft.com/office/drawing/2014/main" id="{A687EDFF-66A9-4061-B5E0-1C1E31C509F3}"/>
               </a:ext>
             </a:extLst>
           </p:cNvPr>
@@ -8726,17 +8504,17 @@
                 <a:ea typeface="Noto Sans"/>
                 <a:cs typeface="Noto Sans"/>
               </a:rPr>
-              <a:t>Три попытки завершают op_101</a:t>
-            </a:r>
-          </a:p>
-        </p:txBody>
-      </p:sp>
-      <p:sp>
-        <p:nvSpPr>
-          <p:cNvPr id="6" name="">
-            <a:extLst xmlns:a="http://schemas.openxmlformats.org/drawingml/2006/main">
-              <a:ext uri="{FF2B5EF4-FFF2-40B4-BE49-F238E27FC236}">
-                <a16:creationId xmlns:a16="http://schemas.microsoft.com/office/drawing/2014/main" id="{499AE165-5147-47CF-9040-E532DCD8B705}"/>
+              <a:t>Две попытки завершают op_101</a:t>
+            </a:r>
+          </a:p>
+        </p:txBody>
+      </p:sp>
+      <p:sp>
+        <p:nvSpPr>
+          <p:cNvPr id="4" name="">
+            <a:extLst xmlns:a="http://schemas.openxmlformats.org/drawingml/2006/main">
+              <a:ext uri="{FF2B5EF4-FFF2-40B4-BE49-F238E27FC236}">
+                <a16:creationId xmlns:a16="http://schemas.microsoft.com/office/drawing/2014/main" id="{80F129BF-5874-4489-8D2E-90DBCB0403E8}"/>
               </a:ext>
             </a:extLst>
           </p:cNvPr>
@@ -8784,17 +8562,17 @@
                 <a:ea typeface="Noto Sans"/>
                 <a:cs typeface="Noto Sans"/>
               </a:rPr>
-              <a:t>Два сбоя освобождают ресурсы. Третий провайдер одобряет выплату.</a:t>
-            </a:r>
-          </a:p>
-        </p:txBody>
-      </p:sp>
-      <p:sp>
-        <p:nvSpPr>
-          <p:cNvPr id="7" name="">
-            <a:extLst xmlns:a="http://schemas.openxmlformats.org/drawingml/2006/main">
-              <a:ext uri="{FF2B5EF4-FFF2-40B4-BE49-F238E27FC236}">
-                <a16:creationId xmlns:a16="http://schemas.microsoft.com/office/drawing/2014/main" id="{CE2E6EED-DD22-4546-AD5F-A7905C287869}"/>
+              <a:t>Первый сбой освобождает ресурсы. Следующий провайдер получает новый расчёт.</a:t>
+            </a:r>
+          </a:p>
+        </p:txBody>
+      </p:sp>
+      <p:sp>
+        <p:nvSpPr>
+          <p:cNvPr id="5" name="">
+            <a:extLst xmlns:a="http://schemas.openxmlformats.org/drawingml/2006/main">
+              <a:ext uri="{FF2B5EF4-FFF2-40B4-BE49-F238E27FC236}">
+                <a16:creationId xmlns:a16="http://schemas.microsoft.com/office/drawing/2014/main" id="{48B93010-0F92-4D28-9C11-479433C33D3D}"/>
               </a:ext>
             </a:extLst>
           </p:cNvPr>
@@ -8822,21 +8600,21 @@
       </p:sp>
       <p:sp>
         <p:nvSpPr>
-          <p:cNvPr id="8" name="">
-            <a:extLst xmlns:a="http://schemas.openxmlformats.org/drawingml/2006/main">
-              <a:ext uri="{FF2B5EF4-FFF2-40B4-BE49-F238E27FC236}">
-                <a16:creationId xmlns:a16="http://schemas.microsoft.com/office/drawing/2014/main" id="{E129ECE6-15D8-447C-AC7B-378AD7D8045E}"/>
-              </a:ext>
-            </a:extLst>
-          </p:cNvPr>
-          <p:cNvSpPr>
-            <a:spLocks xmlns:a="http://schemas.openxmlformats.org/drawingml/2006/main" noGrp="1"/>
-          </p:cNvSpPr>
-          <p:nvPr/>
-        </p:nvSpPr>
-        <p:spPr>
-          <a:xfrm xmlns:a="http://schemas.openxmlformats.org/drawingml/2006/main">
-            <a:off x="800100" y="2114550"/>
+          <p:cNvPr id="6" name="">
+            <a:extLst xmlns:a="http://schemas.openxmlformats.org/drawingml/2006/main">
+              <a:ext uri="{FF2B5EF4-FFF2-40B4-BE49-F238E27FC236}">
+                <a16:creationId xmlns:a16="http://schemas.microsoft.com/office/drawing/2014/main" id="{9410B6E7-2FB6-4687-9F78-86DCA3AE3917}"/>
+              </a:ext>
+            </a:extLst>
+          </p:cNvPr>
+          <p:cNvSpPr>
+            <a:spLocks xmlns:a="http://schemas.openxmlformats.org/drawingml/2006/main" noGrp="1"/>
+          </p:cNvSpPr>
+          <p:nvPr/>
+        </p:nvSpPr>
+        <p:spPr>
+          <a:xfrm xmlns:a="http://schemas.openxmlformats.org/drawingml/2006/main">
+            <a:off x="1905000" y="2114550"/>
             <a:ext cx="2095500" cy="228600"/>
           </a:xfrm>
           <a:prstGeom xmlns:a="http://schemas.openxmlformats.org/drawingml/2006/main" prst="rect">
@@ -8857,7 +8635,7 @@
             <a:pPr algn="ctr">
               <a:defRPr sz="1125" b="1">
                 <a:solidFill>
-                  <a:srgbClr val="B84943"/>
+                  <a:srgbClr val="C87912"/>
                 </a:solidFill>
                 <a:latin typeface="Noto Sans"/>
                 <a:ea typeface="Noto Sans"/>
@@ -8867,7 +8645,7 @@
             <a:r>
               <a:rPr sz="1125" b="1">
                 <a:solidFill>
-                  <a:srgbClr val="B84943"/>
+                  <a:srgbClr val="C87912"/>
                 </a:solidFill>
                 <a:latin typeface="Noto Sans"/>
                 <a:ea typeface="Noto Sans"/>
@@ -8880,21 +8658,21 @@
       </p:sp>
       <p:sp>
         <p:nvSpPr>
-          <p:cNvPr id="9" name="">
-            <a:extLst xmlns:a="http://schemas.openxmlformats.org/drawingml/2006/main">
-              <a:ext uri="{FF2B5EF4-FFF2-40B4-BE49-F238E27FC236}">
-                <a16:creationId xmlns:a16="http://schemas.microsoft.com/office/drawing/2014/main" id="{C24F13B7-A8A1-49D2-95A5-DC691A74601F}"/>
-              </a:ext>
-            </a:extLst>
-          </p:cNvPr>
-          <p:cNvSpPr>
-            <a:spLocks xmlns:a="http://schemas.openxmlformats.org/drawingml/2006/main" noGrp="1"/>
-          </p:cNvSpPr>
-          <p:nvPr/>
-        </p:nvSpPr>
-        <p:spPr>
-          <a:xfrm xmlns:a="http://schemas.openxmlformats.org/drawingml/2006/main">
-            <a:off x="609600" y="2381250"/>
+          <p:cNvPr id="7" name="">
+            <a:extLst xmlns:a="http://schemas.openxmlformats.org/drawingml/2006/main">
+              <a:ext uri="{FF2B5EF4-FFF2-40B4-BE49-F238E27FC236}">
+                <a16:creationId xmlns:a16="http://schemas.microsoft.com/office/drawing/2014/main" id="{6DEFF331-3CC5-4631-90C1-ED50745BAFE8}"/>
+              </a:ext>
+            </a:extLst>
+          </p:cNvPr>
+          <p:cNvSpPr>
+            <a:spLocks xmlns:a="http://schemas.openxmlformats.org/drawingml/2006/main" noGrp="1"/>
+          </p:cNvSpPr>
+          <p:nvPr/>
+        </p:nvSpPr>
+        <p:spPr>
+          <a:xfrm xmlns:a="http://schemas.openxmlformats.org/drawingml/2006/main">
+            <a:off x="1714500" y="2381250"/>
             <a:ext cx="2476500" cy="361950"/>
           </a:xfrm>
           <a:prstGeom xmlns:a="http://schemas.openxmlformats.org/drawingml/2006/main" prst="rect">
@@ -8938,228 +8716,21 @@
       </p:sp>
       <p:sp>
         <p:nvSpPr>
-          <p:cNvPr id="10" name="">
-            <a:extLst xmlns:a="http://schemas.openxmlformats.org/drawingml/2006/main">
-              <a:ext uri="{FF2B5EF4-FFF2-40B4-BE49-F238E27FC236}">
-                <a16:creationId xmlns:a16="http://schemas.microsoft.com/office/drawing/2014/main" id="{2469D26C-53DA-476F-A68B-1215089EC289}"/>
-              </a:ext>
-            </a:extLst>
-          </p:cNvPr>
-          <p:cNvSpPr>
-            <a:spLocks xmlns:a="http://schemas.openxmlformats.org/drawingml/2006/main" noGrp="1"/>
-          </p:cNvSpPr>
-          <p:nvPr/>
-        </p:nvSpPr>
-        <p:spPr>
-          <a:xfrm xmlns:a="http://schemas.openxmlformats.org/drawingml/2006/main">
-            <a:off x="1695450" y="2924175"/>
-            <a:ext cx="304800" cy="304800"/>
-          </a:xfrm>
-          <a:prstGeom xmlns:a="http://schemas.openxmlformats.org/drawingml/2006/main" prst="ellipse">
-            <a:avLst/>
-          </a:prstGeom>
-          <a:solidFill xmlns:a="http://schemas.openxmlformats.org/drawingml/2006/main">
-            <a:srgbClr val="B84943"/>
-          </a:solidFill>
-          <a:ln xmlns:a="http://schemas.openxmlformats.org/drawingml/2006/main" w="0">
-            <a:solidFill>
-              <a:srgbClr val="B84943"/>
-            </a:solidFill>
-            <a:prstDash val="solid"/>
-          </a:ln>
-        </p:spPr>
-      </p:sp>
-      <p:sp>
-        <p:nvSpPr>
-          <p:cNvPr id="11" name="">
-            <a:extLst xmlns:a="http://schemas.openxmlformats.org/drawingml/2006/main">
-              <a:ext uri="{FF2B5EF4-FFF2-40B4-BE49-F238E27FC236}">
-                <a16:creationId xmlns:a16="http://schemas.microsoft.com/office/drawing/2014/main" id="{A9269B58-5A87-4A9B-80F7-FE5DFA943220}"/>
-              </a:ext>
-            </a:extLst>
-          </p:cNvPr>
-          <p:cNvSpPr>
-            <a:spLocks xmlns:a="http://schemas.openxmlformats.org/drawingml/2006/main" noGrp="1"/>
-          </p:cNvSpPr>
-          <p:nvPr/>
-        </p:nvSpPr>
-        <p:spPr>
-          <a:xfrm xmlns:a="http://schemas.openxmlformats.org/drawingml/2006/main">
-            <a:off x="609600" y="3352800"/>
-            <a:ext cx="2476500" cy="266700"/>
-          </a:xfrm>
-          <a:prstGeom xmlns:a="http://schemas.openxmlformats.org/drawingml/2006/main" prst="rect">
-            <a:avLst/>
-          </a:prstGeom>
-          <a:noFill xmlns:a="http://schemas.openxmlformats.org/drawingml/2006/main"/>
-          <a:ln xmlns:a="http://schemas.openxmlformats.org/drawingml/2006/main" w="0">
-            <a:noFill/>
-            <a:prstDash val="solid"/>
-          </a:ln>
-        </p:spPr>
-        <p:txBody>
-          <a:bodyPr xmlns:a="http://schemas.openxmlformats.org/drawingml/2006/main" anchor="ctr">
-            <a:noAutofit/>
-          </a:bodyPr>
-          <a:lstStyle xmlns:a="http://schemas.openxmlformats.org/drawingml/2006/main"/>
-          <a:p xmlns:a="http://schemas.openxmlformats.org/drawingml/2006/main">
-            <a:pPr algn="ctr">
-              <a:defRPr sz="1425" b="1">
-                <a:solidFill>
-                  <a:srgbClr val="B84943"/>
-                </a:solidFill>
-                <a:latin typeface="Noto Sans"/>
-                <a:ea typeface="Noto Sans"/>
-                <a:cs typeface="Noto Sans"/>
-              </a:defRPr>
-            </a:pPr>
-            <a:r>
-              <a:rPr sz="1425" b="1">
-                <a:solidFill>
-                  <a:srgbClr val="B84943"/>
-                </a:solidFill>
-                <a:latin typeface="Noto Sans"/>
-                <a:ea typeface="Noto Sans"/>
-                <a:cs typeface="Noto Sans"/>
-              </a:rPr>
-              <a:t>rejected · 5 с</a:t>
-            </a:r>
-          </a:p>
-        </p:txBody>
-      </p:sp>
-      <p:sp>
-        <p:nvSpPr>
-          <p:cNvPr id="12" name="">
-            <a:extLst xmlns:a="http://schemas.openxmlformats.org/drawingml/2006/main">
-              <a:ext uri="{FF2B5EF4-FFF2-40B4-BE49-F238E27FC236}">
-                <a16:creationId xmlns:a16="http://schemas.microsoft.com/office/drawing/2014/main" id="{08333AC1-6AEB-45B3-99DC-2CB7ED4ED7FC}"/>
-              </a:ext>
-            </a:extLst>
-          </p:cNvPr>
-          <p:cNvSpPr>
-            <a:spLocks xmlns:a="http://schemas.openxmlformats.org/drawingml/2006/main" noGrp="1"/>
-          </p:cNvSpPr>
-          <p:nvPr/>
-        </p:nvSpPr>
-        <p:spPr>
-          <a:xfrm xmlns:a="http://schemas.openxmlformats.org/drawingml/2006/main">
-            <a:off x="5048250" y="2114550"/>
-            <a:ext cx="2095500" cy="228600"/>
-          </a:xfrm>
-          <a:prstGeom xmlns:a="http://schemas.openxmlformats.org/drawingml/2006/main" prst="rect">
-            <a:avLst/>
-          </a:prstGeom>
-          <a:noFill xmlns:a="http://schemas.openxmlformats.org/drawingml/2006/main"/>
-          <a:ln xmlns:a="http://schemas.openxmlformats.org/drawingml/2006/main" w="0">
-            <a:noFill/>
-            <a:prstDash val="solid"/>
-          </a:ln>
-        </p:spPr>
-        <p:txBody>
-          <a:bodyPr xmlns:a="http://schemas.openxmlformats.org/drawingml/2006/main" anchor="ctr">
-            <a:noAutofit/>
-          </a:bodyPr>
-          <a:lstStyle xmlns:a="http://schemas.openxmlformats.org/drawingml/2006/main"/>
-          <a:p xmlns:a="http://schemas.openxmlformats.org/drawingml/2006/main">
-            <a:pPr algn="ctr">
-              <a:defRPr sz="1125" b="1">
-                <a:solidFill>
-                  <a:srgbClr val="C87912"/>
-                </a:solidFill>
-                <a:latin typeface="Noto Sans"/>
-                <a:ea typeface="Noto Sans"/>
-                <a:cs typeface="Noto Sans"/>
-              </a:defRPr>
-            </a:pPr>
-            <a:r>
-              <a:rPr sz="1125" b="1">
-                <a:solidFill>
-                  <a:srgbClr val="C87912"/>
-                </a:solidFill>
-                <a:latin typeface="Noto Sans"/>
-                <a:ea typeface="Noto Sans"/>
-                <a:cs typeface="Noto Sans"/>
-              </a:rPr>
-              <a:t>ПОПЫТКА 2</a:t>
-            </a:r>
-          </a:p>
-        </p:txBody>
-      </p:sp>
-      <p:sp>
-        <p:nvSpPr>
-          <p:cNvPr id="13" name="">
-            <a:extLst xmlns:a="http://schemas.openxmlformats.org/drawingml/2006/main">
-              <a:ext uri="{FF2B5EF4-FFF2-40B4-BE49-F238E27FC236}">
-                <a16:creationId xmlns:a16="http://schemas.microsoft.com/office/drawing/2014/main" id="{DEF055A0-ED22-49BC-87F6-3612D7EC9094}"/>
-              </a:ext>
-            </a:extLst>
-          </p:cNvPr>
-          <p:cNvSpPr>
-            <a:spLocks xmlns:a="http://schemas.openxmlformats.org/drawingml/2006/main" noGrp="1"/>
-          </p:cNvSpPr>
-          <p:nvPr/>
-        </p:nvSpPr>
-        <p:spPr>
-          <a:xfrm xmlns:a="http://schemas.openxmlformats.org/drawingml/2006/main">
-            <a:off x="4857750" y="2381250"/>
-            <a:ext cx="2476500" cy="361950"/>
-          </a:xfrm>
-          <a:prstGeom xmlns:a="http://schemas.openxmlformats.org/drawingml/2006/main" prst="rect">
-            <a:avLst/>
-          </a:prstGeom>
-          <a:noFill xmlns:a="http://schemas.openxmlformats.org/drawingml/2006/main"/>
-          <a:ln xmlns:a="http://schemas.openxmlformats.org/drawingml/2006/main" w="0">
-            <a:noFill/>
-            <a:prstDash val="solid"/>
-          </a:ln>
-        </p:spPr>
-        <p:txBody>
-          <a:bodyPr xmlns:a="http://schemas.openxmlformats.org/drawingml/2006/main" anchor="ctr">
-            <a:noAutofit/>
-          </a:bodyPr>
-          <a:lstStyle xmlns:a="http://schemas.openxmlformats.org/drawingml/2006/main"/>
-          <a:p xmlns:a="http://schemas.openxmlformats.org/drawingml/2006/main">
-            <a:pPr algn="ctr">
-              <a:defRPr sz="2100" b="1">
-                <a:solidFill>
-                  <a:srgbClr val="14251F"/>
-                </a:solidFill>
-                <a:latin typeface="Noto Sans"/>
-                <a:ea typeface="Noto Sans"/>
-                <a:cs typeface="Noto Sans"/>
-              </a:defRPr>
-            </a:pPr>
-            <a:r>
-              <a:rPr sz="2100" b="1">
-                <a:solidFill>
-                  <a:srgbClr val="14251F"/>
-                </a:solidFill>
-                <a:latin typeface="Noto Sans"/>
-                <a:ea typeface="Noto Sans"/>
-                <a:cs typeface="Noto Sans"/>
-              </a:rPr>
-              <a:t>payflow</a:t>
-            </a:r>
-          </a:p>
-        </p:txBody>
-      </p:sp>
-      <p:sp>
-        <p:nvSpPr>
-          <p:cNvPr id="14" name="">
-            <a:extLst xmlns:a="http://schemas.openxmlformats.org/drawingml/2006/main">
-              <a:ext uri="{FF2B5EF4-FFF2-40B4-BE49-F238E27FC236}">
-                <a16:creationId xmlns:a16="http://schemas.microsoft.com/office/drawing/2014/main" id="{C0DBE394-0699-4EC6-8879-CCCAE242A4CB}"/>
-              </a:ext>
-            </a:extLst>
-          </p:cNvPr>
-          <p:cNvSpPr>
-            <a:spLocks xmlns:a="http://schemas.openxmlformats.org/drawingml/2006/main" noGrp="1"/>
-          </p:cNvSpPr>
-          <p:nvPr/>
-        </p:nvSpPr>
-        <p:spPr>
-          <a:xfrm xmlns:a="http://schemas.openxmlformats.org/drawingml/2006/main">
-            <a:off x="5943600" y="2924175"/>
+          <p:cNvPr id="8" name="">
+            <a:extLst xmlns:a="http://schemas.openxmlformats.org/drawingml/2006/main">
+              <a:ext uri="{FF2B5EF4-FFF2-40B4-BE49-F238E27FC236}">
+                <a16:creationId xmlns:a16="http://schemas.microsoft.com/office/drawing/2014/main" id="{325A9256-38CD-42B2-877E-27D0C813E904}"/>
+              </a:ext>
+            </a:extLst>
+          </p:cNvPr>
+          <p:cNvSpPr>
+            <a:spLocks xmlns:a="http://schemas.openxmlformats.org/drawingml/2006/main" noGrp="1"/>
+          </p:cNvSpPr>
+          <p:nvPr/>
+        </p:nvSpPr>
+        <p:spPr>
+          <a:xfrm xmlns:a="http://schemas.openxmlformats.org/drawingml/2006/main">
+            <a:off x="2800350" y="2924175"/>
             <a:ext cx="304800" cy="304800"/>
           </a:xfrm>
           <a:prstGeom xmlns:a="http://schemas.openxmlformats.org/drawingml/2006/main" prst="ellipse">
@@ -9178,21 +8749,21 @@
       </p:sp>
       <p:sp>
         <p:nvSpPr>
-          <p:cNvPr id="15" name="">
-            <a:extLst xmlns:a="http://schemas.openxmlformats.org/drawingml/2006/main">
-              <a:ext uri="{FF2B5EF4-FFF2-40B4-BE49-F238E27FC236}">
-                <a16:creationId xmlns:a16="http://schemas.microsoft.com/office/drawing/2014/main" id="{04477087-FC54-4648-BF71-2B4AA6042B3F}"/>
-              </a:ext>
-            </a:extLst>
-          </p:cNvPr>
-          <p:cNvSpPr>
-            <a:spLocks xmlns:a="http://schemas.openxmlformats.org/drawingml/2006/main" noGrp="1"/>
-          </p:cNvSpPr>
-          <p:nvPr/>
-        </p:nvSpPr>
-        <p:spPr>
-          <a:xfrm xmlns:a="http://schemas.openxmlformats.org/drawingml/2006/main">
-            <a:off x="4857750" y="3352800"/>
+          <p:cNvPr id="9" name="">
+            <a:extLst xmlns:a="http://schemas.openxmlformats.org/drawingml/2006/main">
+              <a:ext uri="{FF2B5EF4-FFF2-40B4-BE49-F238E27FC236}">
+                <a16:creationId xmlns:a16="http://schemas.microsoft.com/office/drawing/2014/main" id="{A8E2FD00-0261-4B11-A9D0-9BFE8EC29946}"/>
+              </a:ext>
+            </a:extLst>
+          </p:cNvPr>
+          <p:cNvSpPr>
+            <a:spLocks xmlns:a="http://schemas.openxmlformats.org/drawingml/2006/main" noGrp="1"/>
+          </p:cNvSpPr>
+          <p:nvPr/>
+        </p:nvSpPr>
+        <p:spPr>
+          <a:xfrm xmlns:a="http://schemas.openxmlformats.org/drawingml/2006/main">
+            <a:off x="1714500" y="3352800"/>
             <a:ext cx="2476500" cy="266700"/>
           </a:xfrm>
           <a:prstGeom xmlns:a="http://schemas.openxmlformats.org/drawingml/2006/main" prst="rect">
@@ -9229,28 +8800,28 @@
                 <a:ea typeface="Noto Sans"/>
                 <a:cs typeface="Noto Sans"/>
               </a:rPr>
-              <a:t>expired · 20 с</a:t>
-            </a:r>
-          </a:p>
-        </p:txBody>
-      </p:sp>
-      <p:sp>
-        <p:nvSpPr>
-          <p:cNvPr id="16" name="">
-            <a:extLst xmlns:a="http://schemas.openxmlformats.org/drawingml/2006/main">
-              <a:ext uri="{FF2B5EF4-FFF2-40B4-BE49-F238E27FC236}">
-                <a16:creationId xmlns:a16="http://schemas.microsoft.com/office/drawing/2014/main" id="{1BF9168A-A1BF-4AFA-B3A2-C893A280130E}"/>
-              </a:ext>
-            </a:extLst>
-          </p:cNvPr>
-          <p:cNvSpPr>
-            <a:spLocks xmlns:a="http://schemas.openxmlformats.org/drawingml/2006/main" noGrp="1"/>
-          </p:cNvSpPr>
-          <p:nvPr/>
-        </p:nvSpPr>
-        <p:spPr>
-          <a:xfrm xmlns:a="http://schemas.openxmlformats.org/drawingml/2006/main">
-            <a:off x="9296400" y="2114550"/>
+              <a:t>expired · 47 с</a:t>
+            </a:r>
+          </a:p>
+        </p:txBody>
+      </p:sp>
+      <p:sp>
+        <p:nvSpPr>
+          <p:cNvPr id="10" name="">
+            <a:extLst xmlns:a="http://schemas.openxmlformats.org/drawingml/2006/main">
+              <a:ext uri="{FF2B5EF4-FFF2-40B4-BE49-F238E27FC236}">
+                <a16:creationId xmlns:a16="http://schemas.microsoft.com/office/drawing/2014/main" id="{C3E79D31-EFB9-4B35-AA64-B1A3679A4A3F}"/>
+              </a:ext>
+            </a:extLst>
+          </p:cNvPr>
+          <p:cNvSpPr>
+            <a:spLocks xmlns:a="http://schemas.openxmlformats.org/drawingml/2006/main" noGrp="1"/>
+          </p:cNvSpPr>
+          <p:nvPr/>
+        </p:nvSpPr>
+        <p:spPr>
+          <a:xfrm xmlns:a="http://schemas.openxmlformats.org/drawingml/2006/main">
+            <a:off x="8191500" y="2114550"/>
             <a:ext cx="2095500" cy="228600"/>
           </a:xfrm>
           <a:prstGeom xmlns:a="http://schemas.openxmlformats.org/drawingml/2006/main" prst="rect">
@@ -9287,28 +8858,28 @@
                 <a:ea typeface="Noto Sans"/>
                 <a:cs typeface="Noto Sans"/>
               </a:rPr>
-              <a:t>ПОПЫТКА 3</a:t>
-            </a:r>
-          </a:p>
-        </p:txBody>
-      </p:sp>
-      <p:sp>
-        <p:nvSpPr>
-          <p:cNvPr id="17" name="">
-            <a:extLst xmlns:a="http://schemas.openxmlformats.org/drawingml/2006/main">
-              <a:ext uri="{FF2B5EF4-FFF2-40B4-BE49-F238E27FC236}">
-                <a16:creationId xmlns:a16="http://schemas.microsoft.com/office/drawing/2014/main" id="{20BC2ED5-EC2A-47E4-8E0F-F671F677D7CA}"/>
-              </a:ext>
-            </a:extLst>
-          </p:cNvPr>
-          <p:cNvSpPr>
-            <a:spLocks xmlns:a="http://schemas.openxmlformats.org/drawingml/2006/main" noGrp="1"/>
-          </p:cNvSpPr>
-          <p:nvPr/>
-        </p:nvSpPr>
-        <p:spPr>
-          <a:xfrm xmlns:a="http://schemas.openxmlformats.org/drawingml/2006/main">
-            <a:off x="9105900" y="2381250"/>
+              <a:t>ПОПЫТКА 2</a:t>
+            </a:r>
+          </a:p>
+        </p:txBody>
+      </p:sp>
+      <p:sp>
+        <p:nvSpPr>
+          <p:cNvPr id="11" name="">
+            <a:extLst xmlns:a="http://schemas.openxmlformats.org/drawingml/2006/main">
+              <a:ext uri="{FF2B5EF4-FFF2-40B4-BE49-F238E27FC236}">
+                <a16:creationId xmlns:a16="http://schemas.microsoft.com/office/drawing/2014/main" id="{952ACC1E-C497-45F7-BD35-03311318CC77}"/>
+              </a:ext>
+            </a:extLst>
+          </p:cNvPr>
+          <p:cNvSpPr>
+            <a:spLocks xmlns:a="http://schemas.openxmlformats.org/drawingml/2006/main" noGrp="1"/>
+          </p:cNvSpPr>
+          <p:nvPr/>
+        </p:nvSpPr>
+        <p:spPr>
+          <a:xfrm xmlns:a="http://schemas.openxmlformats.org/drawingml/2006/main">
+            <a:off x="8001000" y="2381250"/>
             <a:ext cx="2476500" cy="361950"/>
           </a:xfrm>
           <a:prstGeom xmlns:a="http://schemas.openxmlformats.org/drawingml/2006/main" prst="rect">
@@ -9345,28 +8916,28 @@
                 <a:ea typeface="Noto Sans"/>
                 <a:cs typeface="Noto Sans"/>
               </a:rPr>
-              <a:t>quickpay</a:t>
-            </a:r>
-          </a:p>
-        </p:txBody>
-      </p:sp>
-      <p:sp>
-        <p:nvSpPr>
-          <p:cNvPr id="18" name="">
-            <a:extLst xmlns:a="http://schemas.openxmlformats.org/drawingml/2006/main">
-              <a:ext uri="{FF2B5EF4-FFF2-40B4-BE49-F238E27FC236}">
-                <a16:creationId xmlns:a16="http://schemas.microsoft.com/office/drawing/2014/main" id="{0B3A3AF7-3806-4AF3-A1C8-10810036262D}"/>
-              </a:ext>
-            </a:extLst>
-          </p:cNvPr>
-          <p:cNvSpPr>
-            <a:spLocks xmlns:a="http://schemas.openxmlformats.org/drawingml/2006/main" noGrp="1"/>
-          </p:cNvSpPr>
-          <p:nvPr/>
-        </p:nvSpPr>
-        <p:spPr>
-          <a:xfrm xmlns:a="http://schemas.openxmlformats.org/drawingml/2006/main">
-            <a:off x="10191750" y="2924175"/>
+              <a:t>payflow</a:t>
+            </a:r>
+          </a:p>
+        </p:txBody>
+      </p:sp>
+      <p:sp>
+        <p:nvSpPr>
+          <p:cNvPr id="12" name="">
+            <a:extLst xmlns:a="http://schemas.openxmlformats.org/drawingml/2006/main">
+              <a:ext uri="{FF2B5EF4-FFF2-40B4-BE49-F238E27FC236}">
+                <a16:creationId xmlns:a16="http://schemas.microsoft.com/office/drawing/2014/main" id="{2BB9A077-75AC-4416-86AA-8E831E5D990F}"/>
+              </a:ext>
+            </a:extLst>
+          </p:cNvPr>
+          <p:cNvSpPr>
+            <a:spLocks xmlns:a="http://schemas.openxmlformats.org/drawingml/2006/main" noGrp="1"/>
+          </p:cNvSpPr>
+          <p:nvPr/>
+        </p:nvSpPr>
+        <p:spPr>
+          <a:xfrm xmlns:a="http://schemas.openxmlformats.org/drawingml/2006/main">
+            <a:off x="9086850" y="2924175"/>
             <a:ext cx="304800" cy="304800"/>
           </a:xfrm>
           <a:prstGeom xmlns:a="http://schemas.openxmlformats.org/drawingml/2006/main" prst="ellipse">
@@ -9385,21 +8956,21 @@
       </p:sp>
       <p:sp>
         <p:nvSpPr>
-          <p:cNvPr id="19" name="">
-            <a:extLst xmlns:a="http://schemas.openxmlformats.org/drawingml/2006/main">
-              <a:ext uri="{FF2B5EF4-FFF2-40B4-BE49-F238E27FC236}">
-                <a16:creationId xmlns:a16="http://schemas.microsoft.com/office/drawing/2014/main" id="{3966208B-ADEA-489F-8145-3BCD494E8758}"/>
-              </a:ext>
-            </a:extLst>
-          </p:cNvPr>
-          <p:cNvSpPr>
-            <a:spLocks xmlns:a="http://schemas.openxmlformats.org/drawingml/2006/main" noGrp="1"/>
-          </p:cNvSpPr>
-          <p:nvPr/>
-        </p:nvSpPr>
-        <p:spPr>
-          <a:xfrm xmlns:a="http://schemas.openxmlformats.org/drawingml/2006/main">
-            <a:off x="9105900" y="3352800"/>
+          <p:cNvPr id="13" name="">
+            <a:extLst xmlns:a="http://schemas.openxmlformats.org/drawingml/2006/main">
+              <a:ext uri="{FF2B5EF4-FFF2-40B4-BE49-F238E27FC236}">
+                <a16:creationId xmlns:a16="http://schemas.microsoft.com/office/drawing/2014/main" id="{D8BF5245-C057-45F0-822B-FA7884B579B8}"/>
+              </a:ext>
+            </a:extLst>
+          </p:cNvPr>
+          <p:cNvSpPr>
+            <a:spLocks xmlns:a="http://schemas.openxmlformats.org/drawingml/2006/main" noGrp="1"/>
+          </p:cNvSpPr>
+          <p:nvPr/>
+        </p:nvSpPr>
+        <p:spPr>
+          <a:xfrm xmlns:a="http://schemas.openxmlformats.org/drawingml/2006/main">
+            <a:off x="8001000" y="3352800"/>
             <a:ext cx="2476500" cy="266700"/>
           </a:xfrm>
           <a:prstGeom xmlns:a="http://schemas.openxmlformats.org/drawingml/2006/main" prst="rect">
@@ -9436,50 +9007,24 @@
                 <a:ea typeface="Noto Sans"/>
                 <a:cs typeface="Noto Sans"/>
               </a:rPr>
-              <a:t>approved · 25 с</a:t>
+              <a:t>approved · 55 с</a:t>
             </a:r>
           </a:p>
         </p:txBody>
       </p:sp>
       <p:cxnSp>
         <p:nvCxnSpPr>
-          <p:cNvPr id="52" name=""/>
+          <p:cNvPr id="39" name=""/>
           <p:cNvCxnSpPr>
-            <a:stCxn xmlns:a="http://schemas.openxmlformats.org/drawingml/2006/main" id="10" idx="6"/>
-            <a:endCxn xmlns:a="http://schemas.openxmlformats.org/drawingml/2006/main" id="14" idx="2"/>
+            <a:stCxn xmlns:a="http://schemas.openxmlformats.org/drawingml/2006/main" id="8" idx="6"/>
+            <a:endCxn xmlns:a="http://schemas.openxmlformats.org/drawingml/2006/main" id="12" idx="2"/>
           </p:cNvCxnSpPr>
           <p:nvPr/>
         </p:nvCxnSpPr>
         <p:spPr>
           <a:xfrm xmlns:a="http://schemas.openxmlformats.org/drawingml/2006/main">
-            <a:off x="2000250" y="3076575"/>
-            <a:ext cx="3943350" cy="0"/>
-          </a:xfrm>
-          <a:prstGeom xmlns:a="http://schemas.openxmlformats.org/drawingml/2006/main" prst="straightConnector1">
-            <a:avLst/>
-          </a:prstGeom>
-          <a:ln xmlns:a="http://schemas.openxmlformats.org/drawingml/2006/main" w="19050">
-            <a:solidFill>
-              <a:srgbClr val="B84943"/>
-            </a:solidFill>
-            <a:prstDash val="solid"/>
-            <a:tailEnd type="triangle" w="sm" len="sm"/>
-          </a:ln>
-        </p:spPr>
-      </p:cxnSp>
-      <p:cxnSp>
-        <p:nvCxnSpPr>
-          <p:cNvPr id="53" name=""/>
-          <p:cNvCxnSpPr>
-            <a:stCxn xmlns:a="http://schemas.openxmlformats.org/drawingml/2006/main" id="14" idx="6"/>
-            <a:endCxn xmlns:a="http://schemas.openxmlformats.org/drawingml/2006/main" id="18" idx="2"/>
-          </p:cNvCxnSpPr>
-          <p:nvPr/>
-        </p:nvCxnSpPr>
-        <p:spPr>
-          <a:xfrm xmlns:a="http://schemas.openxmlformats.org/drawingml/2006/main">
-            <a:off x="6248400" y="3076575"/>
-            <a:ext cx="3943350" cy="0"/>
+            <a:off x="3105150" y="3076575"/>
+            <a:ext cx="5981700" cy="0"/>
           </a:xfrm>
           <a:prstGeom xmlns:a="http://schemas.openxmlformats.org/drawingml/2006/main" prst="straightConnector1">
             <a:avLst/>
@@ -9495,7 +9040,7 @@
       </p:cxnSp>
       <p:graphicFrame>
         <p:nvGraphicFramePr>
-          <p:cNvPr id="54" name=""/>
+          <p:cNvPr id="40" name=""/>
           <p:cNvGraphicFramePr/>
           <p:nvPr/>
         </p:nvGraphicFramePr>
@@ -9604,7 +9149,7 @@
                           <a:ea typeface="Noto Sans"/>
                           <a:cs typeface="Noto Sans"/>
                         </a:rPr>
-                        <a:t>После отказа</a:t>
+                        <a:t>После сбоя</a:t>
                       </a:r>
                     </a:p>
                   </a:txBody>
@@ -10029,10 +9574,10 @@
       </p:graphicFrame>
       <p:sp>
         <p:nvSpPr>
-          <p:cNvPr id="23" name="">
-            <a:extLst xmlns:a="http://schemas.openxmlformats.org/drawingml/2006/main">
-              <a:ext uri="{FF2B5EF4-FFF2-40B4-BE49-F238E27FC236}">
-                <a16:creationId xmlns:a16="http://schemas.microsoft.com/office/drawing/2014/main" id="{873AC7D7-F7E4-485D-8853-F876DC738736}"/>
+          <p:cNvPr id="16" name="">
+            <a:extLst xmlns:a="http://schemas.openxmlformats.org/drawingml/2006/main">
+              <a:ext uri="{FF2B5EF4-FFF2-40B4-BE49-F238E27FC236}">
+                <a16:creationId xmlns:a16="http://schemas.microsoft.com/office/drawing/2014/main" id="{02D9F4B6-DC82-4334-80C8-27CBA0017A3C}"/>
               </a:ext>
             </a:extLst>
           </p:cNvPr>
@@ -10060,10 +9605,10 @@
       </p:sp>
       <p:sp>
         <p:nvSpPr>
-          <p:cNvPr id="24" name="">
-            <a:extLst xmlns:a="http://schemas.openxmlformats.org/drawingml/2006/main">
-              <a:ext uri="{FF2B5EF4-FFF2-40B4-BE49-F238E27FC236}">
-                <a16:creationId xmlns:a16="http://schemas.microsoft.com/office/drawing/2014/main" id="{5C48CE15-AF48-45FA-9099-9DC3547556D4}"/>
+          <p:cNvPr id="17" name="">
+            <a:extLst xmlns:a="http://schemas.openxmlformats.org/drawingml/2006/main">
+              <a:ext uri="{FF2B5EF4-FFF2-40B4-BE49-F238E27FC236}">
+                <a16:creationId xmlns:a16="http://schemas.microsoft.com/office/drawing/2014/main" id="{CE83C61F-4A1B-4E0E-AB95-3D65B9AA9BF0}"/>
               </a:ext>
             </a:extLst>
           </p:cNvPr>
@@ -10111,17 +9656,17 @@
                 <a:ea typeface="Noto Sans"/>
                 <a:cs typeface="Noto Sans"/>
               </a:rPr>
-              <a:t>50 с</a:t>
-            </a:r>
-          </a:p>
-        </p:txBody>
-      </p:sp>
-      <p:sp>
-        <p:nvSpPr>
-          <p:cNvPr id="25" name="">
-            <a:extLst xmlns:a="http://schemas.openxmlformats.org/drawingml/2006/main">
-              <a:ext uri="{FF2B5EF4-FFF2-40B4-BE49-F238E27FC236}">
-                <a16:creationId xmlns:a16="http://schemas.microsoft.com/office/drawing/2014/main" id="{3517ACDD-E7FC-440F-B6BB-878D7A26B104}"/>
+              <a:t>102 с</a:t>
+            </a:r>
+          </a:p>
+        </p:txBody>
+      </p:sp>
+      <p:sp>
+        <p:nvSpPr>
+          <p:cNvPr id="18" name="">
+            <a:extLst xmlns:a="http://schemas.openxmlformats.org/drawingml/2006/main">
+              <a:ext uri="{FF2B5EF4-FFF2-40B4-BE49-F238E27FC236}">
+                <a16:creationId xmlns:a16="http://schemas.microsoft.com/office/drawing/2014/main" id="{B620144F-7622-4059-A529-A21CA14DA5D0}"/>
               </a:ext>
             </a:extLst>
           </p:cNvPr>
@@ -10176,10 +9721,10 @@
       </p:sp>
       <p:sp>
         <p:nvSpPr>
-          <p:cNvPr id="26" name="">
-            <a:extLst xmlns:a="http://schemas.openxmlformats.org/drawingml/2006/main">
-              <a:ext uri="{FF2B5EF4-FFF2-40B4-BE49-F238E27FC236}">
-                <a16:creationId xmlns:a16="http://schemas.microsoft.com/office/drawing/2014/main" id="{CA22385B-6897-4D8F-93E5-8429B2A5FC76}"/>
+          <p:cNvPr id="19" name="">
+            <a:extLst xmlns:a="http://schemas.openxmlformats.org/drawingml/2006/main">
+              <a:ext uri="{FF2B5EF4-FFF2-40B4-BE49-F238E27FC236}">
+                <a16:creationId xmlns:a16="http://schemas.microsoft.com/office/drawing/2014/main" id="{59627588-4784-4C93-BA6F-E31A0E7DC031}"/>
               </a:ext>
             </a:extLst>
           </p:cNvPr>
@@ -10207,10 +9752,10 @@
       </p:sp>
       <p:sp>
         <p:nvSpPr>
-          <p:cNvPr id="27" name="">
-            <a:extLst xmlns:a="http://schemas.openxmlformats.org/drawingml/2006/main">
-              <a:ext uri="{FF2B5EF4-FFF2-40B4-BE49-F238E27FC236}">
-                <a16:creationId xmlns:a16="http://schemas.microsoft.com/office/drawing/2014/main" id="{A735C014-B48A-409F-98E8-6CEC2FB30ECE}"/>
+          <p:cNvPr id="20" name="">
+            <a:extLst xmlns:a="http://schemas.openxmlformats.org/drawingml/2006/main">
+              <a:ext uri="{FF2B5EF4-FFF2-40B4-BE49-F238E27FC236}">
+                <a16:creationId xmlns:a16="http://schemas.microsoft.com/office/drawing/2014/main" id="{D7C5CB93-D111-41BD-B548-0E553624197D}"/>
               </a:ext>
             </a:extLst>
           </p:cNvPr>
@@ -10265,10 +9810,10 @@
       </p:sp>
       <p:sp>
         <p:nvSpPr>
-          <p:cNvPr id="28" name="">
-            <a:extLst xmlns:a="http://schemas.openxmlformats.org/drawingml/2006/main">
-              <a:ext uri="{FF2B5EF4-FFF2-40B4-BE49-F238E27FC236}">
-                <a16:creationId xmlns:a16="http://schemas.microsoft.com/office/drawing/2014/main" id="{BA22E16F-4EA6-4296-A50F-1E585BB7240B}"/>
+          <p:cNvPr id="21" name="">
+            <a:extLst xmlns:a="http://schemas.openxmlformats.org/drawingml/2006/main">
+              <a:ext uri="{FF2B5EF4-FFF2-40B4-BE49-F238E27FC236}">
+                <a16:creationId xmlns:a16="http://schemas.microsoft.com/office/drawing/2014/main" id="{532836B3-F617-4E6D-9A5B-596F17CB0558}"/>
               </a:ext>
             </a:extLst>
           </p:cNvPr>
@@ -10323,10 +9868,10 @@
       </p:sp>
       <p:sp>
         <p:nvSpPr>
-          <p:cNvPr id="29" name="">
-            <a:extLst xmlns:a="http://schemas.openxmlformats.org/drawingml/2006/main">
-              <a:ext uri="{FF2B5EF4-FFF2-40B4-BE49-F238E27FC236}">
-                <a16:creationId xmlns:a16="http://schemas.microsoft.com/office/drawing/2014/main" id="{36F4E8D4-6C77-48C7-AAB9-CA269F6E526B}"/>
+          <p:cNvPr id="22" name="">
+            <a:extLst xmlns:a="http://schemas.openxmlformats.org/drawingml/2006/main">
+              <a:ext uri="{FF2B5EF4-FFF2-40B4-BE49-F238E27FC236}">
+                <a16:creationId xmlns:a16="http://schemas.microsoft.com/office/drawing/2014/main" id="{38033BCB-7EB6-4241-9A2C-B91516082BC4}"/>
               </a:ext>
             </a:extLst>
           </p:cNvPr>
@@ -10374,17 +9919,17 @@
                 <a:ea typeface="Noto Sans"/>
                 <a:cs typeface="Noto Sans"/>
               </a:rPr>
-              <a:t>op_103: Quickpay expired   →   SpacePayments approved</a:t>
-            </a:r>
-          </a:p>
-        </p:txBody>
-      </p:sp>
-      <p:sp>
-        <p:nvSpPr>
-          <p:cNvPr id="30" name="">
-            <a:extLst xmlns:a="http://schemas.openxmlformats.org/drawingml/2006/main">
-              <a:ext uri="{FF2B5EF4-FFF2-40B4-BE49-F238E27FC236}">
-                <a16:creationId xmlns:a16="http://schemas.microsoft.com/office/drawing/2014/main" id="{279B5FFA-6E6B-46E6-9933-EC09D30873A9}"/>
+              <a:t>op_102: Quickpay expired  ·  Payflow rejected  ·  SpacePayments approved</a:t>
+            </a:r>
+          </a:p>
+        </p:txBody>
+      </p:sp>
+      <p:sp>
+        <p:nvSpPr>
+          <p:cNvPr id="23" name="">
+            <a:extLst xmlns:a="http://schemas.openxmlformats.org/drawingml/2006/main">
+              <a:ext uri="{FF2B5EF4-FFF2-40B4-BE49-F238E27FC236}">
+                <a16:creationId xmlns:a16="http://schemas.microsoft.com/office/drawing/2014/main" id="{97BE7E79-5CA1-4C7F-AB36-363ADEB6EF52}"/>
               </a:ext>
             </a:extLst>
           </p:cNvPr>
@@ -10412,10 +9957,10 @@
       </p:sp>
       <p:sp>
         <p:nvSpPr>
-          <p:cNvPr id="31" name="">
-            <a:extLst xmlns:a="http://schemas.openxmlformats.org/drawingml/2006/main">
-              <a:ext uri="{FF2B5EF4-FFF2-40B4-BE49-F238E27FC236}">
-                <a16:creationId xmlns:a16="http://schemas.microsoft.com/office/drawing/2014/main" id="{0AD2FC39-AE16-4C9E-8BC6-2A721D96AB2A}"/>
+          <p:cNvPr id="24" name="">
+            <a:extLst xmlns:a="http://schemas.openxmlformats.org/drawingml/2006/main">
+              <a:ext uri="{FF2B5EF4-FFF2-40B4-BE49-F238E27FC236}">
+                <a16:creationId xmlns:a16="http://schemas.microsoft.com/office/drawing/2014/main" id="{99120ABC-2DF3-4957-BB1B-9194F2F1ECE3}"/>
               </a:ext>
             </a:extLst>
           </p:cNvPr>
@@ -10470,10 +10015,10 @@
       </p:sp>
       <p:sp>
         <p:nvSpPr>
-          <p:cNvPr id="32" name="">
-            <a:extLst xmlns:a="http://schemas.openxmlformats.org/drawingml/2006/main">
-              <a:ext uri="{FF2B5EF4-FFF2-40B4-BE49-F238E27FC236}">
-                <a16:creationId xmlns:a16="http://schemas.microsoft.com/office/drawing/2014/main" id="{63671146-4FE5-454B-8C64-FC5CC521793D}"/>
+          <p:cNvPr id="25" name="">
+            <a:extLst xmlns:a="http://schemas.openxmlformats.org/drawingml/2006/main">
+              <a:ext uri="{FF2B5EF4-FFF2-40B4-BE49-F238E27FC236}">
+                <a16:creationId xmlns:a16="http://schemas.microsoft.com/office/drawing/2014/main" id="{4FB145DC-65CC-4B1A-872E-934A9937B673}"/>
               </a:ext>
             </a:extLst>
           </p:cNvPr>
@@ -10529,7 +10074,7 @@
     </p:spTree>
     <p:extLst>
       <p:ext uri="{BB962C8B-B14F-4D97-AF65-F5344CB8AC3E}">
-        <p14:creationId xmlns:p14="http://schemas.microsoft.com/office/powerpoint/2010/main" val="137631121"/>
+        <p14:creationId xmlns:p14="http://schemas.microsoft.com/office/powerpoint/2010/main" val="1955491626"/>
       </p:ext>
     </p:extLst>
   </p:cSld>
@@ -10560,7 +10105,7 @@
           <p:cNvPr id="29" name="">
             <a:extLst xmlns:a="http://schemas.openxmlformats.org/drawingml/2006/main">
               <a:ext uri="{FF2B5EF4-FFF2-40B4-BE49-F238E27FC236}">
-                <a16:creationId xmlns:a16="http://schemas.microsoft.com/office/drawing/2014/main" id="{59F1E9F5-2285-4824-9EC3-8EDF49C2B966}"/>
+                <a16:creationId xmlns:a16="http://schemas.microsoft.com/office/drawing/2014/main" id="{892A1066-CD21-4826-9A97-F9EFF55E0612}"/>
               </a:ext>
             </a:extLst>
           </p:cNvPr>
@@ -10618,7 +10163,7 @@
           <p:cNvPr id="2" name="">
             <a:extLst xmlns:a="http://schemas.openxmlformats.org/drawingml/2006/main">
               <a:ext uri="{FF2B5EF4-FFF2-40B4-BE49-F238E27FC236}">
-                <a16:creationId xmlns:a16="http://schemas.microsoft.com/office/drawing/2014/main" id="{3AEB6ABD-BF97-4C49-8282-8F37E81AA1AE}"/>
+                <a16:creationId xmlns:a16="http://schemas.microsoft.com/office/drawing/2014/main" id="{0FDF2912-B0C6-4E2E-97A0-AD859474E748}"/>
               </a:ext>
             </a:extLst>
           </p:cNvPr>
@@ -10676,7 +10221,7 @@
           <p:cNvPr id="3" name="">
             <a:extLst xmlns:a="http://schemas.openxmlformats.org/drawingml/2006/main">
               <a:ext uri="{FF2B5EF4-FFF2-40B4-BE49-F238E27FC236}">
-                <a16:creationId xmlns:a16="http://schemas.microsoft.com/office/drawing/2014/main" id="{F7C8C34A-B888-408E-87B5-25334ECB466B}"/>
+                <a16:creationId xmlns:a16="http://schemas.microsoft.com/office/drawing/2014/main" id="{9271F8EC-26D7-4668-841B-8E9B61B40546}"/>
               </a:ext>
             </a:extLst>
           </p:cNvPr>
@@ -10734,7 +10279,7 @@
           <p:cNvPr id="4" name="">
             <a:extLst xmlns:a="http://schemas.openxmlformats.org/drawingml/2006/main">
               <a:ext uri="{FF2B5EF4-FFF2-40B4-BE49-F238E27FC236}">
-                <a16:creationId xmlns:a16="http://schemas.microsoft.com/office/drawing/2014/main" id="{64793943-76A5-46B3-B175-19DD6A623CEE}"/>
+                <a16:creationId xmlns:a16="http://schemas.microsoft.com/office/drawing/2014/main" id="{0DA96216-3778-41DD-80A9-567D71978A94}"/>
               </a:ext>
             </a:extLst>
           </p:cNvPr>
@@ -10792,7 +10337,7 @@
           <p:cNvPr id="5" name="">
             <a:extLst xmlns:a="http://schemas.openxmlformats.org/drawingml/2006/main">
               <a:ext uri="{FF2B5EF4-FFF2-40B4-BE49-F238E27FC236}">
-                <a16:creationId xmlns:a16="http://schemas.microsoft.com/office/drawing/2014/main" id="{65F31791-0A78-416A-98E7-4C81DD3DE015}"/>
+                <a16:creationId xmlns:a16="http://schemas.microsoft.com/office/drawing/2014/main" id="{171E7560-E07B-454C-A2A4-D837CD8D7904}"/>
               </a:ext>
             </a:extLst>
           </p:cNvPr>
@@ -10850,7 +10395,7 @@
           <p:cNvPr id="6" name="">
             <a:extLst xmlns:a="http://schemas.openxmlformats.org/drawingml/2006/main">
               <a:ext uri="{FF2B5EF4-FFF2-40B4-BE49-F238E27FC236}">
-                <a16:creationId xmlns:a16="http://schemas.microsoft.com/office/drawing/2014/main" id="{23075B9A-2E77-4F8B-9C1F-F35E78E500FE}"/>
+                <a16:creationId xmlns:a16="http://schemas.microsoft.com/office/drawing/2014/main" id="{404651AD-78C1-42F5-B5D4-F45DF13C6660}"/>
               </a:ext>
             </a:extLst>
           </p:cNvPr>
@@ -10908,7 +10453,7 @@
           <p:cNvPr id="7" name="">
             <a:extLst xmlns:a="http://schemas.openxmlformats.org/drawingml/2006/main">
               <a:ext uri="{FF2B5EF4-FFF2-40B4-BE49-F238E27FC236}">
-                <a16:creationId xmlns:a16="http://schemas.microsoft.com/office/drawing/2014/main" id="{C0E8FD09-2328-4914-A0BA-EB3FD6110DB8}"/>
+                <a16:creationId xmlns:a16="http://schemas.microsoft.com/office/drawing/2014/main" id="{88BE2662-2AB0-461B-8BC7-9136005FB3A0}"/>
               </a:ext>
             </a:extLst>
           </p:cNvPr>
@@ -10946,7 +10491,7 @@
         </p:xfrm>
         <a:graphic xmlns:a="http://schemas.openxmlformats.org/drawingml/2006/main">
           <a:graphicData uri="http://schemas.openxmlformats.org/drawingml/2006/chart">
-            <c:chart xmlns:r="http://schemas.openxmlformats.org/officeDocument/2006/relationships" xmlns:c="http://schemas.openxmlformats.org/drawingml/2006/chart" r:id="Rc21eb383a1944a34"/>
+            <c:chart xmlns:r="http://schemas.openxmlformats.org/officeDocument/2006/relationships" xmlns:c="http://schemas.openxmlformats.org/drawingml/2006/chart" r:id="R775b5daf2ed7407b"/>
           </a:graphicData>
         </a:graphic>
       </p:graphicFrame>
@@ -10955,7 +10500,7 @@
           <p:cNvPr id="9" name="">
             <a:extLst xmlns:a="http://schemas.openxmlformats.org/drawingml/2006/main">
               <a:ext uri="{FF2B5EF4-FFF2-40B4-BE49-F238E27FC236}">
-                <a16:creationId xmlns:a16="http://schemas.microsoft.com/office/drawing/2014/main" id="{CE48BDF6-681A-4BFF-9139-09DBC812ADEC}"/>
+                <a16:creationId xmlns:a16="http://schemas.microsoft.com/office/drawing/2014/main" id="{CAE50324-D06F-4979-A8AB-4C0848D84306}"/>
               </a:ext>
             </a:extLst>
           </p:cNvPr>
@@ -10986,7 +10531,7 @@
           <p:cNvPr id="10" name="">
             <a:extLst xmlns:a="http://schemas.openxmlformats.org/drawingml/2006/main">
               <a:ext uri="{FF2B5EF4-FFF2-40B4-BE49-F238E27FC236}">
-                <a16:creationId xmlns:a16="http://schemas.microsoft.com/office/drawing/2014/main" id="{18A9B154-C320-431C-B216-A2DFF5177DEC}"/>
+                <a16:creationId xmlns:a16="http://schemas.microsoft.com/office/drawing/2014/main" id="{70B7E34B-8FD3-4AED-932E-E0CF379BE8EE}"/>
               </a:ext>
             </a:extLst>
           </p:cNvPr>
@@ -11044,7 +10589,7 @@
           <p:cNvPr id="11" name="">
             <a:extLst xmlns:a="http://schemas.openxmlformats.org/drawingml/2006/main">
               <a:ext uri="{FF2B5EF4-FFF2-40B4-BE49-F238E27FC236}">
-                <a16:creationId xmlns:a16="http://schemas.microsoft.com/office/drawing/2014/main" id="{5965E44A-296F-4E98-BC11-B6B7F229C309}"/>
+                <a16:creationId xmlns:a16="http://schemas.microsoft.com/office/drawing/2014/main" id="{857CC982-BA2B-4B47-8816-34B7CD057FA1}"/>
               </a:ext>
             </a:extLst>
           </p:cNvPr>
@@ -11102,7 +10647,7 @@
           <p:cNvPr id="12" name="">
             <a:extLst xmlns:a="http://schemas.openxmlformats.org/drawingml/2006/main">
               <a:ext uri="{FF2B5EF4-FFF2-40B4-BE49-F238E27FC236}">
-                <a16:creationId xmlns:a16="http://schemas.microsoft.com/office/drawing/2014/main" id="{026E8AC6-1D4D-4827-9942-A1E0B6240360}"/>
+                <a16:creationId xmlns:a16="http://schemas.microsoft.com/office/drawing/2014/main" id="{D234B5F6-6EE4-4724-B962-3AD8FBC1AA49}"/>
               </a:ext>
             </a:extLst>
           </p:cNvPr>
@@ -11160,7 +10705,7 @@
           <p:cNvPr id="13" name="">
             <a:extLst xmlns:a="http://schemas.openxmlformats.org/drawingml/2006/main">
               <a:ext uri="{FF2B5EF4-FFF2-40B4-BE49-F238E27FC236}">
-                <a16:creationId xmlns:a16="http://schemas.microsoft.com/office/drawing/2014/main" id="{EAB75043-945F-4969-9566-E40AEB741088}"/>
+                <a16:creationId xmlns:a16="http://schemas.microsoft.com/office/drawing/2014/main" id="{56250CD1-1AA8-4D9F-81E2-C2DF767A1CF0}"/>
               </a:ext>
             </a:extLst>
           </p:cNvPr>
@@ -11218,7 +10763,7 @@
           <p:cNvPr id="14" name="">
             <a:extLst xmlns:a="http://schemas.openxmlformats.org/drawingml/2006/main">
               <a:ext uri="{FF2B5EF4-FFF2-40B4-BE49-F238E27FC236}">
-                <a16:creationId xmlns:a16="http://schemas.microsoft.com/office/drawing/2014/main" id="{D73E69A2-C4D7-4FFD-8CE7-1C049AE27AAB}"/>
+                <a16:creationId xmlns:a16="http://schemas.microsoft.com/office/drawing/2014/main" id="{105F226B-B68C-4636-94C2-2F2597EDFD3D}"/>
               </a:ext>
             </a:extLst>
           </p:cNvPr>
@@ -11276,7 +10821,7 @@
           <p:cNvPr id="15" name="">
             <a:extLst xmlns:a="http://schemas.openxmlformats.org/drawingml/2006/main">
               <a:ext uri="{FF2B5EF4-FFF2-40B4-BE49-F238E27FC236}">
-                <a16:creationId xmlns:a16="http://schemas.microsoft.com/office/drawing/2014/main" id="{0B6F64E3-4C24-42E6-9269-1C71E52E6AE2}"/>
+                <a16:creationId xmlns:a16="http://schemas.microsoft.com/office/drawing/2014/main" id="{59BB2709-FDD9-49BA-B368-C1866CAB67C3}"/>
               </a:ext>
             </a:extLst>
           </p:cNvPr>
@@ -11307,7 +10852,7 @@
           <p:cNvPr id="16" name="">
             <a:extLst xmlns:a="http://schemas.openxmlformats.org/drawingml/2006/main">
               <a:ext uri="{FF2B5EF4-FFF2-40B4-BE49-F238E27FC236}">
-                <a16:creationId xmlns:a16="http://schemas.microsoft.com/office/drawing/2014/main" id="{A64CEAEE-0925-44DB-B3BB-24A1E3FF4729}"/>
+                <a16:creationId xmlns:a16="http://schemas.microsoft.com/office/drawing/2014/main" id="{2653B041-9C94-42DD-AF67-FB6F2875C595}"/>
               </a:ext>
             </a:extLst>
           </p:cNvPr>
@@ -11365,7 +10910,7 @@
           <p:cNvPr id="17" name="">
             <a:extLst xmlns:a="http://schemas.openxmlformats.org/drawingml/2006/main">
               <a:ext uri="{FF2B5EF4-FFF2-40B4-BE49-F238E27FC236}">
-                <a16:creationId xmlns:a16="http://schemas.microsoft.com/office/drawing/2014/main" id="{B23743FF-5DE0-494F-A6F2-2611621DA1F5}"/>
+                <a16:creationId xmlns:a16="http://schemas.microsoft.com/office/drawing/2014/main" id="{FBA63247-351F-4D02-AB58-972AFC28B4BE}"/>
               </a:ext>
             </a:extLst>
           </p:cNvPr>
@@ -11423,7 +10968,7 @@
           <p:cNvPr id="18" name="">
             <a:extLst xmlns:a="http://schemas.openxmlformats.org/drawingml/2006/main">
               <a:ext uri="{FF2B5EF4-FFF2-40B4-BE49-F238E27FC236}">
-                <a16:creationId xmlns:a16="http://schemas.microsoft.com/office/drawing/2014/main" id="{4EC81034-31D1-454A-B5D6-87391A95A3CA}"/>
+                <a16:creationId xmlns:a16="http://schemas.microsoft.com/office/drawing/2014/main" id="{00E0276C-134E-4744-A5AC-3A65DE7A7D4A}"/>
               </a:ext>
             </a:extLst>
           </p:cNvPr>
@@ -11471,7 +11016,7 @@
                 <a:ea typeface="Noto Sans"/>
                 <a:cs typeface="Noto Sans"/>
               </a:rPr>
-              <a:t>98.03%</a:t>
+              <a:t>96.69%</a:t>
             </a:r>
           </a:p>
         </p:txBody>
@@ -11481,7 +11026,7 @@
           <p:cNvPr id="19" name="">
             <a:extLst xmlns:a="http://schemas.openxmlformats.org/drawingml/2006/main">
               <a:ext uri="{FF2B5EF4-FFF2-40B4-BE49-F238E27FC236}">
-                <a16:creationId xmlns:a16="http://schemas.microsoft.com/office/drawing/2014/main" id="{D890E46A-7E4C-4B32-B1B0-C930713CE182}"/>
+                <a16:creationId xmlns:a16="http://schemas.microsoft.com/office/drawing/2014/main" id="{D58529CC-F059-4CF6-8DBB-B55ED8A0BA86}"/>
               </a:ext>
             </a:extLst>
           </p:cNvPr>
@@ -11529,7 +11074,7 @@
                 <a:ea typeface="Noto Sans"/>
                 <a:cs typeface="Noto Sans"/>
               </a:rPr>
-              <a:t>Count error</a:t>
+              <a:t>Count, п.п.</a:t>
             </a:r>
           </a:p>
         </p:txBody>
@@ -11539,7 +11084,7 @@
           <p:cNvPr id="20" name="">
             <a:extLst xmlns:a="http://schemas.openxmlformats.org/drawingml/2006/main">
               <a:ext uri="{FF2B5EF4-FFF2-40B4-BE49-F238E27FC236}">
-                <a16:creationId xmlns:a16="http://schemas.microsoft.com/office/drawing/2014/main" id="{A5AB4CE4-76B4-4055-99AE-7665A0593F55}"/>
+                <a16:creationId xmlns:a16="http://schemas.microsoft.com/office/drawing/2014/main" id="{F99F65E9-543D-46A2-9AE9-30F6774C1527}"/>
               </a:ext>
             </a:extLst>
           </p:cNvPr>
@@ -11587,7 +11132,7 @@
                 <a:ea typeface="Noto Sans"/>
                 <a:cs typeface="Noto Sans"/>
               </a:rPr>
-              <a:t>30</a:t>
+              <a:t>10</a:t>
             </a:r>
           </a:p>
         </p:txBody>
@@ -11597,7 +11142,7 @@
           <p:cNvPr id="21" name="">
             <a:extLst xmlns:a="http://schemas.openxmlformats.org/drawingml/2006/main">
               <a:ext uri="{FF2B5EF4-FFF2-40B4-BE49-F238E27FC236}">
-                <a16:creationId xmlns:a16="http://schemas.microsoft.com/office/drawing/2014/main" id="{EFFDA686-C682-44DA-8AA8-90F15A3AD2C5}"/>
+                <a16:creationId xmlns:a16="http://schemas.microsoft.com/office/drawing/2014/main" id="{0599A775-819D-42A4-9710-AB68F188A258}"/>
               </a:ext>
             </a:extLst>
           </p:cNvPr>
@@ -11645,7 +11190,7 @@
                 <a:ea typeface="Noto Sans"/>
                 <a:cs typeface="Noto Sans"/>
               </a:rPr>
-              <a:t>20 п.п.</a:t>
+              <a:t>0</a:t>
             </a:r>
           </a:p>
         </p:txBody>
@@ -11655,7 +11200,7 @@
           <p:cNvPr id="22" name="">
             <a:extLst xmlns:a="http://schemas.openxmlformats.org/drawingml/2006/main">
               <a:ext uri="{FF2B5EF4-FFF2-40B4-BE49-F238E27FC236}">
-                <a16:creationId xmlns:a16="http://schemas.microsoft.com/office/drawing/2014/main" id="{9DE4EAA7-49FD-40C8-AEAB-0C44CBA4BB61}"/>
+                <a16:creationId xmlns:a16="http://schemas.microsoft.com/office/drawing/2014/main" id="{993BD608-861C-4554-8126-C25480258A74}"/>
               </a:ext>
             </a:extLst>
           </p:cNvPr>
@@ -11703,7 +11248,7 @@
                 <a:ea typeface="Noto Sans"/>
                 <a:cs typeface="Noto Sans"/>
               </a:rPr>
-              <a:t>Volume error</a:t>
+              <a:t>Volume, п.п.</a:t>
             </a:r>
           </a:p>
         </p:txBody>
@@ -11713,7 +11258,7 @@
           <p:cNvPr id="23" name="">
             <a:extLst xmlns:a="http://schemas.openxmlformats.org/drawingml/2006/main">
               <a:ext uri="{FF2B5EF4-FFF2-40B4-BE49-F238E27FC236}">
-                <a16:creationId xmlns:a16="http://schemas.microsoft.com/office/drawing/2014/main" id="{99FBD412-5903-43B8-B9A8-4F4508C335E3}"/>
+                <a16:creationId xmlns:a16="http://schemas.microsoft.com/office/drawing/2014/main" id="{54B2E5E9-8861-45CD-9341-4B1678ABDD33}"/>
               </a:ext>
             </a:extLst>
           </p:cNvPr>
@@ -11761,7 +11306,7 @@
                 <a:ea typeface="Noto Sans"/>
                 <a:cs typeface="Noto Sans"/>
               </a:rPr>
-              <a:t>56.27</a:t>
+              <a:t>51.08</a:t>
             </a:r>
           </a:p>
         </p:txBody>
@@ -11771,7 +11316,7 @@
           <p:cNvPr id="24" name="">
             <a:extLst xmlns:a="http://schemas.openxmlformats.org/drawingml/2006/main">
               <a:ext uri="{FF2B5EF4-FFF2-40B4-BE49-F238E27FC236}">
-                <a16:creationId xmlns:a16="http://schemas.microsoft.com/office/drawing/2014/main" id="{A7A99B2F-7FB7-4899-96EA-5C2A449A862E}"/>
+                <a16:creationId xmlns:a16="http://schemas.microsoft.com/office/drawing/2014/main" id="{62E432B1-CA56-483E-8F89-35DEFA00D40E}"/>
               </a:ext>
             </a:extLst>
           </p:cNvPr>
@@ -11819,7 +11364,7 @@
                 <a:ea typeface="Noto Sans"/>
                 <a:cs typeface="Noto Sans"/>
               </a:rPr>
-              <a:t>81.15</a:t>
+              <a:t>96.7</a:t>
             </a:r>
           </a:p>
         </p:txBody>
@@ -11829,7 +11374,7 @@
           <p:cNvPr id="25" name="">
             <a:extLst xmlns:a="http://schemas.openxmlformats.org/drawingml/2006/main">
               <a:ext uri="{FF2B5EF4-FFF2-40B4-BE49-F238E27FC236}">
-                <a16:creationId xmlns:a16="http://schemas.microsoft.com/office/drawing/2014/main" id="{90EA3DD7-6214-4A40-946D-A603537D12B6}"/>
+                <a16:creationId xmlns:a16="http://schemas.microsoft.com/office/drawing/2014/main" id="{786B1485-F14E-4CE2-B455-3DD78830B430}"/>
               </a:ext>
             </a:extLst>
           </p:cNvPr>
@@ -11887,7 +11432,7 @@
           <p:cNvPr id="26" name="">
             <a:extLst xmlns:a="http://schemas.openxmlformats.org/drawingml/2006/main">
               <a:ext uri="{FF2B5EF4-FFF2-40B4-BE49-F238E27FC236}">
-                <a16:creationId xmlns:a16="http://schemas.microsoft.com/office/drawing/2014/main" id="{AFE713F2-2592-433F-AF4B-1D87FBD1737F}"/>
+                <a16:creationId xmlns:a16="http://schemas.microsoft.com/office/drawing/2014/main" id="{E9733041-B343-4A8C-8527-C4BDB37FF3F4}"/>
               </a:ext>
             </a:extLst>
           </p:cNvPr>
@@ -11918,7 +11463,7 @@
           <p:cNvPr id="27" name="">
             <a:extLst xmlns:a="http://schemas.openxmlformats.org/drawingml/2006/main">
               <a:ext uri="{FF2B5EF4-FFF2-40B4-BE49-F238E27FC236}">
-                <a16:creationId xmlns:a16="http://schemas.microsoft.com/office/drawing/2014/main" id="{E5D3B8A6-181A-4330-9136-F4595808A65D}"/>
+                <a16:creationId xmlns:a16="http://schemas.microsoft.com/office/drawing/2014/main" id="{7223F34F-C092-4ED2-9273-3C94839EC914}"/>
               </a:ext>
             </a:extLst>
           </p:cNvPr>
@@ -11976,7 +11521,7 @@
           <p:cNvPr id="28" name="">
             <a:extLst xmlns:a="http://schemas.openxmlformats.org/drawingml/2006/main">
               <a:ext uri="{FF2B5EF4-FFF2-40B4-BE49-F238E27FC236}">
-                <a16:creationId xmlns:a16="http://schemas.microsoft.com/office/drawing/2014/main" id="{7F0663B4-892B-452B-B824-57BCEF763DD2}"/>
+                <a16:creationId xmlns:a16="http://schemas.microsoft.com/office/drawing/2014/main" id="{093E2220-EBCE-41E9-A094-B89389D9F7B9}"/>
               </a:ext>
             </a:extLst>
           </p:cNvPr>
@@ -12032,7 +11577,7 @@
     </p:spTree>
     <p:extLst>
       <p:ext uri="{BB962C8B-B14F-4D97-AF65-F5344CB8AC3E}">
-        <p14:creationId xmlns:p14="http://schemas.microsoft.com/office/powerpoint/2010/main" val="1736026489"/>
+        <p14:creationId xmlns:p14="http://schemas.microsoft.com/office/powerpoint/2010/main" val="1833022897"/>
       </p:ext>
     </p:extLst>
   </p:cSld>
@@ -12063,7 +11608,7 @@
           <p:cNvPr id="31" name="">
             <a:extLst xmlns:a="http://schemas.openxmlformats.org/drawingml/2006/main">
               <a:ext uri="{FF2B5EF4-FFF2-40B4-BE49-F238E27FC236}">
-                <a16:creationId xmlns:a16="http://schemas.microsoft.com/office/drawing/2014/main" id="{37C19AFF-6D38-4CE7-9780-39CD47F9E084}"/>
+                <a16:creationId xmlns:a16="http://schemas.microsoft.com/office/drawing/2014/main" id="{F82700C0-AADE-4CA9-B8CD-B12FECA77577}"/>
               </a:ext>
             </a:extLst>
           </p:cNvPr>
@@ -12121,7 +11666,7 @@
           <p:cNvPr id="2" name="">
             <a:extLst xmlns:a="http://schemas.openxmlformats.org/drawingml/2006/main">
               <a:ext uri="{FF2B5EF4-FFF2-40B4-BE49-F238E27FC236}">
-                <a16:creationId xmlns:a16="http://schemas.microsoft.com/office/drawing/2014/main" id="{7D54D27B-E139-4DD2-A5E0-41FFD6D0CF8A}"/>
+                <a16:creationId xmlns:a16="http://schemas.microsoft.com/office/drawing/2014/main" id="{76215531-D3F3-4921-B1ED-963293FD7EE7}"/>
               </a:ext>
             </a:extLst>
           </p:cNvPr>
@@ -12179,7 +11724,7 @@
           <p:cNvPr id="3" name="">
             <a:extLst xmlns:a="http://schemas.openxmlformats.org/drawingml/2006/main">
               <a:ext uri="{FF2B5EF4-FFF2-40B4-BE49-F238E27FC236}">
-                <a16:creationId xmlns:a16="http://schemas.microsoft.com/office/drawing/2014/main" id="{285BA23F-E196-456C-A8CF-5072D48D3710}"/>
+                <a16:creationId xmlns:a16="http://schemas.microsoft.com/office/drawing/2014/main" id="{486D2BB1-84F9-4F76-AFDB-FA41FFFCBD2C}"/>
               </a:ext>
             </a:extLst>
           </p:cNvPr>
@@ -12237,7 +11782,7 @@
           <p:cNvPr id="4" name="">
             <a:extLst xmlns:a="http://schemas.openxmlformats.org/drawingml/2006/main">
               <a:ext uri="{FF2B5EF4-FFF2-40B4-BE49-F238E27FC236}">
-                <a16:creationId xmlns:a16="http://schemas.microsoft.com/office/drawing/2014/main" id="{F0F7BA6B-A3E7-4B2D-8998-6CDFC40CFCDD}"/>
+                <a16:creationId xmlns:a16="http://schemas.microsoft.com/office/drawing/2014/main" id="{D48BE207-2742-47C5-A43D-262A1EF40816}"/>
               </a:ext>
             </a:extLst>
           </p:cNvPr>
@@ -12295,7 +11840,7 @@
           <p:cNvPr id="5" name="">
             <a:extLst xmlns:a="http://schemas.openxmlformats.org/drawingml/2006/main">
               <a:ext uri="{FF2B5EF4-FFF2-40B4-BE49-F238E27FC236}">
-                <a16:creationId xmlns:a16="http://schemas.microsoft.com/office/drawing/2014/main" id="{775C39F8-7D6B-46D0-B564-76AFFB4D9551}"/>
+                <a16:creationId xmlns:a16="http://schemas.microsoft.com/office/drawing/2014/main" id="{844D4751-62B1-4E6B-AB6F-029E795BEDF3}"/>
               </a:ext>
             </a:extLst>
           </p:cNvPr>
@@ -12353,7 +11898,7 @@
           <p:cNvPr id="6" name="">
             <a:extLst xmlns:a="http://schemas.openxmlformats.org/drawingml/2006/main">
               <a:ext uri="{FF2B5EF4-FFF2-40B4-BE49-F238E27FC236}">
-                <a16:creationId xmlns:a16="http://schemas.microsoft.com/office/drawing/2014/main" id="{F745AF5E-0C7A-4F8A-A2F1-25A110902321}"/>
+                <a16:creationId xmlns:a16="http://schemas.microsoft.com/office/drawing/2014/main" id="{CAFA99FA-045D-4C7C-8444-E3C47C11F65F}"/>
               </a:ext>
             </a:extLst>
           </p:cNvPr>
@@ -12411,7 +11956,7 @@
           <p:cNvPr id="7" name="">
             <a:extLst xmlns:a="http://schemas.openxmlformats.org/drawingml/2006/main">
               <a:ext uri="{FF2B5EF4-FFF2-40B4-BE49-F238E27FC236}">
-                <a16:creationId xmlns:a16="http://schemas.microsoft.com/office/drawing/2014/main" id="{9B8C3CB7-252C-493C-85F7-E0ED32D99B04}"/>
+                <a16:creationId xmlns:a16="http://schemas.microsoft.com/office/drawing/2014/main" id="{2CAED4E9-482F-4868-9E03-621369FFF636}"/>
               </a:ext>
             </a:extLst>
           </p:cNvPr>
@@ -12442,7 +11987,7 @@
           <p:cNvPr id="8" name="">
             <a:extLst xmlns:a="http://schemas.openxmlformats.org/drawingml/2006/main">
               <a:ext uri="{FF2B5EF4-FFF2-40B4-BE49-F238E27FC236}">
-                <a16:creationId xmlns:a16="http://schemas.microsoft.com/office/drawing/2014/main" id="{5E785F94-CE68-4037-A96F-E97ED2BBE034}"/>
+                <a16:creationId xmlns:a16="http://schemas.microsoft.com/office/drawing/2014/main" id="{7C0E1322-1BE7-423E-96CD-A09489FBFC76}"/>
               </a:ext>
             </a:extLst>
           </p:cNvPr>
@@ -12500,7 +12045,7 @@
           <p:cNvPr id="9" name="">
             <a:extLst xmlns:a="http://schemas.openxmlformats.org/drawingml/2006/main">
               <a:ext uri="{FF2B5EF4-FFF2-40B4-BE49-F238E27FC236}">
-                <a16:creationId xmlns:a16="http://schemas.microsoft.com/office/drawing/2014/main" id="{B2D4FDED-BDF6-4970-BC6F-006844ED66C2}"/>
+                <a16:creationId xmlns:a16="http://schemas.microsoft.com/office/drawing/2014/main" id="{203B1133-2C59-45E8-B959-BB51589A6609}"/>
               </a:ext>
             </a:extLst>
           </p:cNvPr>
@@ -12581,7 +12126,7 @@
           <p:cNvPr id="10" name="">
             <a:extLst xmlns:a="http://schemas.openxmlformats.org/drawingml/2006/main">
               <a:ext uri="{FF2B5EF4-FFF2-40B4-BE49-F238E27FC236}">
-                <a16:creationId xmlns:a16="http://schemas.microsoft.com/office/drawing/2014/main" id="{56EA0338-C9AC-4C4D-A4F7-3DD21B67B4C8}"/>
+                <a16:creationId xmlns:a16="http://schemas.microsoft.com/office/drawing/2014/main" id="{DDBC2770-B065-4A89-83AC-567E066405E6}"/>
               </a:ext>
             </a:extLst>
           </p:cNvPr>
@@ -12612,7 +12157,7 @@
           <p:cNvPr id="11" name="">
             <a:extLst xmlns:a="http://schemas.openxmlformats.org/drawingml/2006/main">
               <a:ext uri="{FF2B5EF4-FFF2-40B4-BE49-F238E27FC236}">
-                <a16:creationId xmlns:a16="http://schemas.microsoft.com/office/drawing/2014/main" id="{7A58F7A6-ABF7-4224-A48E-D9D2A8FF2FC9}"/>
+                <a16:creationId xmlns:a16="http://schemas.microsoft.com/office/drawing/2014/main" id="{6FF6D4CE-F7B1-46A7-8C69-EEE9DF03DED0}"/>
               </a:ext>
             </a:extLst>
           </p:cNvPr>
@@ -12660,7 +12205,7 @@
                 <a:ea typeface="Noto Sans"/>
                 <a:cs typeface="Noto Sans"/>
               </a:rPr>
-              <a:t>81 / 378</a:t>
+              <a:t>140 / 754</a:t>
             </a:r>
           </a:p>
         </p:txBody>
@@ -12670,7 +12215,7 @@
           <p:cNvPr id="12" name="">
             <a:extLst xmlns:a="http://schemas.openxmlformats.org/drawingml/2006/main">
               <a:ext uri="{FF2B5EF4-FFF2-40B4-BE49-F238E27FC236}">
-                <a16:creationId xmlns:a16="http://schemas.microsoft.com/office/drawing/2014/main" id="{5B519B1D-3273-4467-856D-3504074D210F}"/>
+                <a16:creationId xmlns:a16="http://schemas.microsoft.com/office/drawing/2014/main" id="{7A31F5D5-B6F7-489F-945E-283FA793BFCA}"/>
               </a:ext>
             </a:extLst>
           </p:cNvPr>
@@ -12751,7 +12296,7 @@
           <p:cNvPr id="13" name="">
             <a:extLst xmlns:a="http://schemas.openxmlformats.org/drawingml/2006/main">
               <a:ext uri="{FF2B5EF4-FFF2-40B4-BE49-F238E27FC236}">
-                <a16:creationId xmlns:a16="http://schemas.microsoft.com/office/drawing/2014/main" id="{5758DD7E-19FF-4B61-BA6E-360546BE6CEC}"/>
+                <a16:creationId xmlns:a16="http://schemas.microsoft.com/office/drawing/2014/main" id="{D15DB707-310E-4172-9A40-E45ED486BBA4}"/>
               </a:ext>
             </a:extLst>
           </p:cNvPr>
@@ -12782,7 +12327,7 @@
           <p:cNvPr id="14" name="">
             <a:extLst xmlns:a="http://schemas.openxmlformats.org/drawingml/2006/main">
               <a:ext uri="{FF2B5EF4-FFF2-40B4-BE49-F238E27FC236}">
-                <a16:creationId xmlns:a16="http://schemas.microsoft.com/office/drawing/2014/main" id="{1BE802AB-7A40-4D2A-84DD-AAE64FAD1F4A}"/>
+                <a16:creationId xmlns:a16="http://schemas.microsoft.com/office/drawing/2014/main" id="{8EFE54BF-7309-408E-B0FD-19379A34F7A7}"/>
               </a:ext>
             </a:extLst>
           </p:cNvPr>
@@ -12840,7 +12385,7 @@
           <p:cNvPr id="15" name="">
             <a:extLst xmlns:a="http://schemas.openxmlformats.org/drawingml/2006/main">
               <a:ext uri="{FF2B5EF4-FFF2-40B4-BE49-F238E27FC236}">
-                <a16:creationId xmlns:a16="http://schemas.microsoft.com/office/drawing/2014/main" id="{7E606BBF-A787-467B-BF96-E3482D67E973}"/>
+                <a16:creationId xmlns:a16="http://schemas.microsoft.com/office/drawing/2014/main" id="{52BE8EE6-2382-4154-91D7-60630429F5D8}"/>
               </a:ext>
             </a:extLst>
           </p:cNvPr>
@@ -12921,7 +12466,7 @@
           <p:cNvPr id="16" name="">
             <a:extLst xmlns:a="http://schemas.openxmlformats.org/drawingml/2006/main">
               <a:ext uri="{FF2B5EF4-FFF2-40B4-BE49-F238E27FC236}">
-                <a16:creationId xmlns:a16="http://schemas.microsoft.com/office/drawing/2014/main" id="{CB24B1D4-DBF5-476B-9610-1EC5915E2FF7}"/>
+                <a16:creationId xmlns:a16="http://schemas.microsoft.com/office/drawing/2014/main" id="{FF29AF7E-EE89-482A-8F9E-6F8BE4AB82B1}"/>
               </a:ext>
             </a:extLst>
           </p:cNvPr>
@@ -12952,7 +12497,7 @@
           <p:cNvPr id="17" name="">
             <a:extLst xmlns:a="http://schemas.openxmlformats.org/drawingml/2006/main">
               <a:ext uri="{FF2B5EF4-FFF2-40B4-BE49-F238E27FC236}">
-                <a16:creationId xmlns:a16="http://schemas.microsoft.com/office/drawing/2014/main" id="{6D0CA675-A9F5-42A9-AE08-344C52AB63BD}"/>
+                <a16:creationId xmlns:a16="http://schemas.microsoft.com/office/drawing/2014/main" id="{AF278D9A-4A01-4533-93A4-06F49A4C0E34}"/>
               </a:ext>
             </a:extLst>
           </p:cNvPr>
@@ -13010,7 +12555,7 @@
           <p:cNvPr id="18" name="">
             <a:extLst xmlns:a="http://schemas.openxmlformats.org/drawingml/2006/main">
               <a:ext uri="{FF2B5EF4-FFF2-40B4-BE49-F238E27FC236}">
-                <a16:creationId xmlns:a16="http://schemas.microsoft.com/office/drawing/2014/main" id="{A235DC9B-08F5-4D6D-84AD-991A582D72A7}"/>
+                <a16:creationId xmlns:a16="http://schemas.microsoft.com/office/drawing/2014/main" id="{59C45B7B-3DF6-49AC-B705-3D699D81F17E}"/>
               </a:ext>
             </a:extLst>
           </p:cNvPr>
@@ -13091,7 +12636,7 @@
           <p:cNvPr id="19" name="">
             <a:extLst xmlns:a="http://schemas.openxmlformats.org/drawingml/2006/main">
               <a:ext uri="{FF2B5EF4-FFF2-40B4-BE49-F238E27FC236}">
-                <a16:creationId xmlns:a16="http://schemas.microsoft.com/office/drawing/2014/main" id="{AC573489-0EC7-4215-A2C7-6BC83DBD5FE3}"/>
+                <a16:creationId xmlns:a16="http://schemas.microsoft.com/office/drawing/2014/main" id="{143E94F4-1370-45D4-9490-636D9A0DFFBD}"/>
               </a:ext>
             </a:extLst>
           </p:cNvPr>
@@ -13122,7 +12667,7 @@
           <p:cNvPr id="20" name="">
             <a:extLst xmlns:a="http://schemas.openxmlformats.org/drawingml/2006/main">
               <a:ext uri="{FF2B5EF4-FFF2-40B4-BE49-F238E27FC236}">
-                <a16:creationId xmlns:a16="http://schemas.microsoft.com/office/drawing/2014/main" id="{39803D27-FC52-49B4-88DD-EE1CED925D93}"/>
+                <a16:creationId xmlns:a16="http://schemas.microsoft.com/office/drawing/2014/main" id="{786575B6-2F2D-461B-895B-DBB787E5180E}"/>
               </a:ext>
             </a:extLst>
           </p:cNvPr>
@@ -13180,7 +12725,7 @@
           <p:cNvPr id="21" name="">
             <a:extLst xmlns:a="http://schemas.openxmlformats.org/drawingml/2006/main">
               <a:ext uri="{FF2B5EF4-FFF2-40B4-BE49-F238E27FC236}">
-                <a16:creationId xmlns:a16="http://schemas.microsoft.com/office/drawing/2014/main" id="{0D45DDA6-895D-40F2-8A14-001A11974514}"/>
+                <a16:creationId xmlns:a16="http://schemas.microsoft.com/office/drawing/2014/main" id="{205B75F7-74A4-4E15-A9ED-AF04702120A2}"/>
               </a:ext>
             </a:extLst>
           </p:cNvPr>
@@ -13238,7 +12783,7 @@
           <p:cNvPr id="22" name="">
             <a:extLst xmlns:a="http://schemas.openxmlformats.org/drawingml/2006/main">
               <a:ext uri="{FF2B5EF4-FFF2-40B4-BE49-F238E27FC236}">
-                <a16:creationId xmlns:a16="http://schemas.microsoft.com/office/drawing/2014/main" id="{15B4998C-3397-4052-A6BF-6CA2A6E547F1}"/>
+                <a16:creationId xmlns:a16="http://schemas.microsoft.com/office/drawing/2014/main" id="{8827B342-CF80-4E20-BA46-A17575C6CFF1}"/>
               </a:ext>
             </a:extLst>
           </p:cNvPr>
@@ -13296,7 +12841,7 @@
           <p:cNvPr id="23" name="">
             <a:extLst xmlns:a="http://schemas.openxmlformats.org/drawingml/2006/main">
               <a:ext uri="{FF2B5EF4-FFF2-40B4-BE49-F238E27FC236}">
-                <a16:creationId xmlns:a16="http://schemas.microsoft.com/office/drawing/2014/main" id="{9B240794-E177-4CA4-972B-6F208314F0D3}"/>
+                <a16:creationId xmlns:a16="http://schemas.microsoft.com/office/drawing/2014/main" id="{E79CD545-FD39-4183-A55D-BCD603749FE0}"/>
               </a:ext>
             </a:extLst>
           </p:cNvPr>
@@ -13327,7 +12872,7 @@
           <p:cNvPr id="24" name="">
             <a:extLst xmlns:a="http://schemas.openxmlformats.org/drawingml/2006/main">
               <a:ext uri="{FF2B5EF4-FFF2-40B4-BE49-F238E27FC236}">
-                <a16:creationId xmlns:a16="http://schemas.microsoft.com/office/drawing/2014/main" id="{3FF1B0D6-5972-4C1B-9B74-32BC22F98034}"/>
+                <a16:creationId xmlns:a16="http://schemas.microsoft.com/office/drawing/2014/main" id="{AA57ED04-66B5-4827-9732-D76CF37A4316}"/>
               </a:ext>
             </a:extLst>
           </p:cNvPr>
@@ -13385,7 +12930,7 @@
           <p:cNvPr id="25" name="">
             <a:extLst xmlns:a="http://schemas.openxmlformats.org/drawingml/2006/main">
               <a:ext uri="{FF2B5EF4-FFF2-40B4-BE49-F238E27FC236}">
-                <a16:creationId xmlns:a16="http://schemas.microsoft.com/office/drawing/2014/main" id="{AFED349F-5289-4C9D-890F-65D25C5D7443}"/>
+                <a16:creationId xmlns:a16="http://schemas.microsoft.com/office/drawing/2014/main" id="{EBED5A2E-68E1-497A-B600-1BEEF5A26940}"/>
               </a:ext>
             </a:extLst>
           </p:cNvPr>
@@ -13443,7 +12988,7 @@
           <p:cNvPr id="26" name="">
             <a:extLst xmlns:a="http://schemas.openxmlformats.org/drawingml/2006/main">
               <a:ext uri="{FF2B5EF4-FFF2-40B4-BE49-F238E27FC236}">
-                <a16:creationId xmlns:a16="http://schemas.microsoft.com/office/drawing/2014/main" id="{AFCEBE1B-9A46-4098-8EE8-69AE02F6F090}"/>
+                <a16:creationId xmlns:a16="http://schemas.microsoft.com/office/drawing/2014/main" id="{23DB6E4A-AD02-4FD4-9991-16E08CED6E52}"/>
               </a:ext>
             </a:extLst>
           </p:cNvPr>
@@ -13501,7 +13046,7 @@
           <p:cNvPr id="27" name="">
             <a:extLst xmlns:a="http://schemas.openxmlformats.org/drawingml/2006/main">
               <a:ext uri="{FF2B5EF4-FFF2-40B4-BE49-F238E27FC236}">
-                <a16:creationId xmlns:a16="http://schemas.microsoft.com/office/drawing/2014/main" id="{CC870293-1095-4D19-BAE4-D3512DFA7E00}"/>
+                <a16:creationId xmlns:a16="http://schemas.microsoft.com/office/drawing/2014/main" id="{2A29970F-14BB-45A9-A002-90F365B4998A}"/>
               </a:ext>
             </a:extLst>
           </p:cNvPr>
@@ -13549,7 +13094,7 @@
                 <a:ea typeface="Noto Sans"/>
                 <a:cs typeface="Noto Sans"/>
               </a:rPr>
-              <a:t>router.rb   →   eligibility/rules.rb   →   scoring/policy.rb   →   provider_state.rb</a:t>
+              <a:t>router.rb   ·   eligibility/rules.rb   ·   scoring/policy.rb   ·   provider_state.rb</a:t>
             </a:r>
           </a:p>
         </p:txBody>
@@ -13559,7 +13104,7 @@
           <p:cNvPr id="28" name="">
             <a:extLst xmlns:a="http://schemas.openxmlformats.org/drawingml/2006/main">
               <a:ext uri="{FF2B5EF4-FFF2-40B4-BE49-F238E27FC236}">
-                <a16:creationId xmlns:a16="http://schemas.microsoft.com/office/drawing/2014/main" id="{E0DAF3FB-2747-4E2F-934A-32B5C09571C8}"/>
+                <a16:creationId xmlns:a16="http://schemas.microsoft.com/office/drawing/2014/main" id="{AA092976-6340-4391-BAF2-A4181AB31F70}"/>
               </a:ext>
             </a:extLst>
           </p:cNvPr>
@@ -13590,7 +13135,7 @@
           <p:cNvPr id="29" name="">
             <a:extLst xmlns:a="http://schemas.openxmlformats.org/drawingml/2006/main">
               <a:ext uri="{FF2B5EF4-FFF2-40B4-BE49-F238E27FC236}">
-                <a16:creationId xmlns:a16="http://schemas.microsoft.com/office/drawing/2014/main" id="{C11FAF30-6883-46E8-87C6-C330C9B76CD6}"/>
+                <a16:creationId xmlns:a16="http://schemas.microsoft.com/office/drawing/2014/main" id="{3FC30E0A-0B04-4B44-A470-B863E15EF9F2}"/>
               </a:ext>
             </a:extLst>
           </p:cNvPr>
@@ -13648,7 +13193,7 @@
           <p:cNvPr id="30" name="">
             <a:extLst xmlns:a="http://schemas.openxmlformats.org/drawingml/2006/main">
               <a:ext uri="{FF2B5EF4-FFF2-40B4-BE49-F238E27FC236}">
-                <a16:creationId xmlns:a16="http://schemas.microsoft.com/office/drawing/2014/main" id="{0363BF68-E138-4484-9CC1-97F28C2EA50D}"/>
+                <a16:creationId xmlns:a16="http://schemas.microsoft.com/office/drawing/2014/main" id="{FFED0C8D-2791-4BE1-92A7-0B387027F272}"/>
               </a:ext>
             </a:extLst>
           </p:cNvPr>
@@ -13704,7 +13249,7 @@
     </p:spTree>
     <p:extLst>
       <p:ext uri="{BB962C8B-B14F-4D97-AF65-F5344CB8AC3E}">
-        <p14:creationId xmlns:p14="http://schemas.microsoft.com/office/powerpoint/2010/main" val="68700886"/>
+        <p14:creationId xmlns:p14="http://schemas.microsoft.com/office/powerpoint/2010/main" val="1611289330"/>
       </p:ext>
     </p:extLst>
   </p:cSld>

</xml_diff>